<commit_message>
fix: section-divider 슬라이드 footer 억제 + showcase PPTX 재생성
section-divider는 챕터 구분 슬라이드로 페이지 번호와 브랜드 표시가 어울리지 않음.
closing과 동일하게 skipFooter 조건에 추가.

Co-Authored-By: Claude Sonnet 4.6 <noreply@anthropic.com>
</commit_message>
<xml_diff>
--- a/examples/results/showcase-modern-light.pptx
+++ b/examples/results/showcase-modern-light.pptx
@@ -3413,84 +3413,6 @@
               <a:t>How It Works</a:t>
             </a:r>
             <a:endParaRPr lang="en-US" sz="4400" dirty="0"/>
-          </a:p>
-        </p:txBody>
-      </p:sp>
-      <p:sp>
-        <p:nvSpPr>
-          <p:cNvPr id="7" name="Text 5"/>
-          <p:cNvSpPr/>
-          <p:nvPr/>
-        </p:nvSpPr>
-        <p:spPr>
-          <a:xfrm>
-            <a:off x="9902952" y="6537960"/>
-            <a:ext cx="2286000" cy="274320"/>
-          </a:xfrm>
-          <a:prstGeom prst="rect">
-            <a:avLst/>
-          </a:prstGeom>
-          <a:noFill/>
-          <a:ln/>
-        </p:spPr>
-        <p:txBody>
-          <a:bodyPr wrap="square" rtlCol="0" anchor="ctr"/>
-          <a:lstStyle/>
-          <a:p>
-            <a:pPr algn="r" indent="0" marL="0">
-              <a:buNone/>
-            </a:pPr>
-            <a:r>
-              <a:rPr lang="en-US" sz="1000" dirty="0">
-                <a:solidFill>
-                  <a:srgbClr val="6B7280"/>
-                </a:solidFill>
-                <a:latin typeface="Pretendard" pitchFamily="34" charset="0"/>
-                <a:ea typeface="Pretendard" pitchFamily="34" charset="-122"/>
-                <a:cs typeface="Pretendard" pitchFamily="34" charset="-120"/>
-              </a:rPr>
-              <a:t>ai-deck-compiler</a:t>
-            </a:r>
-            <a:endParaRPr lang="en-US" sz="1000" dirty="0"/>
-          </a:p>
-        </p:txBody>
-      </p:sp>
-      <p:sp>
-        <p:nvSpPr>
-          <p:cNvPr id="8" name="Text 6"/>
-          <p:cNvSpPr/>
-          <p:nvPr/>
-        </p:nvSpPr>
-        <p:spPr>
-          <a:xfrm>
-            <a:off x="612648" y="6537960"/>
-            <a:ext cx="914400" cy="274320"/>
-          </a:xfrm>
-          <a:prstGeom prst="rect">
-            <a:avLst/>
-          </a:prstGeom>
-          <a:noFill/>
-          <a:ln/>
-        </p:spPr>
-        <p:txBody>
-          <a:bodyPr wrap="square" rtlCol="0" anchor="ctr"/>
-          <a:lstStyle/>
-          <a:p>
-            <a:pPr algn="l" indent="0" marL="0">
-              <a:buNone/>
-            </a:pPr>
-            <a:r>
-              <a:rPr lang="en-US" sz="1000" dirty="0">
-                <a:solidFill>
-                  <a:srgbClr val="6B7280"/>
-                </a:solidFill>
-                <a:latin typeface="Pretendard" pitchFamily="34" charset="0"/>
-                <a:ea typeface="Pretendard" pitchFamily="34" charset="-122"/>
-                <a:cs typeface="Pretendard" pitchFamily="34" charset="-120"/>
-              </a:rPr>
-              <a:t>10 / 18</a:t>
-            </a:r>
-            <a:endParaRPr lang="en-US" sz="1000" dirty="0"/>
           </a:p>
         </p:txBody>
       </p:sp>
@@ -10752,84 +10674,6 @@
           </a:p>
         </p:txBody>
       </p:sp>
-      <p:sp>
-        <p:nvSpPr>
-          <p:cNvPr id="7" name="Text 5"/>
-          <p:cNvSpPr/>
-          <p:nvPr/>
-        </p:nvSpPr>
-        <p:spPr>
-          <a:xfrm>
-            <a:off x="9902952" y="6537960"/>
-            <a:ext cx="2286000" cy="274320"/>
-          </a:xfrm>
-          <a:prstGeom prst="rect">
-            <a:avLst/>
-          </a:prstGeom>
-          <a:noFill/>
-          <a:ln/>
-        </p:spPr>
-        <p:txBody>
-          <a:bodyPr wrap="square" rtlCol="0" anchor="ctr"/>
-          <a:lstStyle/>
-          <a:p>
-            <a:pPr algn="r" indent="0" marL="0">
-              <a:buNone/>
-            </a:pPr>
-            <a:r>
-              <a:rPr lang="en-US" sz="1000" dirty="0">
-                <a:solidFill>
-                  <a:srgbClr val="6B7280"/>
-                </a:solidFill>
-                <a:latin typeface="Pretendard" pitchFamily="34" charset="0"/>
-                <a:ea typeface="Pretendard" pitchFamily="34" charset="-122"/>
-                <a:cs typeface="Pretendard" pitchFamily="34" charset="-120"/>
-              </a:rPr>
-              <a:t>ai-deck-compiler</a:t>
-            </a:r>
-            <a:endParaRPr lang="en-US" sz="1000" dirty="0"/>
-          </a:p>
-        </p:txBody>
-      </p:sp>
-      <p:sp>
-        <p:nvSpPr>
-          <p:cNvPr id="8" name="Text 6"/>
-          <p:cNvSpPr/>
-          <p:nvPr/>
-        </p:nvSpPr>
-        <p:spPr>
-          <a:xfrm>
-            <a:off x="612648" y="6537960"/>
-            <a:ext cx="914400" cy="274320"/>
-          </a:xfrm>
-          <a:prstGeom prst="rect">
-            <a:avLst/>
-          </a:prstGeom>
-          <a:noFill/>
-          <a:ln/>
-        </p:spPr>
-        <p:txBody>
-          <a:bodyPr wrap="square" rtlCol="0" anchor="ctr"/>
-          <a:lstStyle/>
-          <a:p>
-            <a:pPr algn="l" indent="0" marL="0">
-              <a:buNone/>
-            </a:pPr>
-            <a:r>
-              <a:rPr lang="en-US" sz="1000" dirty="0">
-                <a:solidFill>
-                  <a:srgbClr val="6B7280"/>
-                </a:solidFill>
-                <a:latin typeface="Pretendard" pitchFamily="34" charset="0"/>
-                <a:ea typeface="Pretendard" pitchFamily="34" charset="-122"/>
-                <a:cs typeface="Pretendard" pitchFamily="34" charset="-120"/>
-              </a:rPr>
-              <a:t>3 / 18</a:t>
-            </a:r>
-            <a:endParaRPr lang="en-US" sz="1000" dirty="0"/>
-          </a:p>
-        </p:txBody>
-      </p:sp>
     </p:spTree>
   </p:cSld>
   <p:clrMapOvr>

</xml_diff>

<commit_message>
feat: FEAT-20260601-004 — card inner horizontal padding 통일 (CARD.px = 0.25")
layout.ts에 CARD.px = 0.25" 추가 후 모든 카드 기반 렌더러에 일관 적용.
카드 내부 콘텐츠가 카드 경계에 붙지 않고 좌우 여백을 갖도록 보정.

- layout.ts: CARD.px = 0.25, zoneCenter innerW/leftX 기준 이동
- kpi.ts: 4박스 x/w inner 기준 재계산
- table.ts: addTable x/w inner 기준 이동
- decision.ts: option 박스 + recommendation 배너 inner 기준 이동
- comparison.ts: 모듈 레벨 colW → render 내부 이동, leftX + inner 기준
- two-column.ts: 동일 방식으로 inner 기준 이동
- content.ts, chart.ts, flow.ts, architecture.ts: addText/addChart/placeholder inner 기준
- agenda.ts: 기존 innerPad=0.3 → CARD.px 참조로 통일
- summary.ts: bodyW/panelX inner 기준 재계산
- FEAT-20260601-003 Done 처리, FEAT-20260601-004 Work 파일 등록
- snapshot 9개 업데이트

Co-Authored-By: Claude Sonnet 4.6 <noreply@anthropic.com>
</commit_message>
<xml_diff>
--- a/examples/results/showcase-modern-light.pptx
+++ b/examples/results/showcase-modern-light.pptx
@@ -3586,8 +3586,8 @@
         </p:nvSpPr>
         <p:spPr>
           <a:xfrm flipV="1">
-            <a:off x="2441448" y="2583180"/>
-            <a:ext cx="3657600" cy="1417320"/>
+            <a:off x="2593848" y="2583180"/>
+            <a:ext cx="3505200" cy="1417320"/>
           </a:xfrm>
           <a:prstGeom prst="line">
             <a:avLst/>
@@ -3610,7 +3610,7 @@
         </p:nvSpPr>
         <p:spPr>
           <a:xfrm>
-            <a:off x="3721608" y="3108960"/>
+            <a:off x="3797808" y="3108960"/>
             <a:ext cx="1097280" cy="274320"/>
           </a:xfrm>
           <a:prstGeom prst="rect">
@@ -3713,7 +3713,7 @@
         <p:spPr>
           <a:xfrm>
             <a:off x="6099048" y="4000500"/>
-            <a:ext cx="3657600" cy="9144"/>
+            <a:ext cx="3505200" cy="9144"/>
           </a:xfrm>
           <a:prstGeom prst="line">
             <a:avLst/>
@@ -3736,7 +3736,7 @@
         </p:nvSpPr>
         <p:spPr>
           <a:xfrm>
-            <a:off x="7379208" y="3817620"/>
+            <a:off x="7303008" y="3817620"/>
             <a:ext cx="1097280" cy="274320"/>
           </a:xfrm>
           <a:prstGeom prst="rect">
@@ -3776,7 +3776,7 @@
         <p:spPr>
           <a:xfrm flipV="1">
             <a:off x="6099048" y="4000500"/>
-            <a:ext cx="3657600" cy="1417320"/>
+            <a:ext cx="3505200" cy="1417320"/>
           </a:xfrm>
           <a:prstGeom prst="line">
             <a:avLst/>
@@ -3799,7 +3799,7 @@
         </p:nvSpPr>
         <p:spPr>
           <a:xfrm>
-            <a:off x="7379208" y="4526280"/>
+            <a:off x="7303008" y="4526280"/>
             <a:ext cx="1097280" cy="274320"/>
           </a:xfrm>
           <a:prstGeom prst="rect">
@@ -3838,7 +3838,7 @@
         </p:nvSpPr>
         <p:spPr>
           <a:xfrm>
-            <a:off x="9756648" y="4000500"/>
+            <a:off x="9604248" y="4000500"/>
             <a:ext cx="9144" cy="1417320"/>
           </a:xfrm>
           <a:prstGeom prst="line">
@@ -3862,7 +3862,7 @@
         </p:nvSpPr>
         <p:spPr>
           <a:xfrm>
-            <a:off x="9208008" y="4526280"/>
+            <a:off x="9055608" y="4526280"/>
             <a:ext cx="1097280" cy="274320"/>
           </a:xfrm>
           <a:prstGeom prst="rect">
@@ -3901,7 +3901,7 @@
         </p:nvSpPr>
         <p:spPr>
           <a:xfrm>
-            <a:off x="1618488" y="3703320"/>
+            <a:off x="1770888" y="3703320"/>
             <a:ext cx="1645920" cy="594360"/>
           </a:xfrm>
           <a:prstGeom prst="rect">
@@ -3926,7 +3926,7 @@
         </p:nvSpPr>
         <p:spPr>
           <a:xfrm>
-            <a:off x="1618488" y="3703320"/>
+            <a:off x="1770888" y="3703320"/>
             <a:ext cx="1645920" cy="594360"/>
           </a:xfrm>
           <a:prstGeom prst="rect">
@@ -4157,7 +4157,7 @@
         </p:nvSpPr>
         <p:spPr>
           <a:xfrm>
-            <a:off x="8933688" y="3703320"/>
+            <a:off x="8781288" y="3703320"/>
             <a:ext cx="1645920" cy="594360"/>
           </a:xfrm>
           <a:prstGeom prst="roundRect">
@@ -4182,7 +4182,7 @@
         </p:nvSpPr>
         <p:spPr>
           <a:xfrm>
-            <a:off x="8933688" y="3703320"/>
+            <a:off x="8781288" y="3703320"/>
             <a:ext cx="1645920" cy="594360"/>
           </a:xfrm>
           <a:prstGeom prst="rect">
@@ -4221,7 +4221,7 @@
         </p:nvSpPr>
         <p:spPr>
           <a:xfrm>
-            <a:off x="8933688" y="5120640"/>
+            <a:off x="8781288" y="5120640"/>
             <a:ext cx="1645920" cy="594360"/>
           </a:xfrm>
           <a:prstGeom prst="rect">
@@ -4246,7 +4246,7 @@
         </p:nvSpPr>
         <p:spPr>
           <a:xfrm>
-            <a:off x="8933688" y="5120640"/>
+            <a:off x="8781288" y="5120640"/>
             <a:ext cx="1645920" cy="594360"/>
           </a:xfrm>
           <a:prstGeom prst="rect">
@@ -4525,8 +4525,8 @@
         </p:nvSpPr>
         <p:spPr>
           <a:xfrm flipV="1">
-            <a:off x="2441448" y="2583180"/>
-            <a:ext cx="3657600" cy="1417320"/>
+            <a:off x="2593848" y="2583180"/>
+            <a:ext cx="3505200" cy="1417320"/>
           </a:xfrm>
           <a:prstGeom prst="line">
             <a:avLst/>
@@ -4574,7 +4574,7 @@
         <p:spPr>
           <a:xfrm>
             <a:off x="6099048" y="4000500"/>
-            <a:ext cx="3657600" cy="9144"/>
+            <a:ext cx="3505200" cy="9144"/>
           </a:xfrm>
           <a:prstGeom prst="line">
             <a:avLst/>
@@ -4598,7 +4598,7 @@
         <p:spPr>
           <a:xfrm flipH="1">
             <a:off x="6099048" y="4000500"/>
-            <a:ext cx="3657600" cy="1417320"/>
+            <a:ext cx="3505200" cy="1417320"/>
           </a:xfrm>
           <a:prstGeom prst="line">
             <a:avLst/>
@@ -4622,7 +4622,7 @@
         <p:spPr>
           <a:xfrm>
             <a:off x="6099048" y="5417820"/>
-            <a:ext cx="3657600" cy="9144"/>
+            <a:ext cx="3505200" cy="9144"/>
           </a:xfrm>
           <a:prstGeom prst="line">
             <a:avLst/>
@@ -4646,7 +4646,7 @@
         <p:spPr>
           <a:xfrm flipH="1" flipV="1">
             <a:off x="6099048" y="4000500"/>
-            <a:ext cx="3657600" cy="1417320"/>
+            <a:ext cx="3505200" cy="1417320"/>
           </a:xfrm>
           <a:prstGeom prst="line">
             <a:avLst/>
@@ -4669,7 +4669,7 @@
         </p:nvSpPr>
         <p:spPr>
           <a:xfrm>
-            <a:off x="1618488" y="3703320"/>
+            <a:off x="1770888" y="3703320"/>
             <a:ext cx="1645920" cy="594360"/>
           </a:xfrm>
           <a:prstGeom prst="rect">
@@ -4694,7 +4694,7 @@
         </p:nvSpPr>
         <p:spPr>
           <a:xfrm>
-            <a:off x="1618488" y="3703320"/>
+            <a:off x="1770888" y="3703320"/>
             <a:ext cx="1645920" cy="594360"/>
           </a:xfrm>
           <a:prstGeom prst="rect">
@@ -4861,7 +4861,7 @@
         </p:nvSpPr>
         <p:spPr>
           <a:xfrm>
-            <a:off x="8933688" y="3703320"/>
+            <a:off x="8781288" y="3703320"/>
             <a:ext cx="1645920" cy="594360"/>
           </a:xfrm>
           <a:prstGeom prst="rect">
@@ -4886,7 +4886,7 @@
         </p:nvSpPr>
         <p:spPr>
           <a:xfrm>
-            <a:off x="8933688" y="3703320"/>
+            <a:off x="8781288" y="3703320"/>
             <a:ext cx="1645920" cy="594360"/>
           </a:xfrm>
           <a:prstGeom prst="rect">
@@ -4989,7 +4989,7 @@
         </p:nvSpPr>
         <p:spPr>
           <a:xfrm>
-            <a:off x="8933688" y="5120640"/>
+            <a:off x="8781288" y="5120640"/>
             <a:ext cx="1645920" cy="594360"/>
           </a:xfrm>
           <a:prstGeom prst="roundRect">
@@ -5014,7 +5014,7 @@
         </p:nvSpPr>
         <p:spPr>
           <a:xfrm>
-            <a:off x="8933688" y="5120640"/>
+            <a:off x="8781288" y="5120640"/>
             <a:ext cx="1645920" cy="594360"/>
           </a:xfrm>
           <a:prstGeom prst="rect">
@@ -5300,18 +5300,18 @@
           </p:nvPr>
         </p:nvGraphicFramePr>
         <p:xfrm>
-          <a:off x="612648" y="1874520"/>
-          <a:ext cx="10972800" cy="914400"/>
+          <a:off x="841248" y="1874520"/>
+          <a:ext cx="10515600" cy="914400"/>
         </p:xfrm>
         <a:graphic>
           <a:graphicData uri="http://schemas.openxmlformats.org/drawingml/2006/table">
             <a:tbl>
               <a:tblPr/>
               <a:tblGrid>
-                <a:gridCol w="2743200"/>
-                <a:gridCol w="2743200"/>
-                <a:gridCol w="2743200"/>
-                <a:gridCol w="2743200"/>
+                <a:gridCol w="2628900"/>
+                <a:gridCol w="2628900"/>
+                <a:gridCol w="2628900"/>
+                <a:gridCol w="2628900"/>
               </a:tblGrid>
               <a:tr h="411480">
                 <a:tc>
@@ -7584,8 +7584,8 @@
         </p:nvSpPr>
         <p:spPr>
           <a:xfrm>
-            <a:off x="612648" y="1874520"/>
-            <a:ext cx="5394960" cy="3566160"/>
+            <a:off x="841248" y="1874520"/>
+            <a:ext cx="5166360" cy="3566160"/>
           </a:xfrm>
           <a:prstGeom prst="roundRect">
             <a:avLst>
@@ -7611,8 +7611,8 @@
         </p:nvSpPr>
         <p:spPr>
           <a:xfrm>
-            <a:off x="612648" y="1874520"/>
-            <a:ext cx="5394960" cy="457200"/>
+            <a:off x="841248" y="1874520"/>
+            <a:ext cx="5166360" cy="457200"/>
           </a:xfrm>
           <a:prstGeom prst="roundRect">
             <a:avLst>
@@ -7638,8 +7638,8 @@
         </p:nvSpPr>
         <p:spPr>
           <a:xfrm>
-            <a:off x="612648" y="1874520"/>
-            <a:ext cx="5394960" cy="457200"/>
+            <a:off x="841248" y="1874520"/>
+            <a:ext cx="5166360" cy="457200"/>
           </a:xfrm>
           <a:prstGeom prst="rect">
             <a:avLst/>
@@ -7677,8 +7677,8 @@
         </p:nvSpPr>
         <p:spPr>
           <a:xfrm>
-            <a:off x="777240" y="2441448"/>
-            <a:ext cx="5120640" cy="292608"/>
+            <a:off x="1005840" y="2441448"/>
+            <a:ext cx="4892040" cy="292608"/>
           </a:xfrm>
           <a:prstGeom prst="rect">
             <a:avLst/>
@@ -7716,8 +7716,8 @@
         </p:nvSpPr>
         <p:spPr>
           <a:xfrm>
-            <a:off x="777240" y="2779776"/>
-            <a:ext cx="5120640" cy="292608"/>
+            <a:off x="1005840" y="2779776"/>
+            <a:ext cx="4892040" cy="292608"/>
           </a:xfrm>
           <a:prstGeom prst="rect">
             <a:avLst/>
@@ -7755,8 +7755,8 @@
         </p:nvSpPr>
         <p:spPr>
           <a:xfrm>
-            <a:off x="777240" y="3118104"/>
-            <a:ext cx="5065776" cy="0"/>
+            <a:off x="1005840" y="3118104"/>
+            <a:ext cx="4837176" cy="0"/>
           </a:xfrm>
           <a:prstGeom prst="line">
             <a:avLst/>
@@ -7778,8 +7778,8 @@
         </p:nvSpPr>
         <p:spPr>
           <a:xfrm>
-            <a:off x="777240" y="3255264"/>
-            <a:ext cx="5120640" cy="292608"/>
+            <a:off x="1005840" y="3255264"/>
+            <a:ext cx="4892040" cy="292608"/>
           </a:xfrm>
           <a:prstGeom prst="rect">
             <a:avLst/>
@@ -7817,8 +7817,8 @@
         </p:nvSpPr>
         <p:spPr>
           <a:xfrm>
-            <a:off x="777240" y="3593592"/>
-            <a:ext cx="5120640" cy="292608"/>
+            <a:off x="1005840" y="3593592"/>
+            <a:ext cx="4892040" cy="292608"/>
           </a:xfrm>
           <a:prstGeom prst="rect">
             <a:avLst/>
@@ -7857,7 +7857,7 @@
         <p:spPr>
           <a:xfrm>
             <a:off x="6190488" y="1874520"/>
-            <a:ext cx="5394960" cy="3566160"/>
+            <a:ext cx="5166360" cy="3566160"/>
           </a:xfrm>
           <a:prstGeom prst="roundRect">
             <a:avLst>
@@ -7884,7 +7884,7 @@
         <p:spPr>
           <a:xfrm>
             <a:off x="6190488" y="1874520"/>
-            <a:ext cx="5394960" cy="457200"/>
+            <a:ext cx="5166360" cy="457200"/>
           </a:xfrm>
           <a:prstGeom prst="roundRect">
             <a:avLst>
@@ -7911,7 +7911,7 @@
         <p:spPr>
           <a:xfrm>
             <a:off x="6190488" y="1874520"/>
-            <a:ext cx="5394960" cy="457200"/>
+            <a:ext cx="5166360" cy="457200"/>
           </a:xfrm>
           <a:prstGeom prst="rect">
             <a:avLst/>
@@ -7950,7 +7950,7 @@
         <p:spPr>
           <a:xfrm>
             <a:off x="6355080" y="2441448"/>
-            <a:ext cx="5120640" cy="292608"/>
+            <a:ext cx="4892040" cy="292608"/>
           </a:xfrm>
           <a:prstGeom prst="rect">
             <a:avLst/>
@@ -7989,7 +7989,7 @@
         <p:spPr>
           <a:xfrm>
             <a:off x="6355080" y="2779776"/>
-            <a:ext cx="5120640" cy="292608"/>
+            <a:ext cx="4892040" cy="292608"/>
           </a:xfrm>
           <a:prstGeom prst="rect">
             <a:avLst/>
@@ -8028,7 +8028,7 @@
         <p:spPr>
           <a:xfrm>
             <a:off x="6355080" y="3118104"/>
-            <a:ext cx="5065776" cy="0"/>
+            <a:ext cx="4837176" cy="0"/>
           </a:xfrm>
           <a:prstGeom prst="line">
             <a:avLst/>
@@ -8051,7 +8051,7 @@
         <p:spPr>
           <a:xfrm>
             <a:off x="6355080" y="3255264"/>
-            <a:ext cx="5120640" cy="292608"/>
+            <a:ext cx="4892040" cy="292608"/>
           </a:xfrm>
           <a:prstGeom prst="rect">
             <a:avLst/>
@@ -8089,8 +8089,8 @@
         </p:nvSpPr>
         <p:spPr>
           <a:xfrm>
-            <a:off x="612648" y="5623560"/>
-            <a:ext cx="10972800" cy="502920"/>
+            <a:off x="841248" y="5623560"/>
+            <a:ext cx="10515600" cy="502920"/>
           </a:xfrm>
           <a:prstGeom prst="roundRect">
             <a:avLst>
@@ -8116,8 +8116,8 @@
         </p:nvSpPr>
         <p:spPr>
           <a:xfrm>
-            <a:off x="886968" y="5623560"/>
-            <a:ext cx="10424160" cy="502920"/>
+            <a:off x="1115568" y="5623560"/>
+            <a:ext cx="9966960" cy="502920"/>
           </a:xfrm>
           <a:prstGeom prst="rect">
             <a:avLst/>
@@ -8395,8 +8395,8 @@
         </p:nvSpPr>
         <p:spPr>
           <a:xfrm>
-            <a:off x="612648" y="1874520"/>
-            <a:ext cx="6364224" cy="4251960"/>
+            <a:off x="841248" y="1874520"/>
+            <a:ext cx="6099048" cy="4251960"/>
           </a:xfrm>
           <a:prstGeom prst="rect">
             <a:avLst/>
@@ -8480,12 +8480,12 @@
         </p:nvSpPr>
         <p:spPr>
           <a:xfrm>
-            <a:off x="7251192" y="1874520"/>
-            <a:ext cx="4197096" cy="4251960"/>
+            <a:off x="7214616" y="1874520"/>
+            <a:ext cx="4005072" cy="4251960"/>
           </a:xfrm>
           <a:prstGeom prst="roundRect">
             <a:avLst>
-              <a:gd name="adj" fmla="val 2179"/>
+              <a:gd name="adj" fmla="val 2283"/>
             </a:avLst>
           </a:prstGeom>
           <a:solidFill>
@@ -8507,8 +8507,8 @@
         </p:nvSpPr>
         <p:spPr>
           <a:xfrm>
-            <a:off x="7251192" y="1874520"/>
-            <a:ext cx="4197096" cy="457200"/>
+            <a:off x="7214616" y="1874520"/>
+            <a:ext cx="4005072" cy="457200"/>
           </a:xfrm>
           <a:prstGeom prst="roundRect">
             <a:avLst>
@@ -8534,8 +8534,8 @@
         </p:nvSpPr>
         <p:spPr>
           <a:xfrm>
-            <a:off x="7251192" y="1874520"/>
-            <a:ext cx="4197096" cy="457200"/>
+            <a:off x="7214616" y="1874520"/>
+            <a:ext cx="4005072" cy="457200"/>
           </a:xfrm>
           <a:prstGeom prst="rect">
             <a:avLst/>
@@ -8573,7 +8573,7 @@
         </p:nvSpPr>
         <p:spPr>
           <a:xfrm>
-            <a:off x="7452360" y="2724912"/>
+            <a:off x="7415784" y="2724912"/>
             <a:ext cx="219456" cy="219456"/>
           </a:xfrm>
           <a:prstGeom prst="rect">
@@ -8598,7 +8598,7 @@
         </p:nvSpPr>
         <p:spPr>
           <a:xfrm>
-            <a:off x="7452360" y="2724912"/>
+            <a:off x="7415784" y="2724912"/>
             <a:ext cx="219456" cy="219456"/>
           </a:xfrm>
           <a:prstGeom prst="rect">
@@ -8637,8 +8637,8 @@
         </p:nvSpPr>
         <p:spPr>
           <a:xfrm>
-            <a:off x="7763256" y="2423160"/>
-            <a:ext cx="3538728" cy="822960"/>
+            <a:off x="7726680" y="2423160"/>
+            <a:ext cx="3346704" cy="822960"/>
           </a:xfrm>
           <a:prstGeom prst="rect">
             <a:avLst/>
@@ -8676,7 +8676,7 @@
         </p:nvSpPr>
         <p:spPr>
           <a:xfrm>
-            <a:off x="7452360" y="3547872"/>
+            <a:off x="7415784" y="3547872"/>
             <a:ext cx="219456" cy="219456"/>
           </a:xfrm>
           <a:prstGeom prst="rect">
@@ -8701,7 +8701,7 @@
         </p:nvSpPr>
         <p:spPr>
           <a:xfrm>
-            <a:off x="7452360" y="3547872"/>
+            <a:off x="7415784" y="3547872"/>
             <a:ext cx="219456" cy="219456"/>
           </a:xfrm>
           <a:prstGeom prst="rect">
@@ -8740,8 +8740,8 @@
         </p:nvSpPr>
         <p:spPr>
           <a:xfrm>
-            <a:off x="7763256" y="3246120"/>
-            <a:ext cx="3538728" cy="822960"/>
+            <a:off x="7726680" y="3246120"/>
+            <a:ext cx="3346704" cy="822960"/>
           </a:xfrm>
           <a:prstGeom prst="rect">
             <a:avLst/>
@@ -8779,7 +8779,7 @@
         </p:nvSpPr>
         <p:spPr>
           <a:xfrm>
-            <a:off x="7452360" y="4370832"/>
+            <a:off x="7415784" y="4370832"/>
             <a:ext cx="219456" cy="219456"/>
           </a:xfrm>
           <a:prstGeom prst="rect">
@@ -8804,7 +8804,7 @@
         </p:nvSpPr>
         <p:spPr>
           <a:xfrm>
-            <a:off x="7452360" y="4370832"/>
+            <a:off x="7415784" y="4370832"/>
             <a:ext cx="219456" cy="219456"/>
           </a:xfrm>
           <a:prstGeom prst="rect">
@@ -8843,8 +8843,8 @@
         </p:nvSpPr>
         <p:spPr>
           <a:xfrm>
-            <a:off x="7763256" y="4069080"/>
-            <a:ext cx="3538728" cy="822960"/>
+            <a:off x="7726680" y="4069080"/>
+            <a:ext cx="3346704" cy="822960"/>
           </a:xfrm>
           <a:prstGeom prst="rect">
             <a:avLst/>
@@ -9753,8 +9753,8 @@
         </p:nvSpPr>
         <p:spPr>
           <a:xfrm>
-            <a:off x="886968" y="1874520"/>
-            <a:ext cx="3304032" cy="1997964"/>
+            <a:off x="841248" y="1874520"/>
+            <a:ext cx="3334512" cy="1997964"/>
           </a:xfrm>
           <a:prstGeom prst="roundRect">
             <a:avLst>
@@ -9780,7 +9780,7 @@
         </p:nvSpPr>
         <p:spPr>
           <a:xfrm>
-            <a:off x="1069848" y="2075688"/>
+            <a:off x="1024128" y="2075688"/>
             <a:ext cx="1097280" cy="347472"/>
           </a:xfrm>
           <a:prstGeom prst="rect">
@@ -9819,7 +9819,7 @@
         </p:nvSpPr>
         <p:spPr>
           <a:xfrm>
-            <a:off x="1069848" y="2459736"/>
+            <a:off x="1024128" y="2459736"/>
             <a:ext cx="365760" cy="36576"/>
           </a:xfrm>
           <a:prstGeom prst="rect">
@@ -9844,8 +9844,8 @@
         </p:nvSpPr>
         <p:spPr>
           <a:xfrm>
-            <a:off x="1069848" y="2587752"/>
-            <a:ext cx="2938272" cy="1101852"/>
+            <a:off x="1024128" y="2587752"/>
+            <a:ext cx="2968752" cy="1101852"/>
           </a:xfrm>
           <a:prstGeom prst="rect">
             <a:avLst/>
@@ -9883,8 +9883,8 @@
         </p:nvSpPr>
         <p:spPr>
           <a:xfrm>
-            <a:off x="4447032" y="1874520"/>
-            <a:ext cx="3304032" cy="1997964"/>
+            <a:off x="4431792" y="1874520"/>
+            <a:ext cx="3334512" cy="1997964"/>
           </a:xfrm>
           <a:prstGeom prst="roundRect">
             <a:avLst>
@@ -9910,7 +9910,7 @@
         </p:nvSpPr>
         <p:spPr>
           <a:xfrm>
-            <a:off x="4629912" y="2075688"/>
+            <a:off x="4614672" y="2075688"/>
             <a:ext cx="1097280" cy="347472"/>
           </a:xfrm>
           <a:prstGeom prst="rect">
@@ -9949,7 +9949,7 @@
         </p:nvSpPr>
         <p:spPr>
           <a:xfrm>
-            <a:off x="4629912" y="2459736"/>
+            <a:off x="4614672" y="2459736"/>
             <a:ext cx="365760" cy="36576"/>
           </a:xfrm>
           <a:prstGeom prst="rect">
@@ -9974,8 +9974,8 @@
         </p:nvSpPr>
         <p:spPr>
           <a:xfrm>
-            <a:off x="4629912" y="2587752"/>
-            <a:ext cx="2938272" cy="1101852"/>
+            <a:off x="4614672" y="2587752"/>
+            <a:ext cx="2968752" cy="1101852"/>
           </a:xfrm>
           <a:prstGeom prst="rect">
             <a:avLst/>
@@ -10013,8 +10013,8 @@
         </p:nvSpPr>
         <p:spPr>
           <a:xfrm>
-            <a:off x="8007096" y="1874520"/>
-            <a:ext cx="3304032" cy="1997964"/>
+            <a:off x="8022336" y="1874520"/>
+            <a:ext cx="3334512" cy="1997964"/>
           </a:xfrm>
           <a:prstGeom prst="roundRect">
             <a:avLst>
@@ -10040,7 +10040,7 @@
         </p:nvSpPr>
         <p:spPr>
           <a:xfrm>
-            <a:off x="8189976" y="2075688"/>
+            <a:off x="8205216" y="2075688"/>
             <a:ext cx="1097280" cy="347472"/>
           </a:xfrm>
           <a:prstGeom prst="rect">
@@ -10079,7 +10079,7 @@
         </p:nvSpPr>
         <p:spPr>
           <a:xfrm>
-            <a:off x="8189976" y="2459736"/>
+            <a:off x="8205216" y="2459736"/>
             <a:ext cx="365760" cy="36576"/>
           </a:xfrm>
           <a:prstGeom prst="rect">
@@ -10104,8 +10104,8 @@
         </p:nvSpPr>
         <p:spPr>
           <a:xfrm>
-            <a:off x="8189976" y="2587752"/>
-            <a:ext cx="2938272" cy="1101852"/>
+            <a:off x="8205216" y="2587752"/>
+            <a:ext cx="2968752" cy="1101852"/>
           </a:xfrm>
           <a:prstGeom prst="rect">
             <a:avLst/>
@@ -10143,8 +10143,8 @@
         </p:nvSpPr>
         <p:spPr>
           <a:xfrm>
-            <a:off x="886968" y="4128516"/>
-            <a:ext cx="3304032" cy="1997964"/>
+            <a:off x="841248" y="4128516"/>
+            <a:ext cx="3334512" cy="1997964"/>
           </a:xfrm>
           <a:prstGeom prst="roundRect">
             <a:avLst>
@@ -10170,7 +10170,7 @@
         </p:nvSpPr>
         <p:spPr>
           <a:xfrm>
-            <a:off x="1069848" y="4329684"/>
+            <a:off x="1024128" y="4329684"/>
             <a:ext cx="1097280" cy="347472"/>
           </a:xfrm>
           <a:prstGeom prst="rect">
@@ -10209,7 +10209,7 @@
         </p:nvSpPr>
         <p:spPr>
           <a:xfrm>
-            <a:off x="1069848" y="4713732"/>
+            <a:off x="1024128" y="4713732"/>
             <a:ext cx="365760" cy="36576"/>
           </a:xfrm>
           <a:prstGeom prst="rect">
@@ -10234,8 +10234,8 @@
         </p:nvSpPr>
         <p:spPr>
           <a:xfrm>
-            <a:off x="1069848" y="4841748"/>
-            <a:ext cx="2938272" cy="1101852"/>
+            <a:off x="1024128" y="4841748"/>
+            <a:ext cx="2968752" cy="1101852"/>
           </a:xfrm>
           <a:prstGeom prst="rect">
             <a:avLst/>
@@ -10273,8 +10273,8 @@
         </p:nvSpPr>
         <p:spPr>
           <a:xfrm>
-            <a:off x="4447032" y="4128516"/>
-            <a:ext cx="3304032" cy="1997964"/>
+            <a:off x="4431792" y="4128516"/>
+            <a:ext cx="3334512" cy="1997964"/>
           </a:xfrm>
           <a:prstGeom prst="roundRect">
             <a:avLst>
@@ -10300,7 +10300,7 @@
         </p:nvSpPr>
         <p:spPr>
           <a:xfrm>
-            <a:off x="4629912" y="4329684"/>
+            <a:off x="4614672" y="4329684"/>
             <a:ext cx="1097280" cy="347472"/>
           </a:xfrm>
           <a:prstGeom prst="rect">
@@ -10339,7 +10339,7 @@
         </p:nvSpPr>
         <p:spPr>
           <a:xfrm>
-            <a:off x="4629912" y="4713732"/>
+            <a:off x="4614672" y="4713732"/>
             <a:ext cx="365760" cy="36576"/>
           </a:xfrm>
           <a:prstGeom prst="rect">
@@ -10364,8 +10364,8 @@
         </p:nvSpPr>
         <p:spPr>
           <a:xfrm>
-            <a:off x="4629912" y="4841748"/>
-            <a:ext cx="2938272" cy="1101852"/>
+            <a:off x="4614672" y="4841748"/>
+            <a:ext cx="2968752" cy="1101852"/>
           </a:xfrm>
           <a:prstGeom prst="rect">
             <a:avLst/>
@@ -10844,8 +10844,8 @@
         </p:nvSpPr>
         <p:spPr>
           <a:xfrm>
-            <a:off x="612648" y="1874520"/>
-            <a:ext cx="10972800" cy="4251960"/>
+            <a:off x="841248" y="1874520"/>
+            <a:ext cx="10515600" cy="4251960"/>
           </a:xfrm>
           <a:prstGeom prst="rect">
             <a:avLst/>
@@ -11169,7 +11169,7 @@
         </p:nvSpPr>
         <p:spPr>
           <a:xfrm>
-            <a:off x="612648" y="1874520"/>
+            <a:off x="841248" y="1874520"/>
             <a:ext cx="73152" cy="329184"/>
           </a:xfrm>
           <a:prstGeom prst="rect">
@@ -11194,7 +11194,7 @@
         </p:nvSpPr>
         <p:spPr>
           <a:xfrm>
-            <a:off x="777240" y="1874520"/>
+            <a:off x="1005840" y="1874520"/>
             <a:ext cx="5029200" cy="365760"/>
           </a:xfrm>
           <a:prstGeom prst="rect">
@@ -11322,8 +11322,8 @@
         </p:nvSpPr>
         <p:spPr>
           <a:xfrm>
-            <a:off x="612648" y="2377440"/>
-            <a:ext cx="5349240" cy="3749040"/>
+            <a:off x="841248" y="2377440"/>
+            <a:ext cx="5120640" cy="3749040"/>
           </a:xfrm>
           <a:prstGeom prst="rect">
             <a:avLst/>
@@ -11429,7 +11429,7 @@
         <p:spPr>
           <a:xfrm>
             <a:off x="6373368" y="2377440"/>
-            <a:ext cx="5349240" cy="3749040"/>
+            <a:ext cx="5120640" cy="3749040"/>
           </a:xfrm>
           <a:prstGeom prst="rect">
             <a:avLst/>
@@ -11799,8 +11799,8 @@
         </p:nvSpPr>
         <p:spPr>
           <a:xfrm>
-            <a:off x="612648" y="1874520"/>
-            <a:ext cx="5349240" cy="438912"/>
+            <a:off x="841248" y="1874520"/>
+            <a:ext cx="5120640" cy="438912"/>
           </a:xfrm>
           <a:prstGeom prst="rect">
             <a:avLst/>
@@ -11824,7 +11824,7 @@
         </p:nvSpPr>
         <p:spPr>
           <a:xfrm>
-            <a:off x="749808" y="1956816"/>
+            <a:off x="978408" y="1956816"/>
             <a:ext cx="73152" cy="274320"/>
           </a:xfrm>
           <a:prstGeom prst="rect">
@@ -11849,8 +11849,8 @@
         </p:nvSpPr>
         <p:spPr>
           <a:xfrm>
-            <a:off x="914400" y="1874520"/>
-            <a:ext cx="5029200" cy="438912"/>
+            <a:off x="1143000" y="1874520"/>
+            <a:ext cx="4800600" cy="438912"/>
           </a:xfrm>
           <a:prstGeom prst="rect">
             <a:avLst/>
@@ -11888,8 +11888,8 @@
         </p:nvSpPr>
         <p:spPr>
           <a:xfrm>
-            <a:off x="612648" y="2423160"/>
-            <a:ext cx="5349240" cy="658368"/>
+            <a:off x="841248" y="2423160"/>
+            <a:ext cx="5120640" cy="658368"/>
           </a:xfrm>
           <a:prstGeom prst="rect">
             <a:avLst/>
@@ -11913,7 +11913,7 @@
         </p:nvSpPr>
         <p:spPr>
           <a:xfrm>
-            <a:off x="749808" y="2551176"/>
+            <a:off x="978408" y="2551176"/>
             <a:ext cx="292608" cy="292608"/>
           </a:xfrm>
           <a:prstGeom prst="rect">
@@ -11938,7 +11938,7 @@
         </p:nvSpPr>
         <p:spPr>
           <a:xfrm>
-            <a:off x="749808" y="2551176"/>
+            <a:off x="978408" y="2551176"/>
             <a:ext cx="292608" cy="292608"/>
           </a:xfrm>
           <a:prstGeom prst="rect">
@@ -11977,8 +11977,8 @@
         </p:nvSpPr>
         <p:spPr>
           <a:xfrm>
-            <a:off x="1161288" y="2423160"/>
-            <a:ext cx="4663440" cy="658368"/>
+            <a:off x="1389888" y="2423160"/>
+            <a:ext cx="4434840" cy="658368"/>
           </a:xfrm>
           <a:prstGeom prst="rect">
             <a:avLst/>
@@ -12016,7 +12016,7 @@
         </p:nvSpPr>
         <p:spPr>
           <a:xfrm>
-            <a:off x="749808" y="3209544"/>
+            <a:off x="978408" y="3209544"/>
             <a:ext cx="292608" cy="292608"/>
           </a:xfrm>
           <a:prstGeom prst="rect">
@@ -12041,7 +12041,7 @@
         </p:nvSpPr>
         <p:spPr>
           <a:xfrm>
-            <a:off x="749808" y="3209544"/>
+            <a:off x="978408" y="3209544"/>
             <a:ext cx="292608" cy="292608"/>
           </a:xfrm>
           <a:prstGeom prst="rect">
@@ -12080,8 +12080,8 @@
         </p:nvSpPr>
         <p:spPr>
           <a:xfrm>
-            <a:off x="1161288" y="3081528"/>
-            <a:ext cx="4663440" cy="658368"/>
+            <a:off x="1389888" y="3081528"/>
+            <a:ext cx="4434840" cy="658368"/>
           </a:xfrm>
           <a:prstGeom prst="rect">
             <a:avLst/>
@@ -12119,8 +12119,8 @@
         </p:nvSpPr>
         <p:spPr>
           <a:xfrm>
-            <a:off x="612648" y="3739896"/>
-            <a:ext cx="5349240" cy="658368"/>
+            <a:off x="841248" y="3739896"/>
+            <a:ext cx="5120640" cy="658368"/>
           </a:xfrm>
           <a:prstGeom prst="rect">
             <a:avLst/>
@@ -12144,7 +12144,7 @@
         </p:nvSpPr>
         <p:spPr>
           <a:xfrm>
-            <a:off x="749808" y="3867912"/>
+            <a:off x="978408" y="3867912"/>
             <a:ext cx="292608" cy="292608"/>
           </a:xfrm>
           <a:prstGeom prst="rect">
@@ -12169,7 +12169,7 @@
         </p:nvSpPr>
         <p:spPr>
           <a:xfrm>
-            <a:off x="749808" y="3867912"/>
+            <a:off x="978408" y="3867912"/>
             <a:ext cx="292608" cy="292608"/>
           </a:xfrm>
           <a:prstGeom prst="rect">
@@ -12208,8 +12208,8 @@
         </p:nvSpPr>
         <p:spPr>
           <a:xfrm>
-            <a:off x="1161288" y="3739896"/>
-            <a:ext cx="4663440" cy="658368"/>
+            <a:off x="1389888" y="3739896"/>
+            <a:ext cx="4434840" cy="658368"/>
           </a:xfrm>
           <a:prstGeom prst="rect">
             <a:avLst/>
@@ -12248,7 +12248,7 @@
         <p:spPr>
           <a:xfrm>
             <a:off x="6236208" y="1874520"/>
-            <a:ext cx="5349240" cy="438912"/>
+            <a:ext cx="5120640" cy="438912"/>
           </a:xfrm>
           <a:prstGeom prst="rect">
             <a:avLst/>
@@ -12298,7 +12298,7 @@
         <p:spPr>
           <a:xfrm>
             <a:off x="6537960" y="1874520"/>
-            <a:ext cx="5029200" cy="438912"/>
+            <a:ext cx="4800600" cy="438912"/>
           </a:xfrm>
           <a:prstGeom prst="rect">
             <a:avLst/>
@@ -12337,7 +12337,7 @@
         <p:spPr>
           <a:xfrm>
             <a:off x="6236208" y="2423160"/>
-            <a:ext cx="5349240" cy="658368"/>
+            <a:ext cx="5120640" cy="658368"/>
           </a:xfrm>
           <a:prstGeom prst="rect">
             <a:avLst/>
@@ -12426,7 +12426,7 @@
         <p:spPr>
           <a:xfrm>
             <a:off x="6784848" y="2423160"/>
-            <a:ext cx="4663440" cy="658368"/>
+            <a:ext cx="4434840" cy="658368"/>
           </a:xfrm>
           <a:prstGeom prst="rect">
             <a:avLst/>
@@ -12529,7 +12529,7 @@
         <p:spPr>
           <a:xfrm>
             <a:off x="6784848" y="3081528"/>
-            <a:ext cx="4663440" cy="658368"/>
+            <a:ext cx="4434840" cy="658368"/>
           </a:xfrm>
           <a:prstGeom prst="rect">
             <a:avLst/>
@@ -12568,7 +12568,7 @@
         <p:spPr>
           <a:xfrm>
             <a:off x="6236208" y="3739896"/>
-            <a:ext cx="5349240" cy="658368"/>
+            <a:ext cx="5120640" cy="658368"/>
           </a:xfrm>
           <a:prstGeom prst="rect">
             <a:avLst/>
@@ -12657,7 +12657,7 @@
         <p:spPr>
           <a:xfrm>
             <a:off x="6784848" y="3739896"/>
-            <a:ext cx="4663440" cy="658368"/>
+            <a:ext cx="4434840" cy="658368"/>
           </a:xfrm>
           <a:prstGeom prst="rect">
             <a:avLst/>
@@ -12935,12 +12935,12 @@
         </p:nvSpPr>
         <p:spPr>
           <a:xfrm>
-            <a:off x="612648" y="1947672"/>
-            <a:ext cx="2537460" cy="4114800"/>
+            <a:off x="841248" y="1947672"/>
+            <a:ext cx="2423160" cy="4114800"/>
           </a:xfrm>
           <a:prstGeom prst="roundRect">
             <a:avLst>
-              <a:gd name="adj" fmla="val 3604"/>
+              <a:gd name="adj" fmla="val 3774"/>
             </a:avLst>
           </a:prstGeom>
           <a:solidFill>
@@ -12962,8 +12962,8 @@
         </p:nvSpPr>
         <p:spPr>
           <a:xfrm>
-            <a:off x="612648" y="1947672"/>
-            <a:ext cx="2537460" cy="54864"/>
+            <a:off x="841248" y="1947672"/>
+            <a:ext cx="2423160" cy="54864"/>
           </a:xfrm>
           <a:prstGeom prst="rect">
             <a:avLst/>
@@ -12987,8 +12987,8 @@
         </p:nvSpPr>
         <p:spPr>
           <a:xfrm>
-            <a:off x="612648" y="2450592"/>
-            <a:ext cx="2537460" cy="1280160"/>
+            <a:off x="841248" y="2450592"/>
+            <a:ext cx="2423160" cy="1280160"/>
           </a:xfrm>
           <a:prstGeom prst="rect">
             <a:avLst/>
@@ -13026,8 +13026,8 @@
         </p:nvSpPr>
         <p:spPr>
           <a:xfrm>
-            <a:off x="612648" y="3822192"/>
-            <a:ext cx="2537460" cy="457200"/>
+            <a:off x="841248" y="3822192"/>
+            <a:ext cx="2423160" cy="457200"/>
           </a:xfrm>
           <a:prstGeom prst="rect">
             <a:avLst/>
@@ -13065,8 +13065,8 @@
         </p:nvSpPr>
         <p:spPr>
           <a:xfrm>
-            <a:off x="612648" y="5376672"/>
-            <a:ext cx="2537460" cy="548640"/>
+            <a:off x="841248" y="5376672"/>
+            <a:ext cx="2423160" cy="548640"/>
           </a:xfrm>
           <a:prstGeom prst="rect">
             <a:avLst/>
@@ -13104,12 +13104,12 @@
         </p:nvSpPr>
         <p:spPr>
           <a:xfrm>
-            <a:off x="3424428" y="1947672"/>
-            <a:ext cx="2537460" cy="4114800"/>
+            <a:off x="3538728" y="1947672"/>
+            <a:ext cx="2423160" cy="4114800"/>
           </a:xfrm>
           <a:prstGeom prst="roundRect">
             <a:avLst>
-              <a:gd name="adj" fmla="val 3604"/>
+              <a:gd name="adj" fmla="val 3774"/>
             </a:avLst>
           </a:prstGeom>
           <a:solidFill>
@@ -13131,8 +13131,8 @@
         </p:nvSpPr>
         <p:spPr>
           <a:xfrm>
-            <a:off x="3424428" y="1947672"/>
-            <a:ext cx="2537460" cy="54864"/>
+            <a:off x="3538728" y="1947672"/>
+            <a:ext cx="2423160" cy="54864"/>
           </a:xfrm>
           <a:prstGeom prst="rect">
             <a:avLst/>
@@ -13156,8 +13156,8 @@
         </p:nvSpPr>
         <p:spPr>
           <a:xfrm>
-            <a:off x="3424428" y="2450592"/>
-            <a:ext cx="2537460" cy="1280160"/>
+            <a:off x="3538728" y="2450592"/>
+            <a:ext cx="2423160" cy="1280160"/>
           </a:xfrm>
           <a:prstGeom prst="rect">
             <a:avLst/>
@@ -13195,8 +13195,8 @@
         </p:nvSpPr>
         <p:spPr>
           <a:xfrm>
-            <a:off x="3424428" y="3822192"/>
-            <a:ext cx="2537460" cy="457200"/>
+            <a:off x="3538728" y="3822192"/>
+            <a:ext cx="2423160" cy="457200"/>
           </a:xfrm>
           <a:prstGeom prst="rect">
             <a:avLst/>
@@ -13234,8 +13234,8 @@
         </p:nvSpPr>
         <p:spPr>
           <a:xfrm>
-            <a:off x="3424428" y="5376672"/>
-            <a:ext cx="2537460" cy="548640"/>
+            <a:off x="3538728" y="5376672"/>
+            <a:ext cx="2423160" cy="548640"/>
           </a:xfrm>
           <a:prstGeom prst="rect">
             <a:avLst/>
@@ -13274,11 +13274,11 @@
         <p:spPr>
           <a:xfrm>
             <a:off x="6236208" y="1947672"/>
-            <a:ext cx="2537460" cy="4114800"/>
+            <a:ext cx="2423160" cy="4114800"/>
           </a:xfrm>
           <a:prstGeom prst="roundRect">
             <a:avLst>
-              <a:gd name="adj" fmla="val 3604"/>
+              <a:gd name="adj" fmla="val 3774"/>
             </a:avLst>
           </a:prstGeom>
           <a:solidFill>
@@ -13301,7 +13301,7 @@
         <p:spPr>
           <a:xfrm>
             <a:off x="6236208" y="1947672"/>
-            <a:ext cx="2537460" cy="54864"/>
+            <a:ext cx="2423160" cy="54864"/>
           </a:xfrm>
           <a:prstGeom prst="rect">
             <a:avLst/>
@@ -13326,7 +13326,7 @@
         <p:spPr>
           <a:xfrm>
             <a:off x="6236208" y="2450592"/>
-            <a:ext cx="2537460" cy="1280160"/>
+            <a:ext cx="2423160" cy="1280160"/>
           </a:xfrm>
           <a:prstGeom prst="rect">
             <a:avLst/>
@@ -13365,7 +13365,7 @@
         <p:spPr>
           <a:xfrm>
             <a:off x="6236208" y="3822192"/>
-            <a:ext cx="2537460" cy="457200"/>
+            <a:ext cx="2423160" cy="457200"/>
           </a:xfrm>
           <a:prstGeom prst="rect">
             <a:avLst/>
@@ -13404,7 +13404,7 @@
         <p:spPr>
           <a:xfrm>
             <a:off x="6236208" y="5376672"/>
-            <a:ext cx="2537460" cy="548640"/>
+            <a:ext cx="2423160" cy="548640"/>
           </a:xfrm>
           <a:prstGeom prst="rect">
             <a:avLst/>
@@ -13442,12 +13442,12 @@
         </p:nvSpPr>
         <p:spPr>
           <a:xfrm>
-            <a:off x="9047988" y="1947672"/>
-            <a:ext cx="2537460" cy="4114800"/>
+            <a:off x="8933688" y="1947672"/>
+            <a:ext cx="2423160" cy="4114800"/>
           </a:xfrm>
           <a:prstGeom prst="roundRect">
             <a:avLst>
-              <a:gd name="adj" fmla="val 3604"/>
+              <a:gd name="adj" fmla="val 3774"/>
             </a:avLst>
           </a:prstGeom>
           <a:solidFill>
@@ -13469,8 +13469,8 @@
         </p:nvSpPr>
         <p:spPr>
           <a:xfrm>
-            <a:off x="9047988" y="1947672"/>
-            <a:ext cx="2537460" cy="54864"/>
+            <a:off x="8933688" y="1947672"/>
+            <a:ext cx="2423160" cy="54864"/>
           </a:xfrm>
           <a:prstGeom prst="rect">
             <a:avLst/>
@@ -13494,8 +13494,8 @@
         </p:nvSpPr>
         <p:spPr>
           <a:xfrm>
-            <a:off x="9047988" y="2450592"/>
-            <a:ext cx="2537460" cy="1280160"/>
+            <a:off x="8933688" y="2450592"/>
+            <a:ext cx="2423160" cy="1280160"/>
           </a:xfrm>
           <a:prstGeom prst="rect">
             <a:avLst/>
@@ -13533,8 +13533,8 @@
         </p:nvSpPr>
         <p:spPr>
           <a:xfrm>
-            <a:off x="9047988" y="3822192"/>
-            <a:ext cx="2537460" cy="457200"/>
+            <a:off x="8933688" y="3822192"/>
+            <a:ext cx="2423160" cy="457200"/>
           </a:xfrm>
           <a:prstGeom prst="rect">
             <a:avLst/>
@@ -13572,8 +13572,8 @@
         </p:nvSpPr>
         <p:spPr>
           <a:xfrm>
-            <a:off x="9047988" y="5376672"/>
-            <a:ext cx="2537460" cy="548640"/>
+            <a:off x="8933688" y="5376672"/>
+            <a:ext cx="2423160" cy="548640"/>
           </a:xfrm>
           <a:prstGeom prst="rect">
             <a:avLst/>
@@ -13850,8 +13850,8 @@
           <p:nvPr/>
         </p:nvGraphicFramePr>
         <p:xfrm>
-          <a:off x="612648" y="1874520"/>
-          <a:ext cx="10972800" cy="4251960"/>
+          <a:off x="841248" y="1874520"/>
+          <a:ext cx="10515600" cy="4251960"/>
         </p:xfrm>
         <a:graphic xmlns:a="http://schemas.openxmlformats.org/drawingml/2006/main">
           <a:graphicData uri="http://schemas.openxmlformats.org/drawingml/2006/chart">
@@ -14106,8 +14106,8 @@
           <p:nvPr/>
         </p:nvGraphicFramePr>
         <p:xfrm>
-          <a:off x="612648" y="1874520"/>
-          <a:ext cx="10972800" cy="4251960"/>
+          <a:off x="841248" y="1874520"/>
+          <a:ext cx="10515600" cy="4251960"/>
         </p:xfrm>
         <a:graphic xmlns:a="http://schemas.openxmlformats.org/drawingml/2006/main">
           <a:graphicData uri="http://schemas.openxmlformats.org/drawingml/2006/chart">

</xml_diff>

<commit_message>
feat: comparison 슬라이드 헤더 accent fill 적용 + text-on-accent 토큰 추가
comparison 슬라이드 컬럼 헤더 박스를 테마 accent/muted 색으로 채워
헤더와 목록 아이템 간 시각 계층을 명확히 구분.
헤더 위 bar·텍스트 색상을 text-on-accent 토큰으로 참조하도록 변경하여
향후 밝은 accent를 쓰는 preset도 대응 가능하게 확장.
showcase PPTX·PDF 3종(modern-light, teal-dark, vivid-dark) 재생성.

Co-Authored-By: Claude Sonnet 4.6 <noreply@anthropic.com>
</commit_message>
<xml_diff>
--- a/examples/results/showcase-modern-light.pptx
+++ b/examples/results/showcase-modern-light.pptx
@@ -11806,6 +11806,95 @@
             <a:avLst/>
           </a:prstGeom>
           <a:solidFill>
+            <a:srgbClr val="6B7280"/>
+          </a:solidFill>
+          <a:ln w="12700">
+            <a:solidFill>
+              <a:srgbClr val="6B7280"/>
+            </a:solidFill>
+            <a:prstDash val="solid"/>
+          </a:ln>
+        </p:spPr>
+      </p:sp>
+      <p:sp>
+        <p:nvSpPr>
+          <p:cNvPr id="8" name="Shape 6"/>
+          <p:cNvSpPr/>
+          <p:nvPr/>
+        </p:nvSpPr>
+        <p:spPr>
+          <a:xfrm>
+            <a:off x="978408" y="1956816"/>
+            <a:ext cx="73152" cy="274320"/>
+          </a:xfrm>
+          <a:prstGeom prst="rect">
+            <a:avLst/>
+          </a:prstGeom>
+          <a:solidFill>
+            <a:srgbClr val="FFFFFF"/>
+          </a:solidFill>
+          <a:ln w="12700">
+            <a:solidFill>
+              <a:srgbClr val="FFFFFF"/>
+            </a:solidFill>
+            <a:prstDash val="solid"/>
+          </a:ln>
+        </p:spPr>
+      </p:sp>
+      <p:sp>
+        <p:nvSpPr>
+          <p:cNvPr id="9" name="Text 7"/>
+          <p:cNvSpPr/>
+          <p:nvPr/>
+        </p:nvSpPr>
+        <p:spPr>
+          <a:xfrm>
+            <a:off x="1143000" y="1874520"/>
+            <a:ext cx="4800600" cy="438912"/>
+          </a:xfrm>
+          <a:prstGeom prst="rect">
+            <a:avLst/>
+          </a:prstGeom>
+          <a:noFill/>
+          <a:ln/>
+        </p:spPr>
+        <p:txBody>
+          <a:bodyPr wrap="square" rtlCol="0" anchor="ctr"/>
+          <a:lstStyle/>
+          <a:p>
+            <a:pPr indent="0" marL="0">
+              <a:buNone/>
+            </a:pPr>
+            <a:r>
+              <a:rPr lang="en-US" sz="1800" b="1" dirty="0">
+                <a:solidFill>
+                  <a:srgbClr val="FFFFFF"/>
+                </a:solidFill>
+                <a:latin typeface="Pretendard" pitchFamily="34" charset="0"/>
+                <a:ea typeface="Pretendard" pitchFamily="34" charset="-122"/>
+                <a:cs typeface="Pretendard" pitchFamily="34" charset="-120"/>
+              </a:rPr>
+              <a:t>입력만 보는 방식</a:t>
+            </a:r>
+            <a:endParaRPr lang="en-US" sz="1800" dirty="0"/>
+          </a:p>
+        </p:txBody>
+      </p:sp>
+      <p:sp>
+        <p:nvSpPr>
+          <p:cNvPr id="10" name="Shape 8"/>
+          <p:cNvSpPr/>
+          <p:nvPr/>
+        </p:nvSpPr>
+        <p:spPr>
+          <a:xfrm>
+            <a:off x="841248" y="2423160"/>
+            <a:ext cx="5120640" cy="658368"/>
+          </a:xfrm>
+          <a:prstGeom prst="rect">
+            <a:avLst/>
+          </a:prstGeom>
+          <a:solidFill>
             <a:srgbClr val="F0F0F2"/>
           </a:solidFill>
           <a:ln w="12700">
@@ -11818,14 +11907,14 @@
       </p:sp>
       <p:sp>
         <p:nvSpPr>
-          <p:cNvPr id="8" name="Shape 6"/>
-          <p:cNvSpPr/>
-          <p:nvPr/>
-        </p:nvSpPr>
-        <p:spPr>
-          <a:xfrm>
-            <a:off x="978408" y="1956816"/>
-            <a:ext cx="73152" cy="274320"/>
+          <p:cNvPr id="11" name="Shape 9"/>
+          <p:cNvSpPr/>
+          <p:nvPr/>
+        </p:nvSpPr>
+        <p:spPr>
+          <a:xfrm>
+            <a:off x="978408" y="2551176"/>
+            <a:ext cx="292608" cy="292608"/>
           </a:xfrm>
           <a:prstGeom prst="rect">
             <a:avLst/>
@@ -11843,14 +11932,14 @@
       </p:sp>
       <p:sp>
         <p:nvSpPr>
-          <p:cNvPr id="9" name="Text 7"/>
-          <p:cNvSpPr/>
-          <p:nvPr/>
-        </p:nvSpPr>
-        <p:spPr>
-          <a:xfrm>
-            <a:off x="1143000" y="1874520"/>
-            <a:ext cx="4800600" cy="438912"/>
+          <p:cNvPr id="12" name="Text 10"/>
+          <p:cNvSpPr/>
+          <p:nvPr/>
+        </p:nvSpPr>
+        <p:spPr>
+          <a:xfrm>
+            <a:off x="978408" y="2551176"/>
+            <a:ext cx="292608" cy="292608"/>
           </a:xfrm>
           <a:prstGeom prst="rect">
             <a:avLst/>
@@ -11862,11 +11951,50 @@
           <a:bodyPr wrap="square" rtlCol="0" anchor="ctr"/>
           <a:lstStyle/>
           <a:p>
+            <a:pPr algn="ctr" indent="0" marL="0">
+              <a:buNone/>
+            </a:pPr>
+            <a:r>
+              <a:rPr lang="en-US" sz="1100" b="1" dirty="0">
+                <a:solidFill>
+                  <a:srgbClr val="FFFFFF"/>
+                </a:solidFill>
+                <a:latin typeface="Pretendard" pitchFamily="34" charset="0"/>
+                <a:ea typeface="Pretendard" pitchFamily="34" charset="-122"/>
+                <a:cs typeface="Pretendard" pitchFamily="34" charset="-120"/>
+              </a:rPr>
+              <a:t>×</a:t>
+            </a:r>
+            <a:endParaRPr lang="en-US" sz="1100" dirty="0"/>
+          </a:p>
+        </p:txBody>
+      </p:sp>
+      <p:sp>
+        <p:nvSpPr>
+          <p:cNvPr id="13" name="Text 11"/>
+          <p:cNvSpPr/>
+          <p:nvPr/>
+        </p:nvSpPr>
+        <p:spPr>
+          <a:xfrm>
+            <a:off x="1389888" y="2423160"/>
+            <a:ext cx="4434840" cy="658368"/>
+          </a:xfrm>
+          <a:prstGeom prst="rect">
+            <a:avLst/>
+          </a:prstGeom>
+          <a:noFill/>
+          <a:ln/>
+        </p:spPr>
+        <p:txBody>
+          <a:bodyPr wrap="square" rtlCol="0" anchor="ctr"/>
+          <a:lstStyle/>
+          <a:p>
             <a:pPr indent="0" marL="0">
               <a:buNone/>
             </a:pPr>
             <a:r>
-              <a:rPr lang="en-US" sz="1800" b="1" dirty="0">
+              <a:rPr lang="en-US" sz="1600" dirty="0">
                 <a:solidFill>
                   <a:srgbClr val="6B7280"/>
                 </a:solidFill>
@@ -11874,21 +12002,124 @@
                 <a:ea typeface="Pretendard" pitchFamily="34" charset="-122"/>
                 <a:cs typeface="Pretendard" pitchFamily="34" charset="-120"/>
               </a:rPr>
-              <a:t>입력만 보는 방식</a:t>
-            </a:r>
-            <a:endParaRPr lang="en-US" sz="1800" dirty="0"/>
-          </a:p>
-        </p:txBody>
-      </p:sp>
-      <p:sp>
-        <p:nvSpPr>
-          <p:cNvPr id="10" name="Shape 8"/>
-          <p:cNvSpPr/>
-          <p:nvPr/>
-        </p:nvSpPr>
-        <p:spPr>
-          <a:xfrm>
-            <a:off x="841248" y="2423160"/>
+              <a:t>“요약해줘”를 여러 bullet로 변환</a:t>
+            </a:r>
+            <a:endParaRPr lang="en-US" sz="1600" dirty="0"/>
+          </a:p>
+        </p:txBody>
+      </p:sp>
+      <p:sp>
+        <p:nvSpPr>
+          <p:cNvPr id="14" name="Shape 12"/>
+          <p:cNvSpPr/>
+          <p:nvPr/>
+        </p:nvSpPr>
+        <p:spPr>
+          <a:xfrm>
+            <a:off x="978408" y="3209544"/>
+            <a:ext cx="292608" cy="292608"/>
+          </a:xfrm>
+          <a:prstGeom prst="rect">
+            <a:avLst/>
+          </a:prstGeom>
+          <a:solidFill>
+            <a:srgbClr val="6B7280"/>
+          </a:solidFill>
+          <a:ln w="12700">
+            <a:solidFill>
+              <a:srgbClr val="6B7280"/>
+            </a:solidFill>
+            <a:prstDash val="solid"/>
+          </a:ln>
+        </p:spPr>
+      </p:sp>
+      <p:sp>
+        <p:nvSpPr>
+          <p:cNvPr id="15" name="Text 13"/>
+          <p:cNvSpPr/>
+          <p:nvPr/>
+        </p:nvSpPr>
+        <p:spPr>
+          <a:xfrm>
+            <a:off x="978408" y="3209544"/>
+            <a:ext cx="292608" cy="292608"/>
+          </a:xfrm>
+          <a:prstGeom prst="rect">
+            <a:avLst/>
+          </a:prstGeom>
+          <a:noFill/>
+          <a:ln/>
+        </p:spPr>
+        <p:txBody>
+          <a:bodyPr wrap="square" rtlCol="0" anchor="ctr"/>
+          <a:lstStyle/>
+          <a:p>
+            <a:pPr algn="ctr" indent="0" marL="0">
+              <a:buNone/>
+            </a:pPr>
+            <a:r>
+              <a:rPr lang="en-US" sz="1100" b="1" dirty="0">
+                <a:solidFill>
+                  <a:srgbClr val="FFFFFF"/>
+                </a:solidFill>
+                <a:latin typeface="Pretendard" pitchFamily="34" charset="0"/>
+                <a:ea typeface="Pretendard" pitchFamily="34" charset="-122"/>
+                <a:cs typeface="Pretendard" pitchFamily="34" charset="-120"/>
+              </a:rPr>
+              <a:t>×</a:t>
+            </a:r>
+            <a:endParaRPr lang="en-US" sz="1100" dirty="0"/>
+          </a:p>
+        </p:txBody>
+      </p:sp>
+      <p:sp>
+        <p:nvSpPr>
+          <p:cNvPr id="16" name="Text 14"/>
+          <p:cNvSpPr/>
+          <p:nvPr/>
+        </p:nvSpPr>
+        <p:spPr>
+          <a:xfrm>
+            <a:off x="1389888" y="3081528"/>
+            <a:ext cx="4434840" cy="658368"/>
+          </a:xfrm>
+          <a:prstGeom prst="rect">
+            <a:avLst/>
+          </a:prstGeom>
+          <a:noFill/>
+          <a:ln/>
+        </p:spPr>
+        <p:txBody>
+          <a:bodyPr wrap="square" rtlCol="0" anchor="ctr"/>
+          <a:lstStyle/>
+          <a:p>
+            <a:pPr indent="0" marL="0">
+              <a:buNone/>
+            </a:pPr>
+            <a:r>
+              <a:rPr lang="en-US" sz="1600" dirty="0">
+                <a:solidFill>
+                  <a:srgbClr val="6B7280"/>
+                </a:solidFill>
+                <a:latin typeface="Pretendard" pitchFamily="34" charset="0"/>
+                <a:ea typeface="Pretendard" pitchFamily="34" charset="-122"/>
+                <a:cs typeface="Pretendard" pitchFamily="34" charset="-120"/>
+              </a:rPr>
+              <a:t>중요 문장을 모두 같은 레벨로 표시</a:t>
+            </a:r>
+            <a:endParaRPr lang="en-US" sz="1600" dirty="0"/>
+          </a:p>
+        </p:txBody>
+      </p:sp>
+      <p:sp>
+        <p:nvSpPr>
+          <p:cNvPr id="17" name="Shape 15"/>
+          <p:cNvSpPr/>
+          <p:nvPr/>
+        </p:nvSpPr>
+        <p:spPr>
+          <a:xfrm>
+            <a:off x="841248" y="3739896"/>
             <a:ext cx="5120640" cy="658368"/>
           </a:xfrm>
           <a:prstGeom prst="rect">
@@ -11907,13 +12138,13 @@
       </p:sp>
       <p:sp>
         <p:nvSpPr>
-          <p:cNvPr id="11" name="Shape 9"/>
-          <p:cNvSpPr/>
-          <p:nvPr/>
-        </p:nvSpPr>
-        <p:spPr>
-          <a:xfrm>
-            <a:off x="978408" y="2551176"/>
+          <p:cNvPr id="18" name="Shape 16"/>
+          <p:cNvSpPr/>
+          <p:nvPr/>
+        </p:nvSpPr>
+        <p:spPr>
+          <a:xfrm>
+            <a:off x="978408" y="3867912"/>
             <a:ext cx="292608" cy="292608"/>
           </a:xfrm>
           <a:prstGeom prst="rect">
@@ -11932,213 +12163,7 @@
       </p:sp>
       <p:sp>
         <p:nvSpPr>
-          <p:cNvPr id="12" name="Text 10"/>
-          <p:cNvSpPr/>
-          <p:nvPr/>
-        </p:nvSpPr>
-        <p:spPr>
-          <a:xfrm>
-            <a:off x="978408" y="2551176"/>
-            <a:ext cx="292608" cy="292608"/>
-          </a:xfrm>
-          <a:prstGeom prst="rect">
-            <a:avLst/>
-          </a:prstGeom>
-          <a:noFill/>
-          <a:ln/>
-        </p:spPr>
-        <p:txBody>
-          <a:bodyPr wrap="square" rtlCol="0" anchor="ctr"/>
-          <a:lstStyle/>
-          <a:p>
-            <a:pPr algn="ctr" indent="0" marL="0">
-              <a:buNone/>
-            </a:pPr>
-            <a:r>
-              <a:rPr lang="en-US" sz="1100" b="1" dirty="0">
-                <a:solidFill>
-                  <a:srgbClr val="FFFFFF"/>
-                </a:solidFill>
-                <a:latin typeface="Pretendard" pitchFamily="34" charset="0"/>
-                <a:ea typeface="Pretendard" pitchFamily="34" charset="-122"/>
-                <a:cs typeface="Pretendard" pitchFamily="34" charset="-120"/>
-              </a:rPr>
-              <a:t>×</a:t>
-            </a:r>
-            <a:endParaRPr lang="en-US" sz="1100" dirty="0"/>
-          </a:p>
-        </p:txBody>
-      </p:sp>
-      <p:sp>
-        <p:nvSpPr>
-          <p:cNvPr id="13" name="Text 11"/>
-          <p:cNvSpPr/>
-          <p:nvPr/>
-        </p:nvSpPr>
-        <p:spPr>
-          <a:xfrm>
-            <a:off x="1389888" y="2423160"/>
-            <a:ext cx="4434840" cy="658368"/>
-          </a:xfrm>
-          <a:prstGeom prst="rect">
-            <a:avLst/>
-          </a:prstGeom>
-          <a:noFill/>
-          <a:ln/>
-        </p:spPr>
-        <p:txBody>
-          <a:bodyPr wrap="square" rtlCol="0" anchor="ctr"/>
-          <a:lstStyle/>
-          <a:p>
-            <a:pPr indent="0" marL="0">
-              <a:buNone/>
-            </a:pPr>
-            <a:r>
-              <a:rPr lang="en-US" sz="1600" dirty="0">
-                <a:solidFill>
-                  <a:srgbClr val="6B7280"/>
-                </a:solidFill>
-                <a:latin typeface="Pretendard" pitchFamily="34" charset="0"/>
-                <a:ea typeface="Pretendard" pitchFamily="34" charset="-122"/>
-                <a:cs typeface="Pretendard" pitchFamily="34" charset="-120"/>
-              </a:rPr>
-              <a:t>“요약해줘”를 여러 bullet로 변환</a:t>
-            </a:r>
-            <a:endParaRPr lang="en-US" sz="1600" dirty="0"/>
-          </a:p>
-        </p:txBody>
-      </p:sp>
-      <p:sp>
-        <p:nvSpPr>
-          <p:cNvPr id="14" name="Shape 12"/>
-          <p:cNvSpPr/>
-          <p:nvPr/>
-        </p:nvSpPr>
-        <p:spPr>
-          <a:xfrm>
-            <a:off x="978408" y="3209544"/>
-            <a:ext cx="292608" cy="292608"/>
-          </a:xfrm>
-          <a:prstGeom prst="rect">
-            <a:avLst/>
-          </a:prstGeom>
-          <a:solidFill>
-            <a:srgbClr val="6B7280"/>
-          </a:solidFill>
-          <a:ln w="12700">
-            <a:solidFill>
-              <a:srgbClr val="6B7280"/>
-            </a:solidFill>
-            <a:prstDash val="solid"/>
-          </a:ln>
-        </p:spPr>
-      </p:sp>
-      <p:sp>
-        <p:nvSpPr>
-          <p:cNvPr id="15" name="Text 13"/>
-          <p:cNvSpPr/>
-          <p:nvPr/>
-        </p:nvSpPr>
-        <p:spPr>
-          <a:xfrm>
-            <a:off x="978408" y="3209544"/>
-            <a:ext cx="292608" cy="292608"/>
-          </a:xfrm>
-          <a:prstGeom prst="rect">
-            <a:avLst/>
-          </a:prstGeom>
-          <a:noFill/>
-          <a:ln/>
-        </p:spPr>
-        <p:txBody>
-          <a:bodyPr wrap="square" rtlCol="0" anchor="ctr"/>
-          <a:lstStyle/>
-          <a:p>
-            <a:pPr algn="ctr" indent="0" marL="0">
-              <a:buNone/>
-            </a:pPr>
-            <a:r>
-              <a:rPr lang="en-US" sz="1100" b="1" dirty="0">
-                <a:solidFill>
-                  <a:srgbClr val="FFFFFF"/>
-                </a:solidFill>
-                <a:latin typeface="Pretendard" pitchFamily="34" charset="0"/>
-                <a:ea typeface="Pretendard" pitchFamily="34" charset="-122"/>
-                <a:cs typeface="Pretendard" pitchFamily="34" charset="-120"/>
-              </a:rPr>
-              <a:t>×</a:t>
-            </a:r>
-            <a:endParaRPr lang="en-US" sz="1100" dirty="0"/>
-          </a:p>
-        </p:txBody>
-      </p:sp>
-      <p:sp>
-        <p:nvSpPr>
-          <p:cNvPr id="16" name="Text 14"/>
-          <p:cNvSpPr/>
-          <p:nvPr/>
-        </p:nvSpPr>
-        <p:spPr>
-          <a:xfrm>
-            <a:off x="1389888" y="3081528"/>
-            <a:ext cx="4434840" cy="658368"/>
-          </a:xfrm>
-          <a:prstGeom prst="rect">
-            <a:avLst/>
-          </a:prstGeom>
-          <a:noFill/>
-          <a:ln/>
-        </p:spPr>
-        <p:txBody>
-          <a:bodyPr wrap="square" rtlCol="0" anchor="ctr"/>
-          <a:lstStyle/>
-          <a:p>
-            <a:pPr indent="0" marL="0">
-              <a:buNone/>
-            </a:pPr>
-            <a:r>
-              <a:rPr lang="en-US" sz="1600" dirty="0">
-                <a:solidFill>
-                  <a:srgbClr val="6B7280"/>
-                </a:solidFill>
-                <a:latin typeface="Pretendard" pitchFamily="34" charset="0"/>
-                <a:ea typeface="Pretendard" pitchFamily="34" charset="-122"/>
-                <a:cs typeface="Pretendard" pitchFamily="34" charset="-120"/>
-              </a:rPr>
-              <a:t>중요 문장을 모두 같은 레벨로 표시</a:t>
-            </a:r>
-            <a:endParaRPr lang="en-US" sz="1600" dirty="0"/>
-          </a:p>
-        </p:txBody>
-      </p:sp>
-      <p:sp>
-        <p:nvSpPr>
-          <p:cNvPr id="17" name="Shape 15"/>
-          <p:cNvSpPr/>
-          <p:nvPr/>
-        </p:nvSpPr>
-        <p:spPr>
-          <a:xfrm>
-            <a:off x="841248" y="3739896"/>
-            <a:ext cx="5120640" cy="658368"/>
-          </a:xfrm>
-          <a:prstGeom prst="rect">
-            <a:avLst/>
-          </a:prstGeom>
-          <a:solidFill>
-            <a:srgbClr val="F0F0F2"/>
-          </a:solidFill>
-          <a:ln w="12700">
-            <a:solidFill>
-              <a:srgbClr val="E0E7FF"/>
-            </a:solidFill>
-            <a:prstDash val="solid"/>
-          </a:ln>
-        </p:spPr>
-      </p:sp>
-      <p:sp>
-        <p:nvSpPr>
-          <p:cNvPr id="18" name="Shape 16"/>
+          <p:cNvPr id="19" name="Text 17"/>
           <p:cNvSpPr/>
           <p:nvPr/>
         </p:nvSpPr>
@@ -12150,31 +12175,6 @@
           <a:prstGeom prst="rect">
             <a:avLst/>
           </a:prstGeom>
-          <a:solidFill>
-            <a:srgbClr val="6B7280"/>
-          </a:solidFill>
-          <a:ln w="12700">
-            <a:solidFill>
-              <a:srgbClr val="6B7280"/>
-            </a:solidFill>
-            <a:prstDash val="solid"/>
-          </a:ln>
-        </p:spPr>
-      </p:sp>
-      <p:sp>
-        <p:nvSpPr>
-          <p:cNvPr id="19" name="Text 17"/>
-          <p:cNvSpPr/>
-          <p:nvPr/>
-        </p:nvSpPr>
-        <p:spPr>
-          <a:xfrm>
-            <a:off x="978408" y="3867912"/>
-            <a:ext cx="292608" cy="292608"/>
-          </a:xfrm>
-          <a:prstGeom prst="rect">
-            <a:avLst/>
-          </a:prstGeom>
           <a:noFill/>
           <a:ln/>
         </p:spPr>
@@ -12249,31 +12249,6 @@
           <a:xfrm>
             <a:off x="6236208" y="1874520"/>
             <a:ext cx="5120640" cy="438912"/>
-          </a:xfrm>
-          <a:prstGeom prst="rect">
-            <a:avLst/>
-          </a:prstGeom>
-          <a:solidFill>
-            <a:srgbClr val="EEF2FF"/>
-          </a:solidFill>
-          <a:ln w="12700">
-            <a:solidFill>
-              <a:srgbClr val="E0E7FF"/>
-            </a:solidFill>
-            <a:prstDash val="solid"/>
-          </a:ln>
-        </p:spPr>
-      </p:sp>
-      <p:sp>
-        <p:nvSpPr>
-          <p:cNvPr id="22" name="Shape 20"/>
-          <p:cNvSpPr/>
-          <p:nvPr/>
-        </p:nvSpPr>
-        <p:spPr>
-          <a:xfrm>
-            <a:off x="6373368" y="1956816"/>
-            <a:ext cx="73152" cy="274320"/>
           </a:xfrm>
           <a:prstGeom prst="rect">
             <a:avLst/>
@@ -12291,6 +12266,31 @@
       </p:sp>
       <p:sp>
         <p:nvSpPr>
+          <p:cNvPr id="22" name="Shape 20"/>
+          <p:cNvSpPr/>
+          <p:nvPr/>
+        </p:nvSpPr>
+        <p:spPr>
+          <a:xfrm>
+            <a:off x="6373368" y="1956816"/>
+            <a:ext cx="73152" cy="274320"/>
+          </a:xfrm>
+          <a:prstGeom prst="rect">
+            <a:avLst/>
+          </a:prstGeom>
+          <a:solidFill>
+            <a:srgbClr val="FFFFFF"/>
+          </a:solidFill>
+          <a:ln w="12700">
+            <a:solidFill>
+              <a:srgbClr val="FFFFFF"/>
+            </a:solidFill>
+            <a:prstDash val="solid"/>
+          </a:ln>
+        </p:spPr>
+      </p:sp>
+      <p:sp>
+        <p:nvSpPr>
           <p:cNvPr id="23" name="Text 21"/>
           <p:cNvSpPr/>
           <p:nvPr/>
@@ -12316,7 +12316,7 @@
             <a:r>
               <a:rPr lang="en-US" sz="1800" b="1" dirty="0">
                 <a:solidFill>
-                  <a:srgbClr val="4F46E5"/>
+                  <a:srgbClr val="FFFFFF"/>
                 </a:solidFill>
                 <a:latin typeface="Pretendard" pitchFamily="34" charset="0"/>
                 <a:ea typeface="Pretendard" pitchFamily="34" charset="-122"/>

</xml_diff>

<commit_message>
feat: polish ai-deck-compiler showcase deck
</commit_message>
<xml_diff>
--- a/examples/results/showcase-modern-light.pptx
+++ b/examples/results/showcase-modern-light.pptx
@@ -145,7 +145,7 @@
               <c:strCache>
                 <c:ptCount val="1"/>
                 <c:pt idx="0">
-                  <c:v>Commits by day</c:v>
+                  <c:v>Non-merge commits</c:v>
                 </c:pt>
               </c:strCache>
             </c:strRef>
@@ -240,13 +240,13 @@
                 <c:formatCode>General</c:formatCode>
                 <c:ptCount val="3"/>
                 <c:pt idx="0">
+                  <c:v>1</c:v>
+                </c:pt>
+                <c:pt idx="1">
                   <c:v>24</c:v>
                 </c:pt>
-                <c:pt idx="1">
-                  <c:v>33</c:v>
-                </c:pt>
                 <c:pt idx="2">
-                  <c:v>9</c:v>
+                  <c:v>23</c:v>
                 </c:pt>
               </c:numCache>
             </c:numRef>
@@ -405,7 +405,9 @@
     <c:autoTitleDeleted val="1"/>
     <c:plotArea>
       <c:layout/>
-      <c:lineChart>
+      <c:barChart>
+        <c:barDir val="col"/>
+        <c:grouping val="clustered"/>
         <c:varyColors val="0"/>
         <c:ser>
           <c:idx val="0"/>
@@ -416,7 +418,7 @@
               <c:strCache>
                 <c:ptCount val="1"/>
                 <c:pt idx="0">
-                  <c:v>Cleanup load index</c:v>
+                  <c:v>Local LOC</c:v>
                 </c:pt>
               </c:strCache>
             </c:strRef>
@@ -425,13 +427,6 @@
             <a:solidFill>
               <a:srgbClr val="4F46E5"/>
             </a:solidFill>
-            <a:ln w="25400" cap="flat">
-              <a:solidFill>
-                <a:srgbClr val="4F46E5"/>
-              </a:solidFill>
-              <a:prstDash val="solid"/>
-              <a:round/>
-            </a:ln>
             <a:effectLst/>
           </c:spPr>
           <c:invertIfNegative val="0"/>
@@ -459,23 +454,50 @@
             <c:showBubbleSize val="0"/>
             <c:showLeaderLines val="0"/>
           </c:dLbls>
-          <c:marker>
-            <c:symbol val="circle"/>
-            <c:size val="6"/>
+          <c:dPt>
+            <c:idx val="0"/>
+            <c:invertIfNegative val="0"/>
+            <c:bubble3D val="0"/>
             <c:spPr>
               <a:solidFill>
                 <a:srgbClr val="4F46E5"/>
               </a:solidFill>
-              <a:ln w="9525" cap="flat">
-                <a:solidFill>
-                  <a:srgbClr val="4F46E5"/>
-                </a:solidFill>
-                <a:prstDash val="solid"/>
-                <a:round/>
-              </a:ln>
               <a:effectLst/>
             </c:spPr>
-          </c:marker>
+          </c:dPt>
+          <c:dPt>
+            <c:idx val="1"/>
+            <c:invertIfNegative val="0"/>
+            <c:bubble3D val="0"/>
+            <c:spPr>
+              <a:solidFill>
+                <a:srgbClr val="7C3AED"/>
+              </a:solidFill>
+              <a:effectLst/>
+            </c:spPr>
+          </c:dPt>
+          <c:dPt>
+            <c:idx val="2"/>
+            <c:invertIfNegative val="0"/>
+            <c:bubble3D val="0"/>
+            <c:spPr>
+              <a:solidFill>
+                <a:srgbClr val="059669"/>
+              </a:solidFill>
+              <a:effectLst/>
+            </c:spPr>
+          </c:dPt>
+          <c:dPt>
+            <c:idx val="3"/>
+            <c:invertIfNegative val="0"/>
+            <c:bubble3D val="0"/>
+            <c:spPr>
+              <a:solidFill>
+                <a:srgbClr val="DC2626"/>
+              </a:solidFill>
+              <a:effectLst/>
+            </c:spPr>
+          </c:dPt>
           <c:cat>
             <c:multiLvlStrRef>
               <c:f>Sheet1!$A$2:$A$5</c:f>
@@ -483,16 +505,16 @@
                 <c:ptCount val="4"/>
                 <c:lvl>
                   <c:pt idx="0">
-                    <c:v>Draft</c:v>
+                    <c:v>Engine src</c:v>
                   </c:pt>
                   <c:pt idx="1">
-                    <c:v>Review</c:v>
+                    <c:v>AI skills</c:v>
                   </c:pt>
                   <c:pt idx="2">
-                    <c:v>Preview</c:v>
+                    <c:v>Examples</c:v>
                   </c:pt>
                   <c:pt idx="3">
-                    <c:v>Final</c:v>
+                    <c:v>Tests</c:v>
                   </c:pt>
                 </c:lvl>
               </c:multiLvlStrCache>
@@ -505,21 +527,20 @@
                 <c:formatCode>General</c:formatCode>
                 <c:ptCount val="4"/>
                 <c:pt idx="0">
-                  <c:v>100</c:v>
+                  <c:v>4725</c:v>
                 </c:pt>
                 <c:pt idx="1">
-                  <c:v>64</c:v>
+                  <c:v>1695</c:v>
                 </c:pt>
                 <c:pt idx="2">
-                  <c:v>38</c:v>
+                  <c:v>1675</c:v>
                 </c:pt>
                 <c:pt idx="3">
-                  <c:v>20</c:v>
+                  <c:v>901</c:v>
                 </c:pt>
               </c:numCache>
             </c:numRef>
           </c:val>
-          <c:smooth val="0"/>
         </c:ser>
         <c:dLbls>
           <c:numFmt formatCode="#,##0" sourceLinked="0"/>
@@ -545,11 +566,12 @@
           <c:showBubbleSize val="0"/>
           <c:showLeaderLines val="0"/>
         </c:dLbls>
-        <c:marker val="1"/>
+        <c:gapWidth val="150"/>
+        <c:overlap val="0"/>
         <c:axId val="2094734554"/>
         <c:axId val="2094734552"/>
         <c:axId val="2094734556"/>
-      </c:lineChart>
+      </c:barChart>
       <c:catAx>
         <c:axId val="2094734554"/>
         <c:scaling>
@@ -2989,7 +3011,7 @@
                 <a:ea typeface="Pretendard" pitchFamily="34" charset="-122"/>
                 <a:cs typeface="Pretendard" pitchFamily="34" charset="-120"/>
               </a:rPr>
-              <a:t>v1.0</a:t>
+              <a:t>v1.1</a:t>
             </a:r>
             <a:endParaRPr lang="en-US" sz="1200" dirty="0"/>
           </a:p>
@@ -3092,7 +3114,7 @@
                 <a:ea typeface="Pretendard" pitchFamily="34" charset="-122"/>
                 <a:cs typeface="Pretendard" pitchFamily="34" charset="-120"/>
               </a:rPr>
-              <a:t>자연어를 의미 기반 blueprint로 바꾸고, editable PPTX로 컴파일한다</a:t>
+              <a:t>AI가 기획한 의미 구조를 editable PowerPoint로 컴파일하는 presentation engine</a:t>
             </a:r>
             <a:endParaRPr lang="en-US" sz="2400" dirty="0"/>
           </a:p>
@@ -3131,7 +3153,7 @@
                 <a:ea typeface="Pretendard" pitchFamily="34" charset="-122"/>
                 <a:cs typeface="Pretendard" pitchFamily="34" charset="-120"/>
               </a:rPr>
-              <a:t>Semantic Blueprint Planning · Editable PowerPoint · Preset System</a:t>
+              <a:t>Semantic Blueprint Planning · Deterministic Rendering · Preset Showcase</a:t>
             </a:r>
             <a:endParaRPr lang="en-US" sz="1200" dirty="0"/>
           </a:p>
@@ -3547,7 +3569,7 @@
                 <a:ea typeface="Pretendard" pitchFamily="34" charset="-122"/>
                 <a:cs typeface="Pretendard" pitchFamily="34" charset="-120"/>
               </a:rPr>
-              <a:t>Planning과 rendering을 분리한다</a:t>
+              <a:t>AI planning과 deterministic rendering을 분리한다</a:t>
             </a:r>
             <a:endParaRPr lang="en-US" sz="4000" dirty="0"/>
           </a:p>
@@ -3698,7 +3720,7 @@
                 <a:ea typeface="Pretendard" pitchFamily="34" charset="-122"/>
                 <a:cs typeface="Pretendard" pitchFamily="34" charset="-120"/>
               </a:rPr>
-              <a:t>plan</a:t>
+              <a:t>narrative + schema</a:t>
             </a:r>
             <a:endParaRPr lang="en-US" sz="1000" dirty="0"/>
           </a:p>
@@ -3761,7 +3783,7 @@
                 <a:ea typeface="Pretendard" pitchFamily="34" charset="-122"/>
                 <a:cs typeface="Pretendard" pitchFamily="34" charset="-120"/>
               </a:rPr>
-              <a:t>schema</a:t>
+              <a:t>validated DSL</a:t>
             </a:r>
             <a:endParaRPr lang="en-US" sz="1000" dirty="0"/>
           </a:p>
@@ -3824,7 +3846,7 @@
                 <a:ea typeface="Pretendard" pitchFamily="34" charset="-122"/>
                 <a:cs typeface="Pretendard" pitchFamily="34" charset="-120"/>
               </a:rPr>
-              <a:t>design</a:t>
+              <a:t>design system</a:t>
             </a:r>
             <a:endParaRPr lang="en-US" sz="1000" dirty="0"/>
           </a:p>
@@ -3887,7 +3909,7 @@
                 <a:ea typeface="Pretendard" pitchFamily="34" charset="-122"/>
                 <a:cs typeface="Pretendard" pitchFamily="34" charset="-120"/>
               </a:rPr>
-              <a:t>render</a:t>
+              <a:t>shapes + charts + text</a:t>
             </a:r>
             <a:endParaRPr lang="en-US" sz="1000" dirty="0"/>
           </a:p>
@@ -4015,7 +4037,7 @@
                 <a:ea typeface="Pretendard" pitchFamily="34" charset="-122"/>
                 <a:cs typeface="Pretendard" pitchFamily="34" charset="-120"/>
               </a:rPr>
-              <a:t>create-deck</a:t>
+              <a:t>create-deck Skill</a:t>
             </a:r>
             <a:endParaRPr lang="en-US" sz="1100" dirty="0"/>
           </a:p>
@@ -4207,7 +4229,7 @@
                 <a:ea typeface="Pretendard" pitchFamily="34" charset="-122"/>
                 <a:cs typeface="Pretendard" pitchFamily="34" charset="-120"/>
               </a:rPr>
-              <a:t>Compiler</a:t>
+              <a:t>Compiler + Registry</a:t>
             </a:r>
             <a:endParaRPr lang="en-US" sz="1100" dirty="0"/>
           </a:p>
@@ -4486,7 +4508,7 @@
                 <a:ea typeface="Pretendard" pitchFamily="34" charset="-122"/>
                 <a:cs typeface="Pretendard" pitchFamily="34" charset="-120"/>
               </a:rPr>
-              <a:t>작성과 검토를 하나의 루프로 묶는다</a:t>
+              <a:t>작성과 검토는 preview gate를 통과하며 반복된다</a:t>
             </a:r>
             <a:endParaRPr lang="en-US" sz="4000" dirty="0"/>
           </a:p>
@@ -4543,7 +4565,46 @@
       </p:sp>
       <p:sp>
         <p:nvSpPr>
-          <p:cNvPr id="7" name="Shape 5"/>
+          <p:cNvPr id="7" name="Text 5"/>
+          <p:cNvSpPr/>
+          <p:nvPr/>
+        </p:nvSpPr>
+        <p:spPr>
+          <a:xfrm>
+            <a:off x="3797808" y="3108960"/>
+            <a:ext cx="1097280" cy="274320"/>
+          </a:xfrm>
+          <a:prstGeom prst="rect">
+            <a:avLst/>
+          </a:prstGeom>
+          <a:noFill/>
+          <a:ln/>
+        </p:spPr>
+        <p:txBody>
+          <a:bodyPr wrap="square" rtlCol="0" anchor="ctr"/>
+          <a:lstStyle/>
+          <a:p>
+            <a:pPr algn="ctr" indent="0" marL="0">
+              <a:buNone/>
+            </a:pPr>
+            <a:r>
+              <a:rPr lang="en-US" sz="1000" dirty="0">
+                <a:solidFill>
+                  <a:srgbClr val="6B7280"/>
+                </a:solidFill>
+                <a:latin typeface="Pretendard" pitchFamily="34" charset="0"/>
+                <a:ea typeface="Pretendard" pitchFamily="34" charset="-122"/>
+                <a:cs typeface="Pretendard" pitchFamily="34" charset="-120"/>
+              </a:rPr>
+              <a:t>align</a:t>
+            </a:r>
+            <a:endParaRPr lang="en-US" sz="1000" dirty="0"/>
+          </a:p>
+        </p:txBody>
+      </p:sp>
+      <p:sp>
+        <p:nvSpPr>
+          <p:cNvPr id="8" name="Shape 6"/>
           <p:cNvSpPr/>
           <p:nvPr/>
         </p:nvSpPr>
@@ -4567,7 +4628,46 @@
       </p:sp>
       <p:sp>
         <p:nvSpPr>
-          <p:cNvPr id="8" name="Shape 6"/>
+          <p:cNvPr id="9" name="Text 7"/>
+          <p:cNvSpPr/>
+          <p:nvPr/>
+        </p:nvSpPr>
+        <p:spPr>
+          <a:xfrm>
+            <a:off x="5550408" y="3108960"/>
+            <a:ext cx="1097280" cy="274320"/>
+          </a:xfrm>
+          <a:prstGeom prst="rect">
+            <a:avLst/>
+          </a:prstGeom>
+          <a:noFill/>
+          <a:ln/>
+        </p:spPr>
+        <p:txBody>
+          <a:bodyPr wrap="square" rtlCol="0" anchor="ctr"/>
+          <a:lstStyle/>
+          <a:p>
+            <a:pPr algn="ctr" indent="0" marL="0">
+              <a:buNone/>
+            </a:pPr>
+            <a:r>
+              <a:rPr lang="en-US" sz="1000" dirty="0">
+                <a:solidFill>
+                  <a:srgbClr val="6B7280"/>
+                </a:solidFill>
+                <a:latin typeface="Pretendard" pitchFamily="34" charset="0"/>
+                <a:ea typeface="Pretendard" pitchFamily="34" charset="-122"/>
+                <a:cs typeface="Pretendard" pitchFamily="34" charset="-120"/>
+              </a:rPr>
+              <a:t>write</a:t>
+            </a:r>
+            <a:endParaRPr lang="en-US" sz="1000" dirty="0"/>
+          </a:p>
+        </p:txBody>
+      </p:sp>
+      <p:sp>
+        <p:nvSpPr>
+          <p:cNvPr id="10" name="Shape 8"/>
           <p:cNvSpPr/>
           <p:nvPr/>
         </p:nvSpPr>
@@ -4591,7 +4691,46 @@
       </p:sp>
       <p:sp>
         <p:nvSpPr>
-          <p:cNvPr id="9" name="Shape 7"/>
+          <p:cNvPr id="11" name="Text 9"/>
+          <p:cNvSpPr/>
+          <p:nvPr/>
+        </p:nvSpPr>
+        <p:spPr>
+          <a:xfrm>
+            <a:off x="7303008" y="3817620"/>
+            <a:ext cx="1097280" cy="274320"/>
+          </a:xfrm>
+          <a:prstGeom prst="rect">
+            <a:avLst/>
+          </a:prstGeom>
+          <a:noFill/>
+          <a:ln/>
+        </p:spPr>
+        <p:txBody>
+          <a:bodyPr wrap="square" rtlCol="0" anchor="ctr"/>
+          <a:lstStyle/>
+          <a:p>
+            <a:pPr algn="ctr" indent="0" marL="0">
+              <a:buNone/>
+            </a:pPr>
+            <a:r>
+              <a:rPr lang="en-US" sz="1000" dirty="0">
+                <a:solidFill>
+                  <a:srgbClr val="6B7280"/>
+                </a:solidFill>
+                <a:latin typeface="Pretendard" pitchFamily="34" charset="0"/>
+                <a:ea typeface="Pretendard" pitchFamily="34" charset="-122"/>
+                <a:cs typeface="Pretendard" pitchFamily="34" charset="-120"/>
+              </a:rPr>
+              <a:t>compile</a:t>
+            </a:r>
+            <a:endParaRPr lang="en-US" sz="1000" dirty="0"/>
+          </a:p>
+        </p:txBody>
+      </p:sp>
+      <p:sp>
+        <p:nvSpPr>
+          <p:cNvPr id="12" name="Shape 10"/>
           <p:cNvSpPr/>
           <p:nvPr/>
         </p:nvSpPr>
@@ -4615,7 +4754,7 @@
       </p:sp>
       <p:sp>
         <p:nvSpPr>
-          <p:cNvPr id="10" name="Shape 8"/>
+          <p:cNvPr id="13" name="Shape 11"/>
           <p:cNvSpPr/>
           <p:nvPr/>
         </p:nvSpPr>
@@ -4639,7 +4778,46 @@
       </p:sp>
       <p:sp>
         <p:nvSpPr>
-          <p:cNvPr id="11" name="Shape 9"/>
+          <p:cNvPr id="14" name="Text 12"/>
+          <p:cNvSpPr/>
+          <p:nvPr/>
+        </p:nvSpPr>
+        <p:spPr>
+          <a:xfrm>
+            <a:off x="7303008" y="5234940"/>
+            <a:ext cx="1097280" cy="274320"/>
+          </a:xfrm>
+          <a:prstGeom prst="rect">
+            <a:avLst/>
+          </a:prstGeom>
+          <a:noFill/>
+          <a:ln/>
+        </p:spPr>
+        <p:txBody>
+          <a:bodyPr wrap="square" rtlCol="0" anchor="ctr"/>
+          <a:lstStyle/>
+          <a:p>
+            <a:pPr algn="ctr" indent="0" marL="0">
+              <a:buNone/>
+            </a:pPr>
+            <a:r>
+              <a:rPr lang="en-US" sz="1000" dirty="0">
+                <a:solidFill>
+                  <a:srgbClr val="6B7280"/>
+                </a:solidFill>
+                <a:latin typeface="Pretendard" pitchFamily="34" charset="0"/>
+                <a:ea typeface="Pretendard" pitchFamily="34" charset="-122"/>
+                <a:cs typeface="Pretendard" pitchFamily="34" charset="-120"/>
+              </a:rPr>
+              <a:t>inspect</a:t>
+            </a:r>
+            <a:endParaRPr lang="en-US" sz="1000" dirty="0"/>
+          </a:p>
+        </p:txBody>
+      </p:sp>
+      <p:sp>
+        <p:nvSpPr>
+          <p:cNvPr id="15" name="Shape 13"/>
           <p:cNvSpPr/>
           <p:nvPr/>
         </p:nvSpPr>
@@ -4663,7 +4841,7 @@
       </p:sp>
       <p:sp>
         <p:nvSpPr>
-          <p:cNvPr id="12" name="Shape 10"/>
+          <p:cNvPr id="16" name="Shape 14"/>
           <p:cNvSpPr/>
           <p:nvPr/>
         </p:nvSpPr>
@@ -4688,7 +4866,7 @@
       </p:sp>
       <p:sp>
         <p:nvSpPr>
-          <p:cNvPr id="13" name="Text 11"/>
+          <p:cNvPr id="17" name="Text 15"/>
           <p:cNvSpPr/>
           <p:nvPr/>
         </p:nvSpPr>
@@ -4719,7 +4897,7 @@
                 <a:ea typeface="Pretendard" pitchFamily="34" charset="-122"/>
                 <a:cs typeface="Pretendard" pitchFamily="34" charset="-120"/>
               </a:rPr>
-              <a:t>Brief</a:t>
+              <a:t>Brief or Source</a:t>
             </a:r>
             <a:endParaRPr lang="en-US" sz="1100" dirty="0"/>
           </a:p>
@@ -4727,7 +4905,7 @@
       </p:sp>
       <p:sp>
         <p:nvSpPr>
-          <p:cNvPr id="14" name="Shape 12"/>
+          <p:cNvPr id="18" name="Shape 16"/>
           <p:cNvSpPr/>
           <p:nvPr/>
         </p:nvSpPr>
@@ -4752,7 +4930,7 @@
       </p:sp>
       <p:sp>
         <p:nvSpPr>
-          <p:cNvPr id="15" name="Text 13"/>
+          <p:cNvPr id="19" name="Text 17"/>
           <p:cNvSpPr/>
           <p:nvPr/>
         </p:nvSpPr>
@@ -4791,7 +4969,7 @@
       </p:sp>
       <p:sp>
         <p:nvSpPr>
-          <p:cNvPr id="16" name="Shape 14"/>
+          <p:cNvPr id="20" name="Shape 18"/>
           <p:cNvSpPr/>
           <p:nvPr/>
         </p:nvSpPr>
@@ -4816,7 +4994,7 @@
       </p:sp>
       <p:sp>
         <p:nvSpPr>
-          <p:cNvPr id="17" name="Text 15"/>
+          <p:cNvPr id="21" name="Text 19"/>
           <p:cNvSpPr/>
           <p:nvPr/>
         </p:nvSpPr>
@@ -4847,7 +5025,7 @@
                 <a:ea typeface="Pretendard" pitchFamily="34" charset="-122"/>
                 <a:cs typeface="Pretendard" pitchFamily="34" charset="-120"/>
               </a:rPr>
-              <a:t>Blueprint</a:t>
+              <a:t>Blueprint Draft</a:t>
             </a:r>
             <a:endParaRPr lang="en-US" sz="1100" dirty="0"/>
           </a:p>
@@ -4855,7 +5033,7 @@
       </p:sp>
       <p:sp>
         <p:nvSpPr>
-          <p:cNvPr id="18" name="Shape 16"/>
+          <p:cNvPr id="22" name="Shape 20"/>
           <p:cNvSpPr/>
           <p:nvPr/>
         </p:nvSpPr>
@@ -4880,7 +5058,7 @@
       </p:sp>
       <p:sp>
         <p:nvSpPr>
-          <p:cNvPr id="19" name="Text 17"/>
+          <p:cNvPr id="23" name="Text 21"/>
           <p:cNvSpPr/>
           <p:nvPr/>
         </p:nvSpPr>
@@ -4919,7 +5097,7 @@
       </p:sp>
       <p:sp>
         <p:nvSpPr>
-          <p:cNvPr id="20" name="Shape 18"/>
+          <p:cNvPr id="24" name="Shape 22"/>
           <p:cNvSpPr/>
           <p:nvPr/>
         </p:nvSpPr>
@@ -4944,7 +5122,7 @@
       </p:sp>
       <p:sp>
         <p:nvSpPr>
-          <p:cNvPr id="21" name="Text 19"/>
+          <p:cNvPr id="25" name="Text 23"/>
           <p:cNvSpPr/>
           <p:nvPr/>
         </p:nvSpPr>
@@ -4975,7 +5153,7 @@
                 <a:ea typeface="Pretendard" pitchFamily="34" charset="-122"/>
                 <a:cs typeface="Pretendard" pitchFamily="34" charset="-120"/>
               </a:rPr>
-              <a:t>Preview</a:t>
+              <a:t>Preview PNGs</a:t>
             </a:r>
             <a:endParaRPr lang="en-US" sz="1100" dirty="0"/>
           </a:p>
@@ -4983,7 +5161,7 @@
       </p:sp>
       <p:sp>
         <p:nvSpPr>
-          <p:cNvPr id="22" name="Shape 20"/>
+          <p:cNvPr id="26" name="Shape 24"/>
           <p:cNvSpPr/>
           <p:nvPr/>
         </p:nvSpPr>
@@ -5008,7 +5186,7 @@
       </p:sp>
       <p:sp>
         <p:nvSpPr>
-          <p:cNvPr id="23" name="Text 21"/>
+          <p:cNvPr id="27" name="Text 25"/>
           <p:cNvSpPr/>
           <p:nvPr/>
         </p:nvSpPr>
@@ -5047,7 +5225,7 @@
       </p:sp>
       <p:sp>
         <p:nvSpPr>
-          <p:cNvPr id="24" name="Text 22"/>
+          <p:cNvPr id="28" name="Text 26"/>
           <p:cNvSpPr/>
           <p:nvPr/>
         </p:nvSpPr>
@@ -5086,7 +5264,7 @@
       </p:sp>
       <p:sp>
         <p:nvSpPr>
-          <p:cNvPr id="25" name="Text 23"/>
+          <p:cNvPr id="29" name="Text 27"/>
           <p:cNvSpPr/>
           <p:nvPr/>
         </p:nvSpPr>
@@ -5254,7 +5432,7 @@
                 <a:ea typeface="Pretendard" pitchFamily="34" charset="-122"/>
                 <a:cs typeface="Pretendard" pitchFamily="34" charset="-120"/>
               </a:rPr>
-              <a:t>같은 구조를 다른 톤으로 바꾼다</a:t>
+              <a:t>같은 content, 세 가지 presentation tone</a:t>
             </a:r>
             <a:endParaRPr lang="en-US" sz="4000" dirty="0"/>
           </a:p>
@@ -5467,7 +5645,7 @@
                           <a:ea typeface="Pretendard" pitchFamily="34" charset="-122"/>
                           <a:cs typeface="Pretendard" pitchFamily="34" charset="-120"/>
                         </a:rPr>
-                        <a:t>Use case</a:t>
+                        <a:t>Best fit</a:t>
                       </a:r>
                       <a:endParaRPr lang="en-US" sz="1400" dirty="0">
                         <a:latin typeface="Pretendard" charset="0"/>
@@ -5535,7 +5713,7 @@
                           <a:ea typeface="Pretendard" pitchFamily="34" charset="-122"/>
                           <a:cs typeface="Pretendard" pitchFamily="34" charset="-120"/>
                         </a:rPr>
-                        <a:t>Signal</a:t>
+                        <a:t>What this showcase proves</a:t>
                       </a:r>
                       <a:endParaRPr lang="en-US" sz="1400" dirty="0">
                         <a:latin typeface="Pretendard" charset="0"/>
@@ -5741,7 +5919,7 @@
                           <a:ea typeface="Pretendard" pitchFamily="34" charset="-122"/>
                           <a:cs typeface="Pretendard" pitchFamily="34" charset="-120"/>
                         </a:rPr>
-                        <a:t>AI workflow 기본 추천</a:t>
+                        <a:t>AI-native technical briefing</a:t>
                       </a:r>
                       <a:endParaRPr lang="en-US" sz="1300" dirty="0">
                         <a:latin typeface="Pretendard" charset="0"/>
@@ -5809,7 +5987,7 @@
                           <a:ea typeface="Pretendard" pitchFamily="34" charset="-122"/>
                           <a:cs typeface="Pretendard" pitchFamily="34" charset="-120"/>
                         </a:rPr>
-                        <a:t>차분한 technical executive tone</a:t>
+                        <a:t>차분한 executive tone과 callout bar</a:t>
                       </a:r>
                       <a:endParaRPr lang="en-US" sz="1300" dirty="0">
                         <a:latin typeface="Pretendard" charset="0"/>
@@ -6015,7 +6193,7 @@
                           <a:ea typeface="Pretendard" pitchFamily="34" charset="-122"/>
                           <a:cs typeface="Pretendard" pitchFamily="34" charset="-120"/>
                         </a:rPr>
-                        <a:t>제품 데모와 feature showcase</a:t>
+                        <a:t>Product demo / feature showcase</a:t>
                       </a:r>
                       <a:endParaRPr lang="en-US" sz="1300" dirty="0">
                         <a:latin typeface="Pretendard" charset="0"/>
@@ -6083,7 +6261,7 @@
                           <a:ea typeface="Pretendard" pitchFamily="34" charset="-122"/>
                           <a:cs typeface="Pretendard" pitchFamily="34" charset="-120"/>
                         </a:rPr>
-                        <a:t>강한 accent와 callout bar</a:t>
+                        <a:t>강한 contrast와 vivid accent</a:t>
                       </a:r>
                       <a:endParaRPr lang="en-US" sz="1300" dirty="0">
                         <a:latin typeface="Pretendard" charset="0"/>
@@ -6289,7 +6467,7 @@
                           <a:ea typeface="Pretendard" pitchFamily="34" charset="-122"/>
                           <a:cs typeface="Pretendard" pitchFamily="34" charset="-120"/>
                         </a:rPr>
-                        <a:t>비즈니스 보고와 공유 문서</a:t>
+                        <a:t>Business report / sharing doc</a:t>
                       </a:r>
                       <a:endParaRPr lang="en-US" sz="1300" dirty="0">
                         <a:latin typeface="Pretendard" charset="0"/>
@@ -6357,7 +6535,7 @@
                           <a:ea typeface="Pretendard" pitchFamily="34" charset="-122"/>
                           <a:cs typeface="Pretendard" pitchFamily="34" charset="-120"/>
                         </a:rPr>
-                        <a:t>밝고 보수적인 office tone</a:t>
+                        <a:t>office-friendly light document tone</a:t>
                       </a:r>
                       <a:endParaRPr lang="en-US" sz="1300" dirty="0">
                         <a:latin typeface="Pretendard" charset="0"/>
@@ -6622,7 +6800,7 @@
                 <a:ea typeface="Pretendard" pitchFamily="34" charset="-122"/>
                 <a:cs typeface="Pretendard" pitchFamily="34" charset="-120"/>
               </a:rPr>
-              <a:t>짧은 주기로 품질을 쌓았다</a:t>
+              <a:t>3일의 작업은 기능보다 workflow 완성에 집중됐다</a:t>
             </a:r>
             <a:endParaRPr lang="en-US" sz="4000" dirty="0"/>
           </a:p>
@@ -6796,7 +6974,7 @@
                 <a:ea typeface="Pretendard" pitchFamily="34" charset="-122"/>
                 <a:cs typeface="Pretendard" pitchFamily="34" charset="-120"/>
               </a:rPr>
-              <a:t>Compiler baseline</a:t>
+              <a:t>Engine baseline</a:t>
             </a:r>
             <a:endParaRPr lang="en-US" sz="1600" dirty="0"/>
           </a:p>
@@ -6835,7 +7013,7 @@
                 <a:ea typeface="Pretendard" pitchFamily="34" charset="-122"/>
                 <a:cs typeface="Pretendard" pitchFamily="34" charset="-120"/>
               </a:rPr>
-              <a:t>blueprint schema, renderer, CLI, metadata 기반 구축</a:t>
+              <a:t>schema, renderer, CLI, metadata, preview 기반을 만들었다.</a:t>
             </a:r>
             <a:endParaRPr lang="en-US" sz="1200" dirty="0"/>
           </a:p>
@@ -6961,7 +7139,7 @@
                 <a:ea typeface="Pretendard" pitchFamily="34" charset="-122"/>
                 <a:cs typeface="Pretendard" pitchFamily="34" charset="-120"/>
               </a:rPr>
-              <a:t>Workflow expansion</a:t>
+              <a:t>AI workflow</a:t>
             </a:r>
             <a:endParaRPr lang="en-US" sz="1600" dirty="0"/>
           </a:p>
@@ -7000,7 +7178,7 @@
                 <a:ea typeface="Pretendard" pitchFamily="34" charset="-122"/>
                 <a:cs typeface="Pretendard" pitchFamily="34" charset="-120"/>
               </a:rPr>
-              <a:t>create/review/export skills, examples, architecture slide 강화</a:t>
+              <a:t>create/review/export skills와 사용자·시스템 문서를 정렬했다.</a:t>
             </a:r>
             <a:endParaRPr lang="en-US" sz="1200" dirty="0"/>
           </a:p>
@@ -7126,7 +7304,7 @@
                 <a:ea typeface="Pretendard" pitchFamily="34" charset="-122"/>
                 <a:cs typeface="Pretendard" pitchFamily="34" charset="-120"/>
               </a:rPr>
-              <a:t>Preset system</a:t>
+              <a:t>Public proof</a:t>
             </a:r>
             <a:endParaRPr lang="en-US" sz="1600" dirty="0"/>
           </a:p>
@@ -7165,7 +7343,7 @@
                 <a:ea typeface="Pretendard" pitchFamily="34" charset="-122"/>
                 <a:cs typeface="Pretendard" pitchFamily="34" charset="-120"/>
               </a:rPr>
-              <a:t>teal/vivid/modern, results tracking, semantic planning 강화</a:t>
+              <a:t>presets, semantic planning, code block, showcase artifacts를 다듬었다.</a:t>
             </a:r>
             <a:endParaRPr lang="en-US" sz="1200" dirty="0"/>
           </a:p>
@@ -7252,7 +7430,7 @@
                 <a:ea typeface="Pretendard" pitchFamily="34" charset="-122"/>
                 <a:cs typeface="Pretendard" pitchFamily="34" charset="-120"/>
               </a:rPr>
-              <a:t>Now</a:t>
+              <a:t>Next</a:t>
             </a:r>
             <a:endParaRPr lang="en-US" sz="1100" dirty="0"/>
           </a:p>
@@ -7291,7 +7469,7 @@
                 <a:ea typeface="Pretendard" pitchFamily="34" charset="-122"/>
                 <a:cs typeface="Pretendard" pitchFamily="34" charset="-120"/>
               </a:rPr>
-              <a:t>Showcase results</a:t>
+              <a:t>Release gate</a:t>
             </a:r>
             <a:endParaRPr lang="en-US" sz="1600" dirty="0"/>
           </a:p>
@@ -7330,7 +7508,7 @@
                 <a:ea typeface="Pretendard" pitchFamily="34" charset="-122"/>
                 <a:cs typeface="Pretendard" pitchFamily="34" charset="-120"/>
               </a:rPr>
-              <a:t>제품 소개 deck을 examples/results 대표 산출물로 승격</a:t>
+              <a:t>AI tool simulation과 repo settings로 public 전환을 준비한다.</a:t>
             </a:r>
             <a:endParaRPr lang="en-US" sz="1200" dirty="0"/>
           </a:p>
@@ -7545,7 +7723,7 @@
                 <a:ea typeface="Pretendard" pitchFamily="34" charset="-122"/>
                 <a:cs typeface="Pretendard" pitchFamily="34" charset="-120"/>
               </a:rPr>
-              <a:t>대표 산출물은 제품을 보여줘야 한다</a:t>
+              <a:t>대표 예제는 제품 자체를 증명해야 한다</a:t>
             </a:r>
             <a:endParaRPr lang="en-US" sz="4000" dirty="0"/>
           </a:p>
@@ -7663,7 +7841,7 @@
                 <a:ea typeface="Pretendard" pitchFamily="34" charset="-122"/>
                 <a:cs typeface="Pretendard" pitchFamily="34" charset="-120"/>
               </a:rPr>
-              <a:t>Generic sample</a:t>
+              <a:t>Generic business sample</a:t>
             </a:r>
             <a:endParaRPr lang="en-US" sz="1400" dirty="0"/>
           </a:p>
@@ -7702,7 +7880,7 @@
                 <a:ea typeface="Pretendard" pitchFamily="34" charset="-122"/>
                 <a:cs typeface="Pretendard" pitchFamily="34" charset="-120"/>
               </a:rPr>
-              <a:t>✓  일반적인 비즈니스 deck처럼 읽기 쉽다</a:t>
+              <a:t>✓  누구나 익숙한 주제로 읽기 쉽다</a:t>
             </a:r>
             <a:endParaRPr lang="en-US" sz="1300" dirty="0"/>
           </a:p>
@@ -7741,7 +7919,7 @@
                 <a:ea typeface="Pretendard" pitchFamily="34" charset="-122"/>
                 <a:cs typeface="Pretendard" pitchFamily="34" charset="-120"/>
               </a:rPr>
-              <a:t>✓  도메인 지식 없이 빠르게 이해된다</a:t>
+              <a:t>✓  도메인 설명 부담이 낮다</a:t>
             </a:r>
             <a:endParaRPr lang="en-US" sz="1300" dirty="0"/>
           </a:p>
@@ -7803,7 +7981,7 @@
                 <a:ea typeface="Pretendard" pitchFamily="34" charset="-122"/>
                 <a:cs typeface="Pretendard" pitchFamily="34" charset="-120"/>
               </a:rPr>
-              <a:t>✗  제품의 실제 강점을 직접 보여주기 어렵다</a:t>
+              <a:t>✗  이 repo가 왜 필요한지 첫 화면에서 충분히 말하지 못한다</a:t>
             </a:r>
             <a:endParaRPr lang="en-US" sz="1300" dirty="0"/>
           </a:p>
@@ -7842,7 +8020,7 @@
                 <a:ea typeface="Pretendard" pitchFamily="34" charset="-122"/>
                 <a:cs typeface="Pretendard" pitchFamily="34" charset="-120"/>
               </a:rPr>
-              <a:t>✗  preset과 slide type coverage가 약하게 드러난다</a:t>
+              <a:t>✗  preset, slide type, code block, workflow 증거가 분산된다</a:t>
             </a:r>
             <a:endParaRPr lang="en-US" sz="1300" dirty="0"/>
           </a:p>
@@ -7935,7 +8113,7 @@
                 <a:ea typeface="Pretendard" pitchFamily="34" charset="-122"/>
                 <a:cs typeface="Pretendard" pitchFamily="34" charset="-120"/>
               </a:rPr>
-              <a:t>Product showcase</a:t>
+              <a:t>Product proof showcase</a:t>
             </a:r>
             <a:endParaRPr lang="en-US" sz="1400" dirty="0"/>
           </a:p>
@@ -7974,7 +8152,7 @@
                 <a:ea typeface="Pretendard" pitchFamily="34" charset="-122"/>
                 <a:cs typeface="Pretendard" pitchFamily="34" charset="-120"/>
               </a:rPr>
-              <a:t>✓  첫 화면에서 제품 가치를 바로 설명한다</a:t>
+              <a:t>✓  제품 메시지와 산출물 품질을 같은 deck에서 보여준다</a:t>
             </a:r>
             <a:endParaRPr lang="en-US" sz="1300" dirty="0"/>
           </a:p>
@@ -8013,7 +8191,7 @@
                 <a:ea typeface="Pretendard" pitchFamily="34" charset="-122"/>
                 <a:cs typeface="Pretendard" pitchFamily="34" charset="-120"/>
               </a:rPr>
-              <a:t>✓  preset 차이와 slide type coverage를 함께 보여준다</a:t>
+              <a:t>✓  chart, architecture, code block, preset 비교가 맥락 안에 놓인다</a:t>
             </a:r>
             <a:endParaRPr lang="en-US" sz="1300" dirty="0"/>
           </a:p>
@@ -8075,7 +8253,7 @@
                 <a:ea typeface="Pretendard" pitchFamily="34" charset="-122"/>
                 <a:cs typeface="Pretendard" pitchFamily="34" charset="-120"/>
               </a:rPr>
-              <a:t>✗  예제 자체의 메시지 설계가 더 중요해진다</a:t>
+              <a:t>✗  content 품질 기준이 일반 sample보다 높아진다</a:t>
             </a:r>
             <a:endParaRPr lang="en-US" sz="1300" dirty="0"/>
           </a:p>
@@ -8141,7 +8319,7 @@
                 <a:ea typeface="Pretendard" pitchFamily="34" charset="-122"/>
                 <a:cs typeface="Pretendard" pitchFamily="34" charset="-120"/>
               </a:rPr>
-              <a:t>► 대표 산출물은 제품 자체의 작성 경험과 결과 품질을 보여주는 showcase deck으로 둔다.</a:t>
+              <a:t>► examples/results는 generic sample이 아니라 ai-deck-compiler 자체를 설명하는 product proof artifact로 둔다.</a:t>
             </a:r>
             <a:endParaRPr lang="en-US" sz="1400" dirty="0"/>
           </a:p>
@@ -8356,7 +8534,7 @@
                 <a:ea typeface="Pretendard" pitchFamily="34" charset="-122"/>
                 <a:cs typeface="Pretendard" pitchFamily="34" charset="-120"/>
               </a:rPr>
-              <a:t>AI 판단과 안정적 출력의 결합</a:t>
+              <a:t>이 deck은 제품 설명이자 출력 품질 검증이다</a:t>
             </a:r>
             <a:endParaRPr lang="en-US" sz="4000" dirty="0"/>
           </a:p>
@@ -8424,7 +8602,7 @@
                 <a:ea typeface="Pretendard" pitchFamily="34" charset="-122"/>
                 <a:cs typeface="Pretendard" pitchFamily="34" charset="-120"/>
               </a:rPr>
-              <a:t>AI는 source를 읽고 slide type, component, emphasis를 선택한다.</a:t>
+              <a:t>AI는 발표 목적, 청중, source를 읽고 slide type과 강조 계층을 결정한다.</a:t>
             </a:r>
             <a:endParaRPr lang="en-US" sz="1600" dirty="0"/>
           </a:p>
@@ -8445,7 +8623,7 @@
                 <a:ea typeface="Pretendard" pitchFamily="34" charset="-122"/>
                 <a:cs typeface="Pretendard" pitchFamily="34" charset="-120"/>
               </a:rPr>
-              <a:t>Compiler는 blueprint와 preset token을 기반으로 재현 가능한 PPTX를 만든다.</a:t>
+              <a:t>Compiler는 blueprint와 preset token을 읽어 chart, table, diagram, code block을 PowerPoint 객체로 만든다.</a:t>
             </a:r>
             <a:endParaRPr lang="en-US" sz="1600" dirty="0"/>
           </a:p>
@@ -8466,7 +8644,7 @@
                 <a:ea typeface="Pretendard" pitchFamily="34" charset="-122"/>
                 <a:cs typeface="Pretendard" pitchFamily="34" charset="-120"/>
               </a:rPr>
-              <a:t>Preview와 review loop가 deck 품질을 사람이 확인할 수 있는 단계로 만든다.</a:t>
+              <a:t>Preview와 review loop는 “생성됨”에서 멈추지 않고 사람이 품질을 확인하는 단계로 만든다.</a:t>
             </a:r>
             <a:endParaRPr lang="en-US" sz="1600" dirty="0"/>
           </a:p>
@@ -8662,7 +8840,7 @@
                 <a:ea typeface="Pretendard" pitchFamily="34" charset="-122"/>
                 <a:cs typeface="Pretendard" pitchFamily="34" charset="-120"/>
               </a:rPr>
-              <a:t>자연어 요청을 편집 가능한 PowerPoint 구조로 바꾼다</a:t>
+              <a:t>자연어 요청은 검증 가능한 `blueprint.yaml`로 남는다</a:t>
             </a:r>
             <a:endParaRPr lang="en-US" sz="1400" dirty="0"/>
           </a:p>
@@ -8765,7 +8943,7 @@
                 <a:ea typeface="Pretendard" pitchFamily="34" charset="-122"/>
                 <a:cs typeface="Pretendard" pitchFamily="34" charset="-120"/>
               </a:rPr>
-              <a:t>같은 blueprint를 여러 preset으로 재사용할 수 있다</a:t>
+              <a:t>같은 구조를 teal, vivid, modern preset으로 재생성할 수 있다</a:t>
             </a:r>
             <a:endParaRPr lang="en-US" sz="1400" dirty="0"/>
           </a:p>
@@ -8868,7 +9046,7 @@
                 <a:ea typeface="Pretendard" pitchFamily="34" charset="-122"/>
                 <a:cs typeface="Pretendard" pitchFamily="34" charset="-120"/>
               </a:rPr>
-              <a:t>examples/results는 제품 기능을 보여주는 살아있는 showcase가 된다</a:t>
+              <a:t>showcase deck 자체가 public release 전 proof artifact가 된다</a:t>
             </a:r>
             <a:endParaRPr lang="en-US" sz="1400" dirty="0"/>
           </a:p>
@@ -9122,12 +9300,12 @@
         </p:nvSpPr>
         <p:spPr>
           <a:xfrm>
-            <a:off x="749808" y="1737360"/>
-            <a:ext cx="10698480" cy="1920240"/>
+            <a:off x="841248" y="1874520"/>
+            <a:ext cx="10515600" cy="1737360"/>
           </a:xfrm>
           <a:prstGeom prst="roundRect">
             <a:avLst>
-              <a:gd name="adj" fmla="val 2857"/>
+              <a:gd name="adj" fmla="val 3158"/>
             </a:avLst>
           </a:prstGeom>
           <a:solidFill>
@@ -9149,8 +9327,47 @@
         </p:nvSpPr>
         <p:spPr>
           <a:xfrm>
-            <a:off x="749808" y="1874520"/>
-            <a:ext cx="10698480" cy="1783080"/>
+            <a:off x="969264" y="1929384"/>
+            <a:ext cx="10259568" cy="164592"/>
+          </a:xfrm>
+          <a:prstGeom prst="rect">
+            <a:avLst/>
+          </a:prstGeom>
+          <a:noFill/>
+          <a:ln/>
+        </p:spPr>
+        <p:txBody>
+          <a:bodyPr wrap="square" rtlCol="0" anchor="ctr"/>
+          <a:lstStyle/>
+          <a:p>
+            <a:pPr indent="0" marL="0">
+              <a:buNone/>
+            </a:pPr>
+            <a:r>
+              <a:rPr lang="en-US" sz="800" b="1" dirty="0">
+                <a:solidFill>
+                  <a:srgbClr val="6B7280"/>
+                </a:solidFill>
+                <a:latin typeface="Pretendard" pitchFamily="34" charset="0"/>
+                <a:ea typeface="Pretendard" pitchFamily="34" charset="-122"/>
+                <a:cs typeface="Pretendard" pitchFamily="34" charset="-120"/>
+              </a:rPr>
+              <a:t>BASH</a:t>
+            </a:r>
+            <a:endParaRPr lang="en-US" sz="800" dirty="0"/>
+          </a:p>
+        </p:txBody>
+      </p:sp>
+      <p:sp>
+        <p:nvSpPr>
+          <p:cNvPr id="8" name="Text 6"/>
+          <p:cNvSpPr/>
+          <p:nvPr/>
+        </p:nvSpPr>
+        <p:spPr>
+          <a:xfrm>
+            <a:off x="969264" y="2203704"/>
+            <a:ext cx="10259568" cy="1280160"/>
           </a:xfrm>
           <a:prstGeom prst="rect">
             <a:avLst/>
@@ -9162,18 +9379,11 @@
           <a:bodyPr wrap="square" rtlCol="0" anchor="t"/>
           <a:lstStyle/>
           <a:p>
-            <a:pPr marL="190500" indent="-190500">
-              <a:spcBef>
-                <a:spcPts val="200"/>
-              </a:spcBef>
-              <a:spcAft>
-                <a:spcPts val="600"/>
-              </a:spcAft>
-              <a:buSzPct val="100000"/>
-              <a:buChar char="❯"/>
-            </a:pPr>
-            <a:r>
-              <a:rPr lang="en-US" sz="1200" dirty="0">
+            <a:pPr indent="0" marL="0">
+              <a:buNone/>
+            </a:pPr>
+            <a:r>
+              <a:rPr lang="en-US" sz="1100" dirty="0">
                 <a:solidFill>
                   <a:srgbClr val="4F46E5"/>
                 </a:solidFill>
@@ -9181,23 +9391,13 @@
                 <a:ea typeface="Courier New" pitchFamily="34" charset="-122"/>
                 <a:cs typeface="Courier New" pitchFamily="34" charset="-120"/>
               </a:rPr>
-              <a:t>npm run deck -- --blueprint examples/results/showcase-teal-dark.blueprint.yaml --output examples/results/showcase-teal-dark.pptx</a:t>
-            </a:r>
-            <a:endParaRPr lang="en-US" sz="1200" dirty="0"/>
-          </a:p>
-          <a:p>
-            <a:pPr marL="190500" indent="-190500">
-              <a:spcBef>
-                <a:spcPts val="200"/>
-              </a:spcBef>
-              <a:spcAft>
-                <a:spcPts val="600"/>
-              </a:spcAft>
-              <a:buSzPct val="100000"/>
-              <a:buChar char="❯"/>
-            </a:pPr>
-            <a:r>
-              <a:rPr lang="en-US" sz="1200" dirty="0">
+              <a:t>BP</a:t>
+            </a:r>
+            <a:pPr indent="0" marL="0">
+              <a:buNone/>
+            </a:pPr>
+            <a:r>
+              <a:rPr lang="en-US" sz="1100" dirty="0">
                 <a:solidFill>
                   <a:srgbClr val="4F46E5"/>
                 </a:solidFill>
@@ -9205,23 +9405,13 @@
                 <a:ea typeface="Courier New" pitchFamily="34" charset="-122"/>
                 <a:cs typeface="Courier New" pitchFamily="34" charset="-120"/>
               </a:rPr>
-              <a:t>npm run deck -- --blueprint examples/results/showcase-vivid-dark.blueprint.yaml --output examples/results/showcase-vivid-dark.pptx</a:t>
-            </a:r>
-            <a:endParaRPr lang="en-US" sz="1200" dirty="0"/>
-          </a:p>
-          <a:p>
-            <a:pPr marL="190500" indent="-190500">
-              <a:spcBef>
-                <a:spcPts val="200"/>
-              </a:spcBef>
-              <a:spcAft>
-                <a:spcPts val="600"/>
-              </a:spcAft>
-              <a:buSzPct val="100000"/>
-              <a:buChar char="❯"/>
-            </a:pPr>
-            <a:r>
-              <a:rPr lang="en-US" sz="1200" dirty="0">
+              <a:t>=</a:t>
+            </a:r>
+            <a:pPr indent="0" marL="0">
+              <a:buNone/>
+            </a:pPr>
+            <a:r>
+              <a:rPr lang="en-US" sz="1100" dirty="0">
                 <a:solidFill>
                   <a:srgbClr val="4F46E5"/>
                 </a:solidFill>
@@ -9229,23 +9419,13 @@
                 <a:ea typeface="Courier New" pitchFamily="34" charset="-122"/>
                 <a:cs typeface="Courier New" pitchFamily="34" charset="-120"/>
               </a:rPr>
-              <a:t>npm run deck -- --blueprint examples/results/showcase-modern-light.blueprint.yaml --output examples/results/showcase-modern-light.pptx</a:t>
-            </a:r>
-            <a:endParaRPr lang="en-US" sz="1200" dirty="0"/>
-          </a:p>
-          <a:p>
-            <a:pPr marL="190500" indent="-190500">
-              <a:spcBef>
-                <a:spcPts val="200"/>
-              </a:spcBef>
-              <a:spcAft>
-                <a:spcPts val="600"/>
-              </a:spcAft>
-              <a:buSzPct val="100000"/>
-              <a:buChar char="❯"/>
-            </a:pPr>
-            <a:r>
-              <a:rPr lang="en-US" sz="1200" dirty="0">
+              <a:t>examples</a:t>
+            </a:r>
+            <a:pPr indent="0" marL="0">
+              <a:buNone/>
+            </a:pPr>
+            <a:r>
+              <a:rPr lang="en-US" sz="1100" dirty="0">
                 <a:solidFill>
                   <a:srgbClr val="4F46E5"/>
                 </a:solidFill>
@@ -9253,22 +9433,1678 @@
                 <a:ea typeface="Courier New" pitchFamily="34" charset="-122"/>
                 <a:cs typeface="Courier New" pitchFamily="34" charset="-120"/>
               </a:rPr>
-              <a:t>npm run preview -- examples/results/showcase-teal-dark.pptx --out temp/showcase-teal-preview</a:t>
-            </a:r>
-            <a:endParaRPr lang="en-US" sz="1200" dirty="0"/>
-          </a:p>
-        </p:txBody>
-      </p:sp>
-      <p:sp>
-        <p:nvSpPr>
-          <p:cNvPr id="8" name="Text 6"/>
-          <p:cNvSpPr/>
-          <p:nvPr/>
-        </p:nvSpPr>
-        <p:spPr>
-          <a:xfrm>
-            <a:off x="612648" y="3995928"/>
-            <a:ext cx="10972800" cy="2130552"/>
+              <a:t>/</a:t>
+            </a:r>
+            <a:pPr indent="0" marL="0">
+              <a:buNone/>
+            </a:pPr>
+            <a:r>
+              <a:rPr lang="en-US" sz="1100" dirty="0">
+                <a:solidFill>
+                  <a:srgbClr val="4F46E5"/>
+                </a:solidFill>
+                <a:latin typeface="Courier New" pitchFamily="34" charset="0"/>
+                <a:ea typeface="Courier New" pitchFamily="34" charset="-122"/>
+                <a:cs typeface="Courier New" pitchFamily="34" charset="-120"/>
+              </a:rPr>
+              <a:t>results</a:t>
+            </a:r>
+            <a:pPr indent="0" marL="0">
+              <a:buNone/>
+            </a:pPr>
+            <a:r>
+              <a:rPr lang="en-US" sz="1100" dirty="0">
+                <a:solidFill>
+                  <a:srgbClr val="4F46E5"/>
+                </a:solidFill>
+                <a:latin typeface="Courier New" pitchFamily="34" charset="0"/>
+                <a:ea typeface="Courier New" pitchFamily="34" charset="-122"/>
+                <a:cs typeface="Courier New" pitchFamily="34" charset="-120"/>
+              </a:rPr>
+              <a:t>/</a:t>
+            </a:r>
+            <a:pPr indent="0" marL="0">
+              <a:buNone/>
+            </a:pPr>
+            <a:r>
+              <a:rPr lang="en-US" sz="1100" dirty="0">
+                <a:solidFill>
+                  <a:srgbClr val="4F46E5"/>
+                </a:solidFill>
+                <a:latin typeface="Courier New" pitchFamily="34" charset="0"/>
+                <a:ea typeface="Courier New" pitchFamily="34" charset="-122"/>
+                <a:cs typeface="Courier New" pitchFamily="34" charset="-120"/>
+              </a:rPr>
+              <a:t>showcase</a:t>
+            </a:r>
+            <a:pPr indent="0" marL="0">
+              <a:buNone/>
+            </a:pPr>
+            <a:r>
+              <a:rPr lang="en-US" sz="1100" dirty="0">
+                <a:solidFill>
+                  <a:srgbClr val="4F46E5"/>
+                </a:solidFill>
+                <a:latin typeface="Courier New" pitchFamily="34" charset="0"/>
+                <a:ea typeface="Courier New" pitchFamily="34" charset="-122"/>
+                <a:cs typeface="Courier New" pitchFamily="34" charset="-120"/>
+              </a:rPr>
+              <a:t>-</a:t>
+            </a:r>
+            <a:pPr indent="0" marL="0">
+              <a:buNone/>
+            </a:pPr>
+            <a:r>
+              <a:rPr lang="en-US" sz="1100" dirty="0">
+                <a:solidFill>
+                  <a:srgbClr val="4F46E5"/>
+                </a:solidFill>
+                <a:latin typeface="Courier New" pitchFamily="34" charset="0"/>
+                <a:ea typeface="Courier New" pitchFamily="34" charset="-122"/>
+                <a:cs typeface="Courier New" pitchFamily="34" charset="-120"/>
+              </a:rPr>
+              <a:t>teal</a:t>
+            </a:r>
+            <a:pPr indent="0" marL="0">
+              <a:buNone/>
+            </a:pPr>
+            <a:r>
+              <a:rPr lang="en-US" sz="1100" dirty="0">
+                <a:solidFill>
+                  <a:srgbClr val="4F46E5"/>
+                </a:solidFill>
+                <a:latin typeface="Courier New" pitchFamily="34" charset="0"/>
+                <a:ea typeface="Courier New" pitchFamily="34" charset="-122"/>
+                <a:cs typeface="Courier New" pitchFamily="34" charset="-120"/>
+              </a:rPr>
+              <a:t>-</a:t>
+            </a:r>
+            <a:pPr indent="0" marL="0">
+              <a:buNone/>
+            </a:pPr>
+            <a:r>
+              <a:rPr lang="en-US" sz="1100" dirty="0">
+                <a:solidFill>
+                  <a:srgbClr val="4F46E5"/>
+                </a:solidFill>
+                <a:latin typeface="Courier New" pitchFamily="34" charset="0"/>
+                <a:ea typeface="Courier New" pitchFamily="34" charset="-122"/>
+                <a:cs typeface="Courier New" pitchFamily="34" charset="-120"/>
+              </a:rPr>
+              <a:t>dark</a:t>
+            </a:r>
+            <a:pPr indent="0" marL="0">
+              <a:buNone/>
+            </a:pPr>
+            <a:r>
+              <a:rPr lang="en-US" sz="1100" dirty="0">
+                <a:solidFill>
+                  <a:srgbClr val="4F46E5"/>
+                </a:solidFill>
+                <a:latin typeface="Courier New" pitchFamily="34" charset="0"/>
+                <a:ea typeface="Courier New" pitchFamily="34" charset="-122"/>
+                <a:cs typeface="Courier New" pitchFamily="34" charset="-120"/>
+              </a:rPr>
+              <a:t>.</a:t>
+            </a:r>
+            <a:pPr indent="0" marL="0">
+              <a:buNone/>
+            </a:pPr>
+            <a:r>
+              <a:rPr lang="en-US" sz="1100" dirty="0">
+                <a:solidFill>
+                  <a:srgbClr val="4F46E5"/>
+                </a:solidFill>
+                <a:latin typeface="Courier New" pitchFamily="34" charset="0"/>
+                <a:ea typeface="Courier New" pitchFamily="34" charset="-122"/>
+                <a:cs typeface="Courier New" pitchFamily="34" charset="-120"/>
+              </a:rPr>
+              <a:t>blueprint</a:t>
+            </a:r>
+            <a:pPr indent="0" marL="0">
+              <a:buNone/>
+            </a:pPr>
+            <a:r>
+              <a:rPr lang="en-US" sz="1100" dirty="0">
+                <a:solidFill>
+                  <a:srgbClr val="4F46E5"/>
+                </a:solidFill>
+                <a:latin typeface="Courier New" pitchFamily="34" charset="0"/>
+                <a:ea typeface="Courier New" pitchFamily="34" charset="-122"/>
+                <a:cs typeface="Courier New" pitchFamily="34" charset="-120"/>
+              </a:rPr>
+              <a:t>.</a:t>
+            </a:r>
+            <a:pPr indent="0" marL="0">
+              <a:buNone/>
+            </a:pPr>
+            <a:r>
+              <a:rPr lang="en-US" sz="1100" dirty="0">
+                <a:solidFill>
+                  <a:srgbClr val="4F46E5"/>
+                </a:solidFill>
+                <a:latin typeface="Courier New" pitchFamily="34" charset="0"/>
+                <a:ea typeface="Courier New" pitchFamily="34" charset="-122"/>
+                <a:cs typeface="Courier New" pitchFamily="34" charset="-120"/>
+              </a:rPr>
+              <a:t>yaml</a:t>
+            </a:r>
+            <a:endParaRPr lang="en-US" sz="1100" dirty="0"/>
+          </a:p>
+          <a:p>
+            <a:pPr indent="0" marL="0">
+              <a:buNone/>
+            </a:pPr>
+            <a:r>
+              <a:rPr lang="en-US" sz="1100" dirty="0">
+                <a:solidFill>
+                  <a:srgbClr val="4F46E5"/>
+                </a:solidFill>
+                <a:latin typeface="Courier New" pitchFamily="34" charset="0"/>
+                <a:ea typeface="Courier New" pitchFamily="34" charset="-122"/>
+                <a:cs typeface="Courier New" pitchFamily="34" charset="-120"/>
+              </a:rPr>
+              <a:t>OUT</a:t>
+            </a:r>
+            <a:pPr indent="0" marL="0">
+              <a:buNone/>
+            </a:pPr>
+            <a:r>
+              <a:rPr lang="en-US" sz="1100" dirty="0">
+                <a:solidFill>
+                  <a:srgbClr val="4F46E5"/>
+                </a:solidFill>
+                <a:latin typeface="Courier New" pitchFamily="34" charset="0"/>
+                <a:ea typeface="Courier New" pitchFamily="34" charset="-122"/>
+                <a:cs typeface="Courier New" pitchFamily="34" charset="-120"/>
+              </a:rPr>
+              <a:t>=</a:t>
+            </a:r>
+            <a:pPr indent="0" marL="0">
+              <a:buNone/>
+            </a:pPr>
+            <a:r>
+              <a:rPr lang="en-US" sz="1100" dirty="0">
+                <a:solidFill>
+                  <a:srgbClr val="4F46E5"/>
+                </a:solidFill>
+                <a:latin typeface="Courier New" pitchFamily="34" charset="0"/>
+                <a:ea typeface="Courier New" pitchFamily="34" charset="-122"/>
+                <a:cs typeface="Courier New" pitchFamily="34" charset="-120"/>
+              </a:rPr>
+              <a:t>examples</a:t>
+            </a:r>
+            <a:pPr indent="0" marL="0">
+              <a:buNone/>
+            </a:pPr>
+            <a:r>
+              <a:rPr lang="en-US" sz="1100" dirty="0">
+                <a:solidFill>
+                  <a:srgbClr val="4F46E5"/>
+                </a:solidFill>
+                <a:latin typeface="Courier New" pitchFamily="34" charset="0"/>
+                <a:ea typeface="Courier New" pitchFamily="34" charset="-122"/>
+                <a:cs typeface="Courier New" pitchFamily="34" charset="-120"/>
+              </a:rPr>
+              <a:t>/</a:t>
+            </a:r>
+            <a:pPr indent="0" marL="0">
+              <a:buNone/>
+            </a:pPr>
+            <a:r>
+              <a:rPr lang="en-US" sz="1100" dirty="0">
+                <a:solidFill>
+                  <a:srgbClr val="4F46E5"/>
+                </a:solidFill>
+                <a:latin typeface="Courier New" pitchFamily="34" charset="0"/>
+                <a:ea typeface="Courier New" pitchFamily="34" charset="-122"/>
+                <a:cs typeface="Courier New" pitchFamily="34" charset="-120"/>
+              </a:rPr>
+              <a:t>results</a:t>
+            </a:r>
+            <a:pPr indent="0" marL="0">
+              <a:buNone/>
+            </a:pPr>
+            <a:r>
+              <a:rPr lang="en-US" sz="1100" dirty="0">
+                <a:solidFill>
+                  <a:srgbClr val="4F46E5"/>
+                </a:solidFill>
+                <a:latin typeface="Courier New" pitchFamily="34" charset="0"/>
+                <a:ea typeface="Courier New" pitchFamily="34" charset="-122"/>
+                <a:cs typeface="Courier New" pitchFamily="34" charset="-120"/>
+              </a:rPr>
+              <a:t>/</a:t>
+            </a:r>
+            <a:pPr indent="0" marL="0">
+              <a:buNone/>
+            </a:pPr>
+            <a:r>
+              <a:rPr lang="en-US" sz="1100" dirty="0">
+                <a:solidFill>
+                  <a:srgbClr val="4F46E5"/>
+                </a:solidFill>
+                <a:latin typeface="Courier New" pitchFamily="34" charset="0"/>
+                <a:ea typeface="Courier New" pitchFamily="34" charset="-122"/>
+                <a:cs typeface="Courier New" pitchFamily="34" charset="-120"/>
+              </a:rPr>
+              <a:t>showcase</a:t>
+            </a:r>
+            <a:pPr indent="0" marL="0">
+              <a:buNone/>
+            </a:pPr>
+            <a:r>
+              <a:rPr lang="en-US" sz="1100" dirty="0">
+                <a:solidFill>
+                  <a:srgbClr val="4F46E5"/>
+                </a:solidFill>
+                <a:latin typeface="Courier New" pitchFamily="34" charset="0"/>
+                <a:ea typeface="Courier New" pitchFamily="34" charset="-122"/>
+                <a:cs typeface="Courier New" pitchFamily="34" charset="-120"/>
+              </a:rPr>
+              <a:t>-</a:t>
+            </a:r>
+            <a:pPr indent="0" marL="0">
+              <a:buNone/>
+            </a:pPr>
+            <a:r>
+              <a:rPr lang="en-US" sz="1100" dirty="0">
+                <a:solidFill>
+                  <a:srgbClr val="4F46E5"/>
+                </a:solidFill>
+                <a:latin typeface="Courier New" pitchFamily="34" charset="0"/>
+                <a:ea typeface="Courier New" pitchFamily="34" charset="-122"/>
+                <a:cs typeface="Courier New" pitchFamily="34" charset="-120"/>
+              </a:rPr>
+              <a:t>teal</a:t>
+            </a:r>
+            <a:pPr indent="0" marL="0">
+              <a:buNone/>
+            </a:pPr>
+            <a:r>
+              <a:rPr lang="en-US" sz="1100" dirty="0">
+                <a:solidFill>
+                  <a:srgbClr val="4F46E5"/>
+                </a:solidFill>
+                <a:latin typeface="Courier New" pitchFamily="34" charset="0"/>
+                <a:ea typeface="Courier New" pitchFamily="34" charset="-122"/>
+                <a:cs typeface="Courier New" pitchFamily="34" charset="-120"/>
+              </a:rPr>
+              <a:t>-</a:t>
+            </a:r>
+            <a:pPr indent="0" marL="0">
+              <a:buNone/>
+            </a:pPr>
+            <a:r>
+              <a:rPr lang="en-US" sz="1100" dirty="0">
+                <a:solidFill>
+                  <a:srgbClr val="4F46E5"/>
+                </a:solidFill>
+                <a:latin typeface="Courier New" pitchFamily="34" charset="0"/>
+                <a:ea typeface="Courier New" pitchFamily="34" charset="-122"/>
+                <a:cs typeface="Courier New" pitchFamily="34" charset="-120"/>
+              </a:rPr>
+              <a:t>dark</a:t>
+            </a:r>
+            <a:pPr indent="0" marL="0">
+              <a:buNone/>
+            </a:pPr>
+            <a:r>
+              <a:rPr lang="en-US" sz="1100" dirty="0">
+                <a:solidFill>
+                  <a:srgbClr val="4F46E5"/>
+                </a:solidFill>
+                <a:latin typeface="Courier New" pitchFamily="34" charset="0"/>
+                <a:ea typeface="Courier New" pitchFamily="34" charset="-122"/>
+                <a:cs typeface="Courier New" pitchFamily="34" charset="-120"/>
+              </a:rPr>
+              <a:t>.</a:t>
+            </a:r>
+            <a:pPr indent="0" marL="0">
+              <a:buNone/>
+            </a:pPr>
+            <a:r>
+              <a:rPr lang="en-US" sz="1100" dirty="0">
+                <a:solidFill>
+                  <a:srgbClr val="4F46E5"/>
+                </a:solidFill>
+                <a:latin typeface="Courier New" pitchFamily="34" charset="0"/>
+                <a:ea typeface="Courier New" pitchFamily="34" charset="-122"/>
+                <a:cs typeface="Courier New" pitchFamily="34" charset="-120"/>
+              </a:rPr>
+              <a:t>pptx</a:t>
+            </a:r>
+            <a:endParaRPr lang="en-US" sz="1100" dirty="0"/>
+          </a:p>
+          <a:p>
+            <a:pPr indent="0" marL="0">
+              <a:buNone/>
+            </a:pPr>
+            <a:r>
+              <a:rPr lang="en-US" sz="1100" dirty="0">
+                <a:solidFill>
+                  <a:srgbClr val="4F46E5"/>
+                </a:solidFill>
+                <a:latin typeface="Courier New" pitchFamily="34" charset="0"/>
+                <a:ea typeface="Courier New" pitchFamily="34" charset="-122"/>
+                <a:cs typeface="Courier New" pitchFamily="34" charset="-120"/>
+              </a:rPr>
+              <a:t>PDF</a:t>
+            </a:r>
+            <a:pPr indent="0" marL="0">
+              <a:buNone/>
+            </a:pPr>
+            <a:r>
+              <a:rPr lang="en-US" sz="1100" dirty="0">
+                <a:solidFill>
+                  <a:srgbClr val="4F46E5"/>
+                </a:solidFill>
+                <a:latin typeface="Courier New" pitchFamily="34" charset="0"/>
+                <a:ea typeface="Courier New" pitchFamily="34" charset="-122"/>
+                <a:cs typeface="Courier New" pitchFamily="34" charset="-120"/>
+              </a:rPr>
+              <a:t>=</a:t>
+            </a:r>
+            <a:pPr indent="0" marL="0">
+              <a:buNone/>
+            </a:pPr>
+            <a:r>
+              <a:rPr lang="en-US" sz="1100" dirty="0">
+                <a:solidFill>
+                  <a:srgbClr val="4F46E5"/>
+                </a:solidFill>
+                <a:latin typeface="Courier New" pitchFamily="34" charset="0"/>
+                <a:ea typeface="Courier New" pitchFamily="34" charset="-122"/>
+                <a:cs typeface="Courier New" pitchFamily="34" charset="-120"/>
+              </a:rPr>
+              <a:t>examples</a:t>
+            </a:r>
+            <a:pPr indent="0" marL="0">
+              <a:buNone/>
+            </a:pPr>
+            <a:r>
+              <a:rPr lang="en-US" sz="1100" dirty="0">
+                <a:solidFill>
+                  <a:srgbClr val="4F46E5"/>
+                </a:solidFill>
+                <a:latin typeface="Courier New" pitchFamily="34" charset="0"/>
+                <a:ea typeface="Courier New" pitchFamily="34" charset="-122"/>
+                <a:cs typeface="Courier New" pitchFamily="34" charset="-120"/>
+              </a:rPr>
+              <a:t>/</a:t>
+            </a:r>
+            <a:pPr indent="0" marL="0">
+              <a:buNone/>
+            </a:pPr>
+            <a:r>
+              <a:rPr lang="en-US" sz="1100" dirty="0">
+                <a:solidFill>
+                  <a:srgbClr val="4F46E5"/>
+                </a:solidFill>
+                <a:latin typeface="Courier New" pitchFamily="34" charset="0"/>
+                <a:ea typeface="Courier New" pitchFamily="34" charset="-122"/>
+                <a:cs typeface="Courier New" pitchFamily="34" charset="-120"/>
+              </a:rPr>
+              <a:t>results</a:t>
+            </a:r>
+            <a:pPr indent="0" marL="0">
+              <a:buNone/>
+            </a:pPr>
+            <a:r>
+              <a:rPr lang="en-US" sz="1100" dirty="0">
+                <a:solidFill>
+                  <a:srgbClr val="4F46E5"/>
+                </a:solidFill>
+                <a:latin typeface="Courier New" pitchFamily="34" charset="0"/>
+                <a:ea typeface="Courier New" pitchFamily="34" charset="-122"/>
+                <a:cs typeface="Courier New" pitchFamily="34" charset="-120"/>
+              </a:rPr>
+              <a:t>/</a:t>
+            </a:r>
+            <a:pPr indent="0" marL="0">
+              <a:buNone/>
+            </a:pPr>
+            <a:r>
+              <a:rPr lang="en-US" sz="1100" dirty="0">
+                <a:solidFill>
+                  <a:srgbClr val="4F46E5"/>
+                </a:solidFill>
+                <a:latin typeface="Courier New" pitchFamily="34" charset="0"/>
+                <a:ea typeface="Courier New" pitchFamily="34" charset="-122"/>
+                <a:cs typeface="Courier New" pitchFamily="34" charset="-120"/>
+              </a:rPr>
+              <a:t>showcase</a:t>
+            </a:r>
+            <a:pPr indent="0" marL="0">
+              <a:buNone/>
+            </a:pPr>
+            <a:r>
+              <a:rPr lang="en-US" sz="1100" dirty="0">
+                <a:solidFill>
+                  <a:srgbClr val="4F46E5"/>
+                </a:solidFill>
+                <a:latin typeface="Courier New" pitchFamily="34" charset="0"/>
+                <a:ea typeface="Courier New" pitchFamily="34" charset="-122"/>
+                <a:cs typeface="Courier New" pitchFamily="34" charset="-120"/>
+              </a:rPr>
+              <a:t>-</a:t>
+            </a:r>
+            <a:pPr indent="0" marL="0">
+              <a:buNone/>
+            </a:pPr>
+            <a:r>
+              <a:rPr lang="en-US" sz="1100" dirty="0">
+                <a:solidFill>
+                  <a:srgbClr val="4F46E5"/>
+                </a:solidFill>
+                <a:latin typeface="Courier New" pitchFamily="34" charset="0"/>
+                <a:ea typeface="Courier New" pitchFamily="34" charset="-122"/>
+                <a:cs typeface="Courier New" pitchFamily="34" charset="-120"/>
+              </a:rPr>
+              <a:t>teal</a:t>
+            </a:r>
+            <a:pPr indent="0" marL="0">
+              <a:buNone/>
+            </a:pPr>
+            <a:r>
+              <a:rPr lang="en-US" sz="1100" dirty="0">
+                <a:solidFill>
+                  <a:srgbClr val="4F46E5"/>
+                </a:solidFill>
+                <a:latin typeface="Courier New" pitchFamily="34" charset="0"/>
+                <a:ea typeface="Courier New" pitchFamily="34" charset="-122"/>
+                <a:cs typeface="Courier New" pitchFamily="34" charset="-120"/>
+              </a:rPr>
+              <a:t>-</a:t>
+            </a:r>
+            <a:pPr indent="0" marL="0">
+              <a:buNone/>
+            </a:pPr>
+            <a:r>
+              <a:rPr lang="en-US" sz="1100" dirty="0">
+                <a:solidFill>
+                  <a:srgbClr val="4F46E5"/>
+                </a:solidFill>
+                <a:latin typeface="Courier New" pitchFamily="34" charset="0"/>
+                <a:ea typeface="Courier New" pitchFamily="34" charset="-122"/>
+                <a:cs typeface="Courier New" pitchFamily="34" charset="-120"/>
+              </a:rPr>
+              <a:t>dark</a:t>
+            </a:r>
+            <a:pPr indent="0" marL="0">
+              <a:buNone/>
+            </a:pPr>
+            <a:r>
+              <a:rPr lang="en-US" sz="1100" dirty="0">
+                <a:solidFill>
+                  <a:srgbClr val="4F46E5"/>
+                </a:solidFill>
+                <a:latin typeface="Courier New" pitchFamily="34" charset="0"/>
+                <a:ea typeface="Courier New" pitchFamily="34" charset="-122"/>
+                <a:cs typeface="Courier New" pitchFamily="34" charset="-120"/>
+              </a:rPr>
+              <a:t>.</a:t>
+            </a:r>
+            <a:pPr indent="0" marL="0">
+              <a:buNone/>
+            </a:pPr>
+            <a:r>
+              <a:rPr lang="en-US" sz="1100" dirty="0">
+                <a:solidFill>
+                  <a:srgbClr val="4F46E5"/>
+                </a:solidFill>
+                <a:latin typeface="Courier New" pitchFamily="34" charset="0"/>
+                <a:ea typeface="Courier New" pitchFamily="34" charset="-122"/>
+                <a:cs typeface="Courier New" pitchFamily="34" charset="-120"/>
+              </a:rPr>
+              <a:t>pdf</a:t>
+            </a:r>
+            <a:endParaRPr lang="en-US" sz="1100" dirty="0"/>
+          </a:p>
+          <a:p>
+            <a:pPr indent="0" marL="0">
+              <a:buNone/>
+            </a:pPr>
+            <a:r>
+              <a:rPr lang="en-US" sz="1100" dirty="0">
+                <a:solidFill>
+                  <a:srgbClr val="4F46E5"/>
+                </a:solidFill>
+                <a:latin typeface="Courier New" pitchFamily="34" charset="0"/>
+                <a:ea typeface="Courier New" pitchFamily="34" charset="-122"/>
+                <a:cs typeface="Courier New" pitchFamily="34" charset="-120"/>
+              </a:rPr>
+              <a:t>npm</a:t>
+            </a:r>
+            <a:pPr indent="0" marL="0">
+              <a:buNone/>
+            </a:pPr>
+            <a:r>
+              <a:rPr lang="en-US" sz="1100" dirty="0">
+                <a:solidFill>
+                  <a:srgbClr val="4F46E5"/>
+                </a:solidFill>
+                <a:latin typeface="Courier New" pitchFamily="34" charset="0"/>
+                <a:ea typeface="Courier New" pitchFamily="34" charset="-122"/>
+                <a:cs typeface="Courier New" pitchFamily="34" charset="-120"/>
+              </a:rPr>
+              <a:t> </a:t>
+            </a:r>
+            <a:pPr indent="0" marL="0">
+              <a:buNone/>
+            </a:pPr>
+            <a:r>
+              <a:rPr lang="en-US" sz="1100" dirty="0">
+                <a:solidFill>
+                  <a:srgbClr val="4F46E5"/>
+                </a:solidFill>
+                <a:latin typeface="Courier New" pitchFamily="34" charset="0"/>
+                <a:ea typeface="Courier New" pitchFamily="34" charset="-122"/>
+                <a:cs typeface="Courier New" pitchFamily="34" charset="-120"/>
+              </a:rPr>
+              <a:t>run</a:t>
+            </a:r>
+            <a:pPr indent="0" marL="0">
+              <a:buNone/>
+            </a:pPr>
+            <a:r>
+              <a:rPr lang="en-US" sz="1100" dirty="0">
+                <a:solidFill>
+                  <a:srgbClr val="4F46E5"/>
+                </a:solidFill>
+                <a:latin typeface="Courier New" pitchFamily="34" charset="0"/>
+                <a:ea typeface="Courier New" pitchFamily="34" charset="-122"/>
+                <a:cs typeface="Courier New" pitchFamily="34" charset="-120"/>
+              </a:rPr>
+              <a:t> </a:t>
+            </a:r>
+            <a:pPr indent="0" marL="0">
+              <a:buNone/>
+            </a:pPr>
+            <a:r>
+              <a:rPr lang="en-US" sz="1100" dirty="0">
+                <a:solidFill>
+                  <a:srgbClr val="4F46E5"/>
+                </a:solidFill>
+                <a:latin typeface="Courier New" pitchFamily="34" charset="0"/>
+                <a:ea typeface="Courier New" pitchFamily="34" charset="-122"/>
+                <a:cs typeface="Courier New" pitchFamily="34" charset="-120"/>
+              </a:rPr>
+              <a:t>validate</a:t>
+            </a:r>
+            <a:pPr indent="0" marL="0">
+              <a:buNone/>
+            </a:pPr>
+            <a:r>
+              <a:rPr lang="en-US" sz="1100" dirty="0">
+                <a:solidFill>
+                  <a:srgbClr val="4F46E5"/>
+                </a:solidFill>
+                <a:latin typeface="Courier New" pitchFamily="34" charset="0"/>
+                <a:ea typeface="Courier New" pitchFamily="34" charset="-122"/>
+                <a:cs typeface="Courier New" pitchFamily="34" charset="-120"/>
+              </a:rPr>
+              <a:t> </a:t>
+            </a:r>
+            <a:pPr indent="0" marL="0">
+              <a:buNone/>
+            </a:pPr>
+            <a:r>
+              <a:rPr lang="en-US" sz="1100" dirty="0">
+                <a:solidFill>
+                  <a:srgbClr val="4F46E5"/>
+                </a:solidFill>
+                <a:latin typeface="Courier New" pitchFamily="34" charset="0"/>
+                <a:ea typeface="Courier New" pitchFamily="34" charset="-122"/>
+                <a:cs typeface="Courier New" pitchFamily="34" charset="-120"/>
+              </a:rPr>
+              <a:t>-</a:t>
+            </a:r>
+            <a:pPr indent="0" marL="0">
+              <a:buNone/>
+            </a:pPr>
+            <a:r>
+              <a:rPr lang="en-US" sz="1100" dirty="0">
+                <a:solidFill>
+                  <a:srgbClr val="4F46E5"/>
+                </a:solidFill>
+                <a:latin typeface="Courier New" pitchFamily="34" charset="0"/>
+                <a:ea typeface="Courier New" pitchFamily="34" charset="-122"/>
+                <a:cs typeface="Courier New" pitchFamily="34" charset="-120"/>
+              </a:rPr>
+              <a:t>-</a:t>
+            </a:r>
+            <a:pPr indent="0" marL="0">
+              <a:buNone/>
+            </a:pPr>
+            <a:r>
+              <a:rPr lang="en-US" sz="1100" dirty="0">
+                <a:solidFill>
+                  <a:srgbClr val="4F46E5"/>
+                </a:solidFill>
+                <a:latin typeface="Courier New" pitchFamily="34" charset="0"/>
+                <a:ea typeface="Courier New" pitchFamily="34" charset="-122"/>
+                <a:cs typeface="Courier New" pitchFamily="34" charset="-120"/>
+              </a:rPr>
+              <a:t> </a:t>
+            </a:r>
+            <a:pPr indent="0" marL="0">
+              <a:buNone/>
+            </a:pPr>
+            <a:r>
+              <a:rPr lang="en-US" sz="1100" dirty="0">
+                <a:solidFill>
+                  <a:srgbClr val="4F46E5"/>
+                </a:solidFill>
+                <a:latin typeface="Courier New" pitchFamily="34" charset="0"/>
+                <a:ea typeface="Courier New" pitchFamily="34" charset="-122"/>
+                <a:cs typeface="Courier New" pitchFamily="34" charset="-120"/>
+              </a:rPr>
+              <a:t>-</a:t>
+            </a:r>
+            <a:pPr indent="0" marL="0">
+              <a:buNone/>
+            </a:pPr>
+            <a:r>
+              <a:rPr lang="en-US" sz="1100" dirty="0">
+                <a:solidFill>
+                  <a:srgbClr val="4F46E5"/>
+                </a:solidFill>
+                <a:latin typeface="Courier New" pitchFamily="34" charset="0"/>
+                <a:ea typeface="Courier New" pitchFamily="34" charset="-122"/>
+                <a:cs typeface="Courier New" pitchFamily="34" charset="-120"/>
+              </a:rPr>
+              <a:t>-</a:t>
+            </a:r>
+            <a:pPr indent="0" marL="0">
+              <a:buNone/>
+            </a:pPr>
+            <a:r>
+              <a:rPr lang="en-US" sz="1100" dirty="0">
+                <a:solidFill>
+                  <a:srgbClr val="4F46E5"/>
+                </a:solidFill>
+                <a:latin typeface="Courier New" pitchFamily="34" charset="0"/>
+                <a:ea typeface="Courier New" pitchFamily="34" charset="-122"/>
+                <a:cs typeface="Courier New" pitchFamily="34" charset="-120"/>
+              </a:rPr>
+              <a:t>blueprint</a:t>
+            </a:r>
+            <a:pPr indent="0" marL="0">
+              <a:buNone/>
+            </a:pPr>
+            <a:r>
+              <a:rPr lang="en-US" sz="1100" dirty="0">
+                <a:solidFill>
+                  <a:srgbClr val="4F46E5"/>
+                </a:solidFill>
+                <a:latin typeface="Courier New" pitchFamily="34" charset="0"/>
+                <a:ea typeface="Courier New" pitchFamily="34" charset="-122"/>
+                <a:cs typeface="Courier New" pitchFamily="34" charset="-120"/>
+              </a:rPr>
+              <a:t> </a:t>
+            </a:r>
+            <a:pPr indent="0" marL="0">
+              <a:buNone/>
+            </a:pPr>
+            <a:r>
+              <a:rPr lang="en-US" sz="1100" dirty="0">
+                <a:solidFill>
+                  <a:srgbClr val="059669"/>
+                </a:solidFill>
+                <a:latin typeface="Courier New" pitchFamily="34" charset="0"/>
+                <a:ea typeface="Courier New" pitchFamily="34" charset="-122"/>
+                <a:cs typeface="Courier New" pitchFamily="34" charset="-120"/>
+              </a:rPr>
+              <a:t>"$BP"</a:t>
+            </a:r>
+            <a:endParaRPr lang="en-US" sz="1100" dirty="0"/>
+          </a:p>
+          <a:p>
+            <a:pPr indent="0" marL="0">
+              <a:buNone/>
+            </a:pPr>
+            <a:r>
+              <a:rPr lang="en-US" sz="1100" dirty="0">
+                <a:solidFill>
+                  <a:srgbClr val="4F46E5"/>
+                </a:solidFill>
+                <a:latin typeface="Courier New" pitchFamily="34" charset="0"/>
+                <a:ea typeface="Courier New" pitchFamily="34" charset="-122"/>
+                <a:cs typeface="Courier New" pitchFamily="34" charset="-120"/>
+              </a:rPr>
+              <a:t>npm</a:t>
+            </a:r>
+            <a:pPr indent="0" marL="0">
+              <a:buNone/>
+            </a:pPr>
+            <a:r>
+              <a:rPr lang="en-US" sz="1100" dirty="0">
+                <a:solidFill>
+                  <a:srgbClr val="4F46E5"/>
+                </a:solidFill>
+                <a:latin typeface="Courier New" pitchFamily="34" charset="0"/>
+                <a:ea typeface="Courier New" pitchFamily="34" charset="-122"/>
+                <a:cs typeface="Courier New" pitchFamily="34" charset="-120"/>
+              </a:rPr>
+              <a:t> </a:t>
+            </a:r>
+            <a:pPr indent="0" marL="0">
+              <a:buNone/>
+            </a:pPr>
+            <a:r>
+              <a:rPr lang="en-US" sz="1100" dirty="0">
+                <a:solidFill>
+                  <a:srgbClr val="4F46E5"/>
+                </a:solidFill>
+                <a:latin typeface="Courier New" pitchFamily="34" charset="0"/>
+                <a:ea typeface="Courier New" pitchFamily="34" charset="-122"/>
+                <a:cs typeface="Courier New" pitchFamily="34" charset="-120"/>
+              </a:rPr>
+              <a:t>run</a:t>
+            </a:r>
+            <a:pPr indent="0" marL="0">
+              <a:buNone/>
+            </a:pPr>
+            <a:r>
+              <a:rPr lang="en-US" sz="1100" dirty="0">
+                <a:solidFill>
+                  <a:srgbClr val="4F46E5"/>
+                </a:solidFill>
+                <a:latin typeface="Courier New" pitchFamily="34" charset="0"/>
+                <a:ea typeface="Courier New" pitchFamily="34" charset="-122"/>
+                <a:cs typeface="Courier New" pitchFamily="34" charset="-120"/>
+              </a:rPr>
+              <a:t> </a:t>
+            </a:r>
+            <a:pPr indent="0" marL="0">
+              <a:buNone/>
+            </a:pPr>
+            <a:r>
+              <a:rPr lang="en-US" sz="1100" dirty="0">
+                <a:solidFill>
+                  <a:srgbClr val="4F46E5"/>
+                </a:solidFill>
+                <a:latin typeface="Courier New" pitchFamily="34" charset="0"/>
+                <a:ea typeface="Courier New" pitchFamily="34" charset="-122"/>
+                <a:cs typeface="Courier New" pitchFamily="34" charset="-120"/>
+              </a:rPr>
+              <a:t>deck</a:t>
+            </a:r>
+            <a:pPr indent="0" marL="0">
+              <a:buNone/>
+            </a:pPr>
+            <a:r>
+              <a:rPr lang="en-US" sz="1100" dirty="0">
+                <a:solidFill>
+                  <a:srgbClr val="4F46E5"/>
+                </a:solidFill>
+                <a:latin typeface="Courier New" pitchFamily="34" charset="0"/>
+                <a:ea typeface="Courier New" pitchFamily="34" charset="-122"/>
+                <a:cs typeface="Courier New" pitchFamily="34" charset="-120"/>
+              </a:rPr>
+              <a:t> </a:t>
+            </a:r>
+            <a:pPr indent="0" marL="0">
+              <a:buNone/>
+            </a:pPr>
+            <a:r>
+              <a:rPr lang="en-US" sz="1100" dirty="0">
+                <a:solidFill>
+                  <a:srgbClr val="4F46E5"/>
+                </a:solidFill>
+                <a:latin typeface="Courier New" pitchFamily="34" charset="0"/>
+                <a:ea typeface="Courier New" pitchFamily="34" charset="-122"/>
+                <a:cs typeface="Courier New" pitchFamily="34" charset="-120"/>
+              </a:rPr>
+              <a:t>-</a:t>
+            </a:r>
+            <a:pPr indent="0" marL="0">
+              <a:buNone/>
+            </a:pPr>
+            <a:r>
+              <a:rPr lang="en-US" sz="1100" dirty="0">
+                <a:solidFill>
+                  <a:srgbClr val="4F46E5"/>
+                </a:solidFill>
+                <a:latin typeface="Courier New" pitchFamily="34" charset="0"/>
+                <a:ea typeface="Courier New" pitchFamily="34" charset="-122"/>
+                <a:cs typeface="Courier New" pitchFamily="34" charset="-120"/>
+              </a:rPr>
+              <a:t>-</a:t>
+            </a:r>
+            <a:pPr indent="0" marL="0">
+              <a:buNone/>
+            </a:pPr>
+            <a:r>
+              <a:rPr lang="en-US" sz="1100" dirty="0">
+                <a:solidFill>
+                  <a:srgbClr val="4F46E5"/>
+                </a:solidFill>
+                <a:latin typeface="Courier New" pitchFamily="34" charset="0"/>
+                <a:ea typeface="Courier New" pitchFamily="34" charset="-122"/>
+                <a:cs typeface="Courier New" pitchFamily="34" charset="-120"/>
+              </a:rPr>
+              <a:t> </a:t>
+            </a:r>
+            <a:pPr indent="0" marL="0">
+              <a:buNone/>
+            </a:pPr>
+            <a:r>
+              <a:rPr lang="en-US" sz="1100" dirty="0">
+                <a:solidFill>
+                  <a:srgbClr val="4F46E5"/>
+                </a:solidFill>
+                <a:latin typeface="Courier New" pitchFamily="34" charset="0"/>
+                <a:ea typeface="Courier New" pitchFamily="34" charset="-122"/>
+                <a:cs typeface="Courier New" pitchFamily="34" charset="-120"/>
+              </a:rPr>
+              <a:t>-</a:t>
+            </a:r>
+            <a:pPr indent="0" marL="0">
+              <a:buNone/>
+            </a:pPr>
+            <a:r>
+              <a:rPr lang="en-US" sz="1100" dirty="0">
+                <a:solidFill>
+                  <a:srgbClr val="4F46E5"/>
+                </a:solidFill>
+                <a:latin typeface="Courier New" pitchFamily="34" charset="0"/>
+                <a:ea typeface="Courier New" pitchFamily="34" charset="-122"/>
+                <a:cs typeface="Courier New" pitchFamily="34" charset="-120"/>
+              </a:rPr>
+              <a:t>-</a:t>
+            </a:r>
+            <a:pPr indent="0" marL="0">
+              <a:buNone/>
+            </a:pPr>
+            <a:r>
+              <a:rPr lang="en-US" sz="1100" dirty="0">
+                <a:solidFill>
+                  <a:srgbClr val="4F46E5"/>
+                </a:solidFill>
+                <a:latin typeface="Courier New" pitchFamily="34" charset="0"/>
+                <a:ea typeface="Courier New" pitchFamily="34" charset="-122"/>
+                <a:cs typeface="Courier New" pitchFamily="34" charset="-120"/>
+              </a:rPr>
+              <a:t>blueprint</a:t>
+            </a:r>
+            <a:pPr indent="0" marL="0">
+              <a:buNone/>
+            </a:pPr>
+            <a:r>
+              <a:rPr lang="en-US" sz="1100" dirty="0">
+                <a:solidFill>
+                  <a:srgbClr val="4F46E5"/>
+                </a:solidFill>
+                <a:latin typeface="Courier New" pitchFamily="34" charset="0"/>
+                <a:ea typeface="Courier New" pitchFamily="34" charset="-122"/>
+                <a:cs typeface="Courier New" pitchFamily="34" charset="-120"/>
+              </a:rPr>
+              <a:t> </a:t>
+            </a:r>
+            <a:pPr indent="0" marL="0">
+              <a:buNone/>
+            </a:pPr>
+            <a:r>
+              <a:rPr lang="en-US" sz="1100" dirty="0">
+                <a:solidFill>
+                  <a:srgbClr val="059669"/>
+                </a:solidFill>
+                <a:latin typeface="Courier New" pitchFamily="34" charset="0"/>
+                <a:ea typeface="Courier New" pitchFamily="34" charset="-122"/>
+                <a:cs typeface="Courier New" pitchFamily="34" charset="-120"/>
+              </a:rPr>
+              <a:t>"$BP"</a:t>
+            </a:r>
+            <a:pPr indent="0" marL="0">
+              <a:buNone/>
+            </a:pPr>
+            <a:r>
+              <a:rPr lang="en-US" sz="1100" dirty="0">
+                <a:solidFill>
+                  <a:srgbClr val="4F46E5"/>
+                </a:solidFill>
+                <a:latin typeface="Courier New" pitchFamily="34" charset="0"/>
+                <a:ea typeface="Courier New" pitchFamily="34" charset="-122"/>
+                <a:cs typeface="Courier New" pitchFamily="34" charset="-120"/>
+              </a:rPr>
+              <a:t> </a:t>
+            </a:r>
+            <a:pPr indent="0" marL="0">
+              <a:buNone/>
+            </a:pPr>
+            <a:r>
+              <a:rPr lang="en-US" sz="1100" dirty="0">
+                <a:solidFill>
+                  <a:srgbClr val="4F46E5"/>
+                </a:solidFill>
+                <a:latin typeface="Courier New" pitchFamily="34" charset="0"/>
+                <a:ea typeface="Courier New" pitchFamily="34" charset="-122"/>
+                <a:cs typeface="Courier New" pitchFamily="34" charset="-120"/>
+              </a:rPr>
+              <a:t>-</a:t>
+            </a:r>
+            <a:pPr indent="0" marL="0">
+              <a:buNone/>
+            </a:pPr>
+            <a:r>
+              <a:rPr lang="en-US" sz="1100" dirty="0">
+                <a:solidFill>
+                  <a:srgbClr val="4F46E5"/>
+                </a:solidFill>
+                <a:latin typeface="Courier New" pitchFamily="34" charset="0"/>
+                <a:ea typeface="Courier New" pitchFamily="34" charset="-122"/>
+                <a:cs typeface="Courier New" pitchFamily="34" charset="-120"/>
+              </a:rPr>
+              <a:t>-</a:t>
+            </a:r>
+            <a:pPr indent="0" marL="0">
+              <a:buNone/>
+            </a:pPr>
+            <a:r>
+              <a:rPr lang="en-US" sz="1100" dirty="0">
+                <a:solidFill>
+                  <a:srgbClr val="4F46E5"/>
+                </a:solidFill>
+                <a:latin typeface="Courier New" pitchFamily="34" charset="0"/>
+                <a:ea typeface="Courier New" pitchFamily="34" charset="-122"/>
+                <a:cs typeface="Courier New" pitchFamily="34" charset="-120"/>
+              </a:rPr>
+              <a:t>output</a:t>
+            </a:r>
+            <a:pPr indent="0" marL="0">
+              <a:buNone/>
+            </a:pPr>
+            <a:r>
+              <a:rPr lang="en-US" sz="1100" dirty="0">
+                <a:solidFill>
+                  <a:srgbClr val="4F46E5"/>
+                </a:solidFill>
+                <a:latin typeface="Courier New" pitchFamily="34" charset="0"/>
+                <a:ea typeface="Courier New" pitchFamily="34" charset="-122"/>
+                <a:cs typeface="Courier New" pitchFamily="34" charset="-120"/>
+              </a:rPr>
+              <a:t> </a:t>
+            </a:r>
+            <a:pPr indent="0" marL="0">
+              <a:buNone/>
+            </a:pPr>
+            <a:r>
+              <a:rPr lang="en-US" sz="1100" dirty="0">
+                <a:solidFill>
+                  <a:srgbClr val="059669"/>
+                </a:solidFill>
+                <a:latin typeface="Courier New" pitchFamily="34" charset="0"/>
+                <a:ea typeface="Courier New" pitchFamily="34" charset="-122"/>
+                <a:cs typeface="Courier New" pitchFamily="34" charset="-120"/>
+              </a:rPr>
+              <a:t>"$OUT"</a:t>
+            </a:r>
+            <a:endParaRPr lang="en-US" sz="1100" dirty="0"/>
+          </a:p>
+          <a:p>
+            <a:pPr indent="0" marL="0">
+              <a:buNone/>
+            </a:pPr>
+            <a:r>
+              <a:rPr lang="en-US" sz="1100" dirty="0">
+                <a:solidFill>
+                  <a:srgbClr val="4F46E5"/>
+                </a:solidFill>
+                <a:latin typeface="Courier New" pitchFamily="34" charset="0"/>
+                <a:ea typeface="Courier New" pitchFamily="34" charset="-122"/>
+                <a:cs typeface="Courier New" pitchFamily="34" charset="-120"/>
+              </a:rPr>
+              <a:t>npm</a:t>
+            </a:r>
+            <a:pPr indent="0" marL="0">
+              <a:buNone/>
+            </a:pPr>
+            <a:r>
+              <a:rPr lang="en-US" sz="1100" dirty="0">
+                <a:solidFill>
+                  <a:srgbClr val="4F46E5"/>
+                </a:solidFill>
+                <a:latin typeface="Courier New" pitchFamily="34" charset="0"/>
+                <a:ea typeface="Courier New" pitchFamily="34" charset="-122"/>
+                <a:cs typeface="Courier New" pitchFamily="34" charset="-120"/>
+              </a:rPr>
+              <a:t> </a:t>
+            </a:r>
+            <a:pPr indent="0" marL="0">
+              <a:buNone/>
+            </a:pPr>
+            <a:r>
+              <a:rPr lang="en-US" sz="1100" dirty="0">
+                <a:solidFill>
+                  <a:srgbClr val="4F46E5"/>
+                </a:solidFill>
+                <a:latin typeface="Courier New" pitchFamily="34" charset="0"/>
+                <a:ea typeface="Courier New" pitchFamily="34" charset="-122"/>
+                <a:cs typeface="Courier New" pitchFamily="34" charset="-120"/>
+              </a:rPr>
+              <a:t>run</a:t>
+            </a:r>
+            <a:pPr indent="0" marL="0">
+              <a:buNone/>
+            </a:pPr>
+            <a:r>
+              <a:rPr lang="en-US" sz="1100" dirty="0">
+                <a:solidFill>
+                  <a:srgbClr val="4F46E5"/>
+                </a:solidFill>
+                <a:latin typeface="Courier New" pitchFamily="34" charset="0"/>
+                <a:ea typeface="Courier New" pitchFamily="34" charset="-122"/>
+                <a:cs typeface="Courier New" pitchFamily="34" charset="-120"/>
+              </a:rPr>
+              <a:t> </a:t>
+            </a:r>
+            <a:pPr indent="0" marL="0">
+              <a:buNone/>
+            </a:pPr>
+            <a:r>
+              <a:rPr lang="en-US" sz="1100" dirty="0">
+                <a:solidFill>
+                  <a:srgbClr val="7C3AED"/>
+                </a:solidFill>
+                <a:latin typeface="Courier New" pitchFamily="34" charset="0"/>
+                <a:ea typeface="Courier New" pitchFamily="34" charset="-122"/>
+                <a:cs typeface="Courier New" pitchFamily="34" charset="-120"/>
+              </a:rPr>
+              <a:t>export</a:t>
+            </a:r>
+            <a:pPr indent="0" marL="0">
+              <a:buNone/>
+            </a:pPr>
+            <a:r>
+              <a:rPr lang="en-US" sz="1100" dirty="0">
+                <a:solidFill>
+                  <a:srgbClr val="4F46E5"/>
+                </a:solidFill>
+                <a:latin typeface="Courier New" pitchFamily="34" charset="0"/>
+                <a:ea typeface="Courier New" pitchFamily="34" charset="-122"/>
+                <a:cs typeface="Courier New" pitchFamily="34" charset="-120"/>
+              </a:rPr>
+              <a:t>-</a:t>
+            </a:r>
+            <a:pPr indent="0" marL="0">
+              <a:buNone/>
+            </a:pPr>
+            <a:r>
+              <a:rPr lang="en-US" sz="1100" dirty="0">
+                <a:solidFill>
+                  <a:srgbClr val="4F46E5"/>
+                </a:solidFill>
+                <a:latin typeface="Courier New" pitchFamily="34" charset="0"/>
+                <a:ea typeface="Courier New" pitchFamily="34" charset="-122"/>
+                <a:cs typeface="Courier New" pitchFamily="34" charset="-120"/>
+              </a:rPr>
+              <a:t>pdf</a:t>
+            </a:r>
+            <a:pPr indent="0" marL="0">
+              <a:buNone/>
+            </a:pPr>
+            <a:r>
+              <a:rPr lang="en-US" sz="1100" dirty="0">
+                <a:solidFill>
+                  <a:srgbClr val="4F46E5"/>
+                </a:solidFill>
+                <a:latin typeface="Courier New" pitchFamily="34" charset="0"/>
+                <a:ea typeface="Courier New" pitchFamily="34" charset="-122"/>
+                <a:cs typeface="Courier New" pitchFamily="34" charset="-120"/>
+              </a:rPr>
+              <a:t> </a:t>
+            </a:r>
+            <a:pPr indent="0" marL="0">
+              <a:buNone/>
+            </a:pPr>
+            <a:r>
+              <a:rPr lang="en-US" sz="1100" dirty="0">
+                <a:solidFill>
+                  <a:srgbClr val="4F46E5"/>
+                </a:solidFill>
+                <a:latin typeface="Courier New" pitchFamily="34" charset="0"/>
+                <a:ea typeface="Courier New" pitchFamily="34" charset="-122"/>
+                <a:cs typeface="Courier New" pitchFamily="34" charset="-120"/>
+              </a:rPr>
+              <a:t>-</a:t>
+            </a:r>
+            <a:pPr indent="0" marL="0">
+              <a:buNone/>
+            </a:pPr>
+            <a:r>
+              <a:rPr lang="en-US" sz="1100" dirty="0">
+                <a:solidFill>
+                  <a:srgbClr val="4F46E5"/>
+                </a:solidFill>
+                <a:latin typeface="Courier New" pitchFamily="34" charset="0"/>
+                <a:ea typeface="Courier New" pitchFamily="34" charset="-122"/>
+                <a:cs typeface="Courier New" pitchFamily="34" charset="-120"/>
+              </a:rPr>
+              <a:t>-</a:t>
+            </a:r>
+            <a:pPr indent="0" marL="0">
+              <a:buNone/>
+            </a:pPr>
+            <a:r>
+              <a:rPr lang="en-US" sz="1100" dirty="0">
+                <a:solidFill>
+                  <a:srgbClr val="4F46E5"/>
+                </a:solidFill>
+                <a:latin typeface="Courier New" pitchFamily="34" charset="0"/>
+                <a:ea typeface="Courier New" pitchFamily="34" charset="-122"/>
+                <a:cs typeface="Courier New" pitchFamily="34" charset="-120"/>
+              </a:rPr>
+              <a:t> </a:t>
+            </a:r>
+            <a:pPr indent="0" marL="0">
+              <a:buNone/>
+            </a:pPr>
+            <a:r>
+              <a:rPr lang="en-US" sz="1100" dirty="0">
+                <a:solidFill>
+                  <a:srgbClr val="059669"/>
+                </a:solidFill>
+                <a:latin typeface="Courier New" pitchFamily="34" charset="0"/>
+                <a:ea typeface="Courier New" pitchFamily="34" charset="-122"/>
+                <a:cs typeface="Courier New" pitchFamily="34" charset="-120"/>
+              </a:rPr>
+              <a:t>"$OUT"</a:t>
+            </a:r>
+            <a:pPr indent="0" marL="0">
+              <a:buNone/>
+            </a:pPr>
+            <a:r>
+              <a:rPr lang="en-US" sz="1100" dirty="0">
+                <a:solidFill>
+                  <a:srgbClr val="4F46E5"/>
+                </a:solidFill>
+                <a:latin typeface="Courier New" pitchFamily="34" charset="0"/>
+                <a:ea typeface="Courier New" pitchFamily="34" charset="-122"/>
+                <a:cs typeface="Courier New" pitchFamily="34" charset="-120"/>
+              </a:rPr>
+              <a:t> </a:t>
+            </a:r>
+            <a:pPr indent="0" marL="0">
+              <a:buNone/>
+            </a:pPr>
+            <a:r>
+              <a:rPr lang="en-US" sz="1100" dirty="0">
+                <a:solidFill>
+                  <a:srgbClr val="4F46E5"/>
+                </a:solidFill>
+                <a:latin typeface="Courier New" pitchFamily="34" charset="0"/>
+                <a:ea typeface="Courier New" pitchFamily="34" charset="-122"/>
+                <a:cs typeface="Courier New" pitchFamily="34" charset="-120"/>
+              </a:rPr>
+              <a:t>-</a:t>
+            </a:r>
+            <a:pPr indent="0" marL="0">
+              <a:buNone/>
+            </a:pPr>
+            <a:r>
+              <a:rPr lang="en-US" sz="1100" dirty="0">
+                <a:solidFill>
+                  <a:srgbClr val="4F46E5"/>
+                </a:solidFill>
+                <a:latin typeface="Courier New" pitchFamily="34" charset="0"/>
+                <a:ea typeface="Courier New" pitchFamily="34" charset="-122"/>
+                <a:cs typeface="Courier New" pitchFamily="34" charset="-120"/>
+              </a:rPr>
+              <a:t>-</a:t>
+            </a:r>
+            <a:pPr indent="0" marL="0">
+              <a:buNone/>
+            </a:pPr>
+            <a:r>
+              <a:rPr lang="en-US" sz="1100" dirty="0">
+                <a:solidFill>
+                  <a:srgbClr val="4F46E5"/>
+                </a:solidFill>
+                <a:latin typeface="Courier New" pitchFamily="34" charset="0"/>
+                <a:ea typeface="Courier New" pitchFamily="34" charset="-122"/>
+                <a:cs typeface="Courier New" pitchFamily="34" charset="-120"/>
+              </a:rPr>
+              <a:t>out</a:t>
+            </a:r>
+            <a:pPr indent="0" marL="0">
+              <a:buNone/>
+            </a:pPr>
+            <a:r>
+              <a:rPr lang="en-US" sz="1100" dirty="0">
+                <a:solidFill>
+                  <a:srgbClr val="4F46E5"/>
+                </a:solidFill>
+                <a:latin typeface="Courier New" pitchFamily="34" charset="0"/>
+                <a:ea typeface="Courier New" pitchFamily="34" charset="-122"/>
+                <a:cs typeface="Courier New" pitchFamily="34" charset="-120"/>
+              </a:rPr>
+              <a:t> </a:t>
+            </a:r>
+            <a:pPr indent="0" marL="0">
+              <a:buNone/>
+            </a:pPr>
+            <a:r>
+              <a:rPr lang="en-US" sz="1100" dirty="0">
+                <a:solidFill>
+                  <a:srgbClr val="059669"/>
+                </a:solidFill>
+                <a:latin typeface="Courier New" pitchFamily="34" charset="0"/>
+                <a:ea typeface="Courier New" pitchFamily="34" charset="-122"/>
+                <a:cs typeface="Courier New" pitchFamily="34" charset="-120"/>
+              </a:rPr>
+              <a:t>"$PDF"</a:t>
+            </a:r>
+            <a:endParaRPr lang="en-US" sz="1100" dirty="0"/>
+          </a:p>
+          <a:p>
+            <a:pPr indent="0" marL="0">
+              <a:buNone/>
+            </a:pPr>
+            <a:r>
+              <a:rPr lang="en-US" sz="1100" dirty="0">
+                <a:solidFill>
+                  <a:srgbClr val="4F46E5"/>
+                </a:solidFill>
+                <a:latin typeface="Courier New" pitchFamily="34" charset="0"/>
+                <a:ea typeface="Courier New" pitchFamily="34" charset="-122"/>
+                <a:cs typeface="Courier New" pitchFamily="34" charset="-120"/>
+              </a:rPr>
+              <a:t>npm</a:t>
+            </a:r>
+            <a:pPr indent="0" marL="0">
+              <a:buNone/>
+            </a:pPr>
+            <a:r>
+              <a:rPr lang="en-US" sz="1100" dirty="0">
+                <a:solidFill>
+                  <a:srgbClr val="4F46E5"/>
+                </a:solidFill>
+                <a:latin typeface="Courier New" pitchFamily="34" charset="0"/>
+                <a:ea typeface="Courier New" pitchFamily="34" charset="-122"/>
+                <a:cs typeface="Courier New" pitchFamily="34" charset="-120"/>
+              </a:rPr>
+              <a:t> </a:t>
+            </a:r>
+            <a:pPr indent="0" marL="0">
+              <a:buNone/>
+            </a:pPr>
+            <a:r>
+              <a:rPr lang="en-US" sz="1100" dirty="0">
+                <a:solidFill>
+                  <a:srgbClr val="4F46E5"/>
+                </a:solidFill>
+                <a:latin typeface="Courier New" pitchFamily="34" charset="0"/>
+                <a:ea typeface="Courier New" pitchFamily="34" charset="-122"/>
+                <a:cs typeface="Courier New" pitchFamily="34" charset="-120"/>
+              </a:rPr>
+              <a:t>run</a:t>
+            </a:r>
+            <a:pPr indent="0" marL="0">
+              <a:buNone/>
+            </a:pPr>
+            <a:r>
+              <a:rPr lang="en-US" sz="1100" dirty="0">
+                <a:solidFill>
+                  <a:srgbClr val="4F46E5"/>
+                </a:solidFill>
+                <a:latin typeface="Courier New" pitchFamily="34" charset="0"/>
+                <a:ea typeface="Courier New" pitchFamily="34" charset="-122"/>
+                <a:cs typeface="Courier New" pitchFamily="34" charset="-120"/>
+              </a:rPr>
+              <a:t> </a:t>
+            </a:r>
+            <a:pPr indent="0" marL="0">
+              <a:buNone/>
+            </a:pPr>
+            <a:r>
+              <a:rPr lang="en-US" sz="1100" dirty="0">
+                <a:solidFill>
+                  <a:srgbClr val="4F46E5"/>
+                </a:solidFill>
+                <a:latin typeface="Courier New" pitchFamily="34" charset="0"/>
+                <a:ea typeface="Courier New" pitchFamily="34" charset="-122"/>
+                <a:cs typeface="Courier New" pitchFamily="34" charset="-120"/>
+              </a:rPr>
+              <a:t>preview</a:t>
+            </a:r>
+            <a:pPr indent="0" marL="0">
+              <a:buNone/>
+            </a:pPr>
+            <a:r>
+              <a:rPr lang="en-US" sz="1100" dirty="0">
+                <a:solidFill>
+                  <a:srgbClr val="4F46E5"/>
+                </a:solidFill>
+                <a:latin typeface="Courier New" pitchFamily="34" charset="0"/>
+                <a:ea typeface="Courier New" pitchFamily="34" charset="-122"/>
+                <a:cs typeface="Courier New" pitchFamily="34" charset="-120"/>
+              </a:rPr>
+              <a:t> </a:t>
+            </a:r>
+            <a:pPr indent="0" marL="0">
+              <a:buNone/>
+            </a:pPr>
+            <a:r>
+              <a:rPr lang="en-US" sz="1100" dirty="0">
+                <a:solidFill>
+                  <a:srgbClr val="4F46E5"/>
+                </a:solidFill>
+                <a:latin typeface="Courier New" pitchFamily="34" charset="0"/>
+                <a:ea typeface="Courier New" pitchFamily="34" charset="-122"/>
+                <a:cs typeface="Courier New" pitchFamily="34" charset="-120"/>
+              </a:rPr>
+              <a:t>-</a:t>
+            </a:r>
+            <a:pPr indent="0" marL="0">
+              <a:buNone/>
+            </a:pPr>
+            <a:r>
+              <a:rPr lang="en-US" sz="1100" dirty="0">
+                <a:solidFill>
+                  <a:srgbClr val="4F46E5"/>
+                </a:solidFill>
+                <a:latin typeface="Courier New" pitchFamily="34" charset="0"/>
+                <a:ea typeface="Courier New" pitchFamily="34" charset="-122"/>
+                <a:cs typeface="Courier New" pitchFamily="34" charset="-120"/>
+              </a:rPr>
+              <a:t>-</a:t>
+            </a:r>
+            <a:pPr indent="0" marL="0">
+              <a:buNone/>
+            </a:pPr>
+            <a:r>
+              <a:rPr lang="en-US" sz="1100" dirty="0">
+                <a:solidFill>
+                  <a:srgbClr val="4F46E5"/>
+                </a:solidFill>
+                <a:latin typeface="Courier New" pitchFamily="34" charset="0"/>
+                <a:ea typeface="Courier New" pitchFamily="34" charset="-122"/>
+                <a:cs typeface="Courier New" pitchFamily="34" charset="-120"/>
+              </a:rPr>
+              <a:t> </a:t>
+            </a:r>
+            <a:pPr indent="0" marL="0">
+              <a:buNone/>
+            </a:pPr>
+            <a:r>
+              <a:rPr lang="en-US" sz="1100" dirty="0">
+                <a:solidFill>
+                  <a:srgbClr val="059669"/>
+                </a:solidFill>
+                <a:latin typeface="Courier New" pitchFamily="34" charset="0"/>
+                <a:ea typeface="Courier New" pitchFamily="34" charset="-122"/>
+                <a:cs typeface="Courier New" pitchFamily="34" charset="-120"/>
+              </a:rPr>
+              <a:t>"$OUT"</a:t>
+            </a:r>
+            <a:pPr indent="0" marL="0">
+              <a:buNone/>
+            </a:pPr>
+            <a:r>
+              <a:rPr lang="en-US" sz="1100" dirty="0">
+                <a:solidFill>
+                  <a:srgbClr val="4F46E5"/>
+                </a:solidFill>
+                <a:latin typeface="Courier New" pitchFamily="34" charset="0"/>
+                <a:ea typeface="Courier New" pitchFamily="34" charset="-122"/>
+                <a:cs typeface="Courier New" pitchFamily="34" charset="-120"/>
+              </a:rPr>
+              <a:t> </a:t>
+            </a:r>
+            <a:pPr indent="0" marL="0">
+              <a:buNone/>
+            </a:pPr>
+            <a:r>
+              <a:rPr lang="en-US" sz="1100" dirty="0">
+                <a:solidFill>
+                  <a:srgbClr val="4F46E5"/>
+                </a:solidFill>
+                <a:latin typeface="Courier New" pitchFamily="34" charset="0"/>
+                <a:ea typeface="Courier New" pitchFamily="34" charset="-122"/>
+                <a:cs typeface="Courier New" pitchFamily="34" charset="-120"/>
+              </a:rPr>
+              <a:t>-</a:t>
+            </a:r>
+            <a:pPr indent="0" marL="0">
+              <a:buNone/>
+            </a:pPr>
+            <a:r>
+              <a:rPr lang="en-US" sz="1100" dirty="0">
+                <a:solidFill>
+                  <a:srgbClr val="4F46E5"/>
+                </a:solidFill>
+                <a:latin typeface="Courier New" pitchFamily="34" charset="0"/>
+                <a:ea typeface="Courier New" pitchFamily="34" charset="-122"/>
+                <a:cs typeface="Courier New" pitchFamily="34" charset="-120"/>
+              </a:rPr>
+              <a:t>-</a:t>
+            </a:r>
+            <a:pPr indent="0" marL="0">
+              <a:buNone/>
+            </a:pPr>
+            <a:r>
+              <a:rPr lang="en-US" sz="1100" dirty="0">
+                <a:solidFill>
+                  <a:srgbClr val="4F46E5"/>
+                </a:solidFill>
+                <a:latin typeface="Courier New" pitchFamily="34" charset="0"/>
+                <a:ea typeface="Courier New" pitchFamily="34" charset="-122"/>
+                <a:cs typeface="Courier New" pitchFamily="34" charset="-120"/>
+              </a:rPr>
+              <a:t>out</a:t>
+            </a:r>
+            <a:pPr indent="0" marL="0">
+              <a:buNone/>
+            </a:pPr>
+            <a:r>
+              <a:rPr lang="en-US" sz="1100" dirty="0">
+                <a:solidFill>
+                  <a:srgbClr val="4F46E5"/>
+                </a:solidFill>
+                <a:latin typeface="Courier New" pitchFamily="34" charset="0"/>
+                <a:ea typeface="Courier New" pitchFamily="34" charset="-122"/>
+                <a:cs typeface="Courier New" pitchFamily="34" charset="-120"/>
+              </a:rPr>
+              <a:t> </a:t>
+            </a:r>
+            <a:pPr indent="0" marL="0">
+              <a:buNone/>
+            </a:pPr>
+            <a:r>
+              <a:rPr lang="en-US" sz="1100" dirty="0">
+                <a:solidFill>
+                  <a:srgbClr val="4F46E5"/>
+                </a:solidFill>
+                <a:latin typeface="Courier New" pitchFamily="34" charset="0"/>
+                <a:ea typeface="Courier New" pitchFamily="34" charset="-122"/>
+                <a:cs typeface="Courier New" pitchFamily="34" charset="-120"/>
+              </a:rPr>
+              <a:t>temp</a:t>
+            </a:r>
+            <a:pPr indent="0" marL="0">
+              <a:buNone/>
+            </a:pPr>
+            <a:r>
+              <a:rPr lang="en-US" sz="1100" dirty="0">
+                <a:solidFill>
+                  <a:srgbClr val="4F46E5"/>
+                </a:solidFill>
+                <a:latin typeface="Courier New" pitchFamily="34" charset="0"/>
+                <a:ea typeface="Courier New" pitchFamily="34" charset="-122"/>
+                <a:cs typeface="Courier New" pitchFamily="34" charset="-120"/>
+              </a:rPr>
+              <a:t>/</a:t>
+            </a:r>
+            <a:pPr indent="0" marL="0">
+              <a:buNone/>
+            </a:pPr>
+            <a:r>
+              <a:rPr lang="en-US" sz="1100" dirty="0">
+                <a:solidFill>
+                  <a:srgbClr val="4F46E5"/>
+                </a:solidFill>
+                <a:latin typeface="Courier New" pitchFamily="34" charset="0"/>
+                <a:ea typeface="Courier New" pitchFamily="34" charset="-122"/>
+                <a:cs typeface="Courier New" pitchFamily="34" charset="-120"/>
+              </a:rPr>
+              <a:t>showcase</a:t>
+            </a:r>
+            <a:pPr indent="0" marL="0">
+              <a:buNone/>
+            </a:pPr>
+            <a:r>
+              <a:rPr lang="en-US" sz="1100" dirty="0">
+                <a:solidFill>
+                  <a:srgbClr val="4F46E5"/>
+                </a:solidFill>
+                <a:latin typeface="Courier New" pitchFamily="34" charset="0"/>
+                <a:ea typeface="Courier New" pitchFamily="34" charset="-122"/>
+                <a:cs typeface="Courier New" pitchFamily="34" charset="-120"/>
+              </a:rPr>
+              <a:t>-</a:t>
+            </a:r>
+            <a:pPr indent="0" marL="0">
+              <a:buNone/>
+            </a:pPr>
+            <a:r>
+              <a:rPr lang="en-US" sz="1100" dirty="0">
+                <a:solidFill>
+                  <a:srgbClr val="4F46E5"/>
+                </a:solidFill>
+                <a:latin typeface="Courier New" pitchFamily="34" charset="0"/>
+                <a:ea typeface="Courier New" pitchFamily="34" charset="-122"/>
+                <a:cs typeface="Courier New" pitchFamily="34" charset="-120"/>
+              </a:rPr>
+              <a:t>teal</a:t>
+            </a:r>
+            <a:pPr indent="0" marL="0">
+              <a:buNone/>
+            </a:pPr>
+            <a:r>
+              <a:rPr lang="en-US" sz="1100" dirty="0">
+                <a:solidFill>
+                  <a:srgbClr val="4F46E5"/>
+                </a:solidFill>
+                <a:latin typeface="Courier New" pitchFamily="34" charset="0"/>
+                <a:ea typeface="Courier New" pitchFamily="34" charset="-122"/>
+                <a:cs typeface="Courier New" pitchFamily="34" charset="-120"/>
+              </a:rPr>
+              <a:t>-</a:t>
+            </a:r>
+            <a:pPr indent="0" marL="0">
+              <a:buNone/>
+            </a:pPr>
+            <a:r>
+              <a:rPr lang="en-US" sz="1100" dirty="0">
+                <a:solidFill>
+                  <a:srgbClr val="4F46E5"/>
+                </a:solidFill>
+                <a:latin typeface="Courier New" pitchFamily="34" charset="0"/>
+                <a:ea typeface="Courier New" pitchFamily="34" charset="-122"/>
+                <a:cs typeface="Courier New" pitchFamily="34" charset="-120"/>
+              </a:rPr>
+              <a:t>preview</a:t>
+            </a:r>
+            <a:pPr indent="0" marL="0">
+              <a:buNone/>
+            </a:pPr>
+            <a:r>
+              <a:rPr lang="en-US" sz="1100" dirty="0">
+                <a:solidFill>
+                  <a:srgbClr val="4F46E5"/>
+                </a:solidFill>
+                <a:latin typeface="Courier New" pitchFamily="34" charset="0"/>
+                <a:ea typeface="Courier New" pitchFamily="34" charset="-122"/>
+                <a:cs typeface="Courier New" pitchFamily="34" charset="-120"/>
+              </a:rPr>
+              <a:t> </a:t>
+            </a:r>
+            <a:pPr indent="0" marL="0">
+              <a:buNone/>
+            </a:pPr>
+            <a:r>
+              <a:rPr lang="en-US" sz="1100" dirty="0">
+                <a:solidFill>
+                  <a:srgbClr val="4F46E5"/>
+                </a:solidFill>
+                <a:latin typeface="Courier New" pitchFamily="34" charset="0"/>
+                <a:ea typeface="Courier New" pitchFamily="34" charset="-122"/>
+                <a:cs typeface="Courier New" pitchFamily="34" charset="-120"/>
+              </a:rPr>
+              <a:t>-</a:t>
+            </a:r>
+            <a:pPr indent="0" marL="0">
+              <a:buNone/>
+            </a:pPr>
+            <a:r>
+              <a:rPr lang="en-US" sz="1100" dirty="0">
+                <a:solidFill>
+                  <a:srgbClr val="4F46E5"/>
+                </a:solidFill>
+                <a:latin typeface="Courier New" pitchFamily="34" charset="0"/>
+                <a:ea typeface="Courier New" pitchFamily="34" charset="-122"/>
+                <a:cs typeface="Courier New" pitchFamily="34" charset="-120"/>
+              </a:rPr>
+              <a:t>-</a:t>
+            </a:r>
+            <a:pPr indent="0" marL="0">
+              <a:buNone/>
+            </a:pPr>
+            <a:r>
+              <a:rPr lang="en-US" sz="1100" dirty="0">
+                <a:solidFill>
+                  <a:srgbClr val="4F46E5"/>
+                </a:solidFill>
+                <a:latin typeface="Courier New" pitchFamily="34" charset="0"/>
+                <a:ea typeface="Courier New" pitchFamily="34" charset="-122"/>
+                <a:cs typeface="Courier New" pitchFamily="34" charset="-120"/>
+              </a:rPr>
+              <a:t>dpi</a:t>
+            </a:r>
+            <a:pPr indent="0" marL="0">
+              <a:buNone/>
+            </a:pPr>
+            <a:r>
+              <a:rPr lang="en-US" sz="1100" dirty="0">
+                <a:solidFill>
+                  <a:srgbClr val="4F46E5"/>
+                </a:solidFill>
+                <a:latin typeface="Courier New" pitchFamily="34" charset="0"/>
+                <a:ea typeface="Courier New" pitchFamily="34" charset="-122"/>
+                <a:cs typeface="Courier New" pitchFamily="34" charset="-120"/>
+              </a:rPr>
+              <a:t> </a:t>
+            </a:r>
+            <a:pPr indent="0" marL="0">
+              <a:buNone/>
+            </a:pPr>
+            <a:r>
+              <a:rPr lang="en-US" sz="1100" dirty="0">
+                <a:solidFill>
+                  <a:srgbClr val="D97706"/>
+                </a:solidFill>
+                <a:latin typeface="Courier New" pitchFamily="34" charset="0"/>
+                <a:ea typeface="Courier New" pitchFamily="34" charset="-122"/>
+                <a:cs typeface="Courier New" pitchFamily="34" charset="-120"/>
+              </a:rPr>
+              <a:t>120</a:t>
+            </a:r>
+            <a:endParaRPr lang="en-US" sz="1100" dirty="0"/>
+          </a:p>
+        </p:txBody>
+      </p:sp>
+      <p:sp>
+        <p:nvSpPr>
+          <p:cNvPr id="9" name="Text 7"/>
+          <p:cNvSpPr/>
+          <p:nvPr/>
+        </p:nvSpPr>
+        <p:spPr>
+          <a:xfrm>
+            <a:off x="841248" y="3758184"/>
+            <a:ext cx="10515600" cy="666496"/>
           </a:xfrm>
           <a:prstGeom prst="rect">
             <a:avLst/>
@@ -9296,15 +11132,36 @@
                 <a:ea typeface="Pretendard" pitchFamily="34" charset="-122"/>
                 <a:cs typeface="Pretendard" pitchFamily="34" charset="-120"/>
               </a:rPr>
-              <a:t>Preview vivid/modern: 같은 명령에서 파일명과 --out 경로만 vivid 또는 modern으로 바꾼다.</a:t>
+              <a:t>vivid/modern 결과물은 같은 명령에서 파일명과 `--out` 경로만 바꿔 재생성한다.</a:t>
             </a:r>
             <a:endParaRPr lang="en-US" sz="1600" dirty="0"/>
           </a:p>
-        </p:txBody>
-      </p:sp>
-      <p:sp>
-        <p:nvSpPr>
-          <p:cNvPr id="9" name="Text 7"/>
+          <a:p>
+            <a:pPr marL="190500" indent="-190500">
+              <a:spcAft>
+                <a:spcPts val="800"/>
+              </a:spcAft>
+              <a:buSzPct val="100000"/>
+              <a:buChar char="•"/>
+            </a:pPr>
+            <a:r>
+              <a:rPr lang="en-US" sz="1600" dirty="0">
+                <a:solidFill>
+                  <a:srgbClr val="6B7280"/>
+                </a:solidFill>
+                <a:latin typeface="Pretendard" pitchFamily="34" charset="0"/>
+                <a:ea typeface="Pretendard" pitchFamily="34" charset="-122"/>
+                <a:cs typeface="Pretendard" pitchFamily="34" charset="-120"/>
+              </a:rPr>
+              <a:t>이 slide는 최근 추가한 fenced code box와 syntax highlighting을 실제 showcase 안에서 보여준다.</a:t>
+            </a:r>
+            <a:endParaRPr lang="en-US" sz="1600" dirty="0"/>
+          </a:p>
+        </p:txBody>
+      </p:sp>
+      <p:sp>
+        <p:nvSpPr>
+          <p:cNvPr id="10" name="Text 8"/>
           <p:cNvSpPr/>
           <p:nvPr/>
         </p:nvSpPr>
@@ -9343,7 +11200,7 @@
       </p:sp>
       <p:sp>
         <p:nvSpPr>
-          <p:cNvPr id="10" name="Text 8"/>
+          <p:cNvPr id="11" name="Text 9"/>
           <p:cNvSpPr/>
           <p:nvPr/>
         </p:nvSpPr>
@@ -9511,7 +11368,7 @@
                 <a:ea typeface="Pretendard" pitchFamily="34" charset="-122"/>
                 <a:cs typeface="Pretendard" pitchFamily="34" charset="-120"/>
               </a:rPr>
-              <a:t>Decks as structured artifacts</a:t>
+              <a:t>From prompt to proof artifact</a:t>
             </a:r>
             <a:endParaRPr lang="en-US" sz="5600" dirty="0"/>
           </a:p>
@@ -9577,7 +11434,7 @@
                 <a:ea typeface="Pretendard" pitchFamily="34" charset="-122"/>
                 <a:cs typeface="Pretendard" pitchFamily="34" charset="-120"/>
               </a:rPr>
-              <a:t>Prompt로 시작해도 결과는 검증 가능한 blueprint와 editable PPTX로 남는다</a:t>
+              <a:t>AI가 만든 초안을 넘어, 재생성 가능하고 편집 가능한 presentation system으로 남긴다</a:t>
             </a:r>
             <a:endParaRPr lang="en-US" sz="1800" dirty="0"/>
           </a:p>
@@ -9869,7 +11726,7 @@
                 <a:ea typeface="Pretendard" pitchFamily="34" charset="-122"/>
                 <a:cs typeface="Pretendard" pitchFamily="34" charset="-120"/>
               </a:rPr>
-              <a:t>왜 bullet deck 생성만으로는 부족한가</a:t>
+              <a:t>AI가 만든 PPT가 왜 다시 손봐야 하는 산출물이 되는가</a:t>
             </a:r>
             <a:endParaRPr lang="en-US" sz="1600" dirty="0"/>
           </a:p>
@@ -9999,7 +11856,7 @@
                 <a:ea typeface="Pretendard" pitchFamily="34" charset="-122"/>
                 <a:cs typeface="Pretendard" pitchFamily="34" charset="-120"/>
               </a:rPr>
-              <a:t>ai-deck-compiler가 blueprint 품질을 다루는 방식</a:t>
+              <a:t>blueprint-first workflow가 내용을 구조화하는 방식</a:t>
             </a:r>
             <a:endParaRPr lang="en-US" sz="1600" dirty="0"/>
           </a:p>
@@ -10129,7 +11986,7 @@
                 <a:ea typeface="Pretendard" pitchFamily="34" charset="-122"/>
                 <a:cs typeface="Pretendard" pitchFamily="34" charset="-120"/>
               </a:rPr>
-              <a:t>지원 slide type과 preset 결과물</a:t>
+              <a:t>짧은 기간에 쌓은 compiler, skill, preset, example evidence</a:t>
             </a:r>
             <a:endParaRPr lang="en-US" sz="1600" dirty="0"/>
           </a:p>
@@ -10259,7 +12116,7 @@
                 <a:ea typeface="Pretendard" pitchFamily="34" charset="-122"/>
                 <a:cs typeface="Pretendard" pitchFamily="34" charset="-120"/>
               </a:rPr>
-              <a:t>create-deck workflow와 검증 루프</a:t>
+              <a:t>같은 deck을 teal, vivid, modern preset으로 재생성하는 결과</a:t>
             </a:r>
             <a:endParaRPr lang="en-US" sz="1600" dirty="0"/>
           </a:p>
@@ -10389,7 +12246,7 @@
                 <a:ea typeface="Pretendard" pitchFamily="34" charset="-122"/>
                 <a:cs typeface="Pretendard" pitchFamily="34" charset="-120"/>
               </a:rPr>
-              <a:t>대표 showcase 결과물이 갖춰야 할 기준</a:t>
+              <a:t>이 showcase 자체가 public proof artifact가 되는 이유</a:t>
             </a:r>
             <a:endParaRPr lang="en-US" sz="1600" dirty="0"/>
           </a:p>
@@ -10668,7 +12525,7 @@
                 <a:ea typeface="Pretendard" pitchFamily="34" charset="-122"/>
                 <a:cs typeface="Pretendard" pitchFamily="34" charset="-120"/>
               </a:rPr>
-              <a:t>From Prompt To Deck</a:t>
+              <a:t>Why It Exists</a:t>
             </a:r>
             <a:endParaRPr lang="en-US" sz="4400" dirty="0"/>
           </a:p>
@@ -10715,7 +12572,7 @@
         <p:spPr>
           <a:xfrm>
             <a:off x="612648" y="182880"/>
-            <a:ext cx="1554480" cy="256032"/>
+            <a:ext cx="1371600" cy="256032"/>
           </a:xfrm>
           <a:prstGeom prst="roundRect">
             <a:avLst>
@@ -10742,7 +12599,7 @@
         <p:spPr>
           <a:xfrm>
             <a:off x="740664" y="182880"/>
-            <a:ext cx="1298448" cy="256032"/>
+            <a:ext cx="1115568" cy="256032"/>
           </a:xfrm>
           <a:prstGeom prst="rect">
             <a:avLst/>
@@ -10766,7 +12623,7 @@
                 <a:ea typeface="Pretendard" pitchFamily="34" charset="-122"/>
                 <a:cs typeface="Pretendard" pitchFamily="34" charset="-120"/>
               </a:rPr>
-              <a:t>01. PRINCIPLE</a:t>
+              <a:t>01. PROBLEM</a:t>
             </a:r>
             <a:endParaRPr lang="en-US" sz="1100" dirty="0"/>
           </a:p>
@@ -10805,7 +12662,7 @@
                 <a:ea typeface="Pretendard" pitchFamily="34" charset="-122"/>
                 <a:cs typeface="Pretendard" pitchFamily="34" charset="-120"/>
               </a:rPr>
-              <a:t>결과물은 편집 가능한 구조다</a:t>
+              <a:t>AI가 만든 deck도 구조가 없으면 다시 수작업이 된다</a:t>
             </a:r>
             <a:endParaRPr lang="en-US" sz="4000" dirty="0"/>
           </a:p>
@@ -10873,7 +12730,7 @@
                 <a:ea typeface="Pretendard" pitchFamily="34" charset="-122"/>
                 <a:cs typeface="Pretendard" pitchFamily="34" charset="-120"/>
               </a:rPr>
-              <a:t>자연어 요청은 narrative spine과 slide plan으로 먼저 정리된다.</a:t>
+              <a:t>일반적인 AI slide 생성은 빠르지만, 내용의 의미 구조와 편집 가능한 객체 경계가 쉽게 사라진다.</a:t>
             </a:r>
             <a:endParaRPr lang="en-US" sz="1600" dirty="0"/>
           </a:p>
@@ -10894,7 +12751,7 @@
                 <a:ea typeface="Pretendard" pitchFamily="34" charset="-122"/>
                 <a:cs typeface="Pretendard" pitchFamily="34" charset="-120"/>
               </a:rPr>
-              <a:t>수치, 구조, 결정, 요약은 각각 KPI, chart, architecture, decision, summary로 승격된다.</a:t>
+              <a:t>차트, 표, 아키텍처, 의사결정, 코드 예시는 모두 다른 표현 방식이 필요한데 bullet slide 하나로 눌리기 쉽다.</a:t>
             </a:r>
             <a:endParaRPr lang="en-US" sz="1600" dirty="0"/>
           </a:p>
@@ -10915,7 +12772,28 @@
                 <a:ea typeface="Pretendard" pitchFamily="34" charset="-122"/>
                 <a:cs typeface="Pretendard" pitchFamily="34" charset="-120"/>
               </a:rPr>
-              <a:t>최종 산출물은 이미지가 아니라 텍스트, 표, 차트, 도형으로 편집 가능한 PowerPoint다.</a:t>
+              <a:t>`ai-deck-compiler`는 AI가 고른 표현 결정을 `blueprint.yaml`에 남기고, renderer가 PowerPoint 객체로 재현한다.</a:t>
+            </a:r>
+            <a:endParaRPr lang="en-US" sz="1600" dirty="0"/>
+          </a:p>
+          <a:p>
+            <a:pPr marL="190500" indent="-190500">
+              <a:spcAft>
+                <a:spcPts val="800"/>
+              </a:spcAft>
+              <a:buSzPct val="100000"/>
+              <a:buChar char="•"/>
+            </a:pPr>
+            <a:r>
+              <a:rPr lang="en-US" sz="1600" dirty="0">
+                <a:solidFill>
+                  <a:srgbClr val="4B4B5A"/>
+                </a:solidFill>
+                <a:latin typeface="Pretendard" pitchFamily="34" charset="0"/>
+                <a:ea typeface="Pretendard" pitchFamily="34" charset="-122"/>
+                <a:cs typeface="Pretendard" pitchFamily="34" charset="-120"/>
+              </a:rPr>
+              <a:t>검증 명령, preview 이미지, tracked result files가 산출물을 반복 가능한 작업 단위로 만든다.</a:t>
             </a:r>
             <a:endParaRPr lang="en-US" sz="1600" dirty="0"/>
           </a:p>
@@ -11130,7 +13008,7 @@
                 <a:ea typeface="Pretendard" pitchFamily="34" charset="-122"/>
                 <a:cs typeface="Pretendard" pitchFamily="34" charset="-120"/>
               </a:rPr>
-              <a:t>Bullet-first와 Blueprint-first</a:t>
+              <a:t>Prompt output이 아니라 구조화된 artifact를 남긴다</a:t>
             </a:r>
             <a:endParaRPr lang="en-US" sz="4000" dirty="0"/>
           </a:p>
@@ -11219,7 +13097,7 @@
                 <a:ea typeface="Pretendard" pitchFamily="34" charset="-122"/>
                 <a:cs typeface="Pretendard" pitchFamily="34" charset="-120"/>
               </a:rPr>
-              <a:t>BULLET-FIRST DECK</a:t>
+              <a:t>AI-ONLY SLIDE DRAFT</a:t>
             </a:r>
             <a:endParaRPr lang="en-US" sz="1800" dirty="0"/>
           </a:p>
@@ -11351,7 +13229,7 @@
                 <a:ea typeface="Pretendard" pitchFamily="34" charset="-122"/>
                 <a:cs typeface="Pretendard" pitchFamily="34" charset="-120"/>
               </a:rPr>
-              <a:t>모든 내용을 비슷한 bullet slide로 압축</a:t>
+              <a:t>결과물이 이미지나 느슨한 bullet 묶음으로 남기 쉽다.</a:t>
             </a:r>
             <a:endParaRPr lang="en-US" sz="1600" dirty="0"/>
           </a:p>
@@ -11372,7 +13250,7 @@
                 <a:ea typeface="Pretendard" pitchFamily="34" charset="-122"/>
                 <a:cs typeface="Pretendard" pitchFamily="34" charset="-120"/>
               </a:rPr>
-              <a:t>chart와 architecture가 수동 후처리로 밀림</a:t>
+              <a:t>같은 요청을 다시 실행하면 layout과 강조 수준이 흔들릴 수 있다.</a:t>
             </a:r>
             <a:endParaRPr lang="en-US" sz="1600" dirty="0"/>
           </a:p>
@@ -11393,7 +13271,7 @@
                 <a:ea typeface="Pretendard" pitchFamily="34" charset="-122"/>
                 <a:cs typeface="Pretendard" pitchFamily="34" charset="-120"/>
               </a:rPr>
-              <a:t>디자인과 구조가 prompt마다 흔들림</a:t>
+              <a:t>리뷰는 “보기 괜찮은가” 중심이라 수정 근거가 약하다.</a:t>
             </a:r>
             <a:endParaRPr lang="en-US" sz="1600" dirty="0"/>
           </a:p>
@@ -11414,7 +13292,7 @@
                 <a:ea typeface="Pretendard" pitchFamily="34" charset="-122"/>
                 <a:cs typeface="Pretendard" pitchFamily="34" charset="-120"/>
               </a:rPr>
-              <a:t>검토 기준이 주관적 시각 확인에 머무름</a:t>
+              <a:t>코드·명령어·재생성 절차가 일반 문장처럼 섞인다.</a:t>
             </a:r>
             <a:endParaRPr lang="en-US" sz="1600" dirty="0"/>
           </a:p>
@@ -11457,7 +13335,7 @@
                 <a:ea typeface="Pretendard" pitchFamily="34" charset="-122"/>
                 <a:cs typeface="Pretendard" pitchFamily="34" charset="-120"/>
               </a:rPr>
-              <a:t>내용의 성격에 맞는 slide type을 먼저 선택</a:t>
+              <a:t>slide type, chart data, diagram node, notes가 YAML에 보존된다.</a:t>
             </a:r>
             <a:endParaRPr lang="en-US" sz="1600" dirty="0"/>
           </a:p>
@@ -11478,7 +13356,7 @@
                 <a:ea typeface="Pretendard" pitchFamily="34" charset="-122"/>
                 <a:cs typeface="Pretendard" pitchFamily="34" charset="-120"/>
               </a:rPr>
-              <a:t>schema가 chart, table, diagram data를 보존</a:t>
+              <a:t>같은 blueprint와 preset이면 같은 rendering 규칙으로 재생성된다.</a:t>
             </a:r>
             <a:endParaRPr lang="en-US" sz="1600" dirty="0"/>
           </a:p>
@@ -11499,7 +13377,7 @@
                 <a:ea typeface="Pretendard" pitchFamily="34" charset="-122"/>
                 <a:cs typeface="Pretendard" pitchFamily="34" charset="-120"/>
               </a:rPr>
-              <a:t>preset token으로 일관된 visual system 적용</a:t>
+              <a:t>validate, deck, preview, review loop가 품질 게이트가 된다.</a:t>
             </a:r>
             <a:endParaRPr lang="en-US" sz="1600" dirty="0"/>
           </a:p>
@@ -11520,7 +13398,7 @@
                 <a:ea typeface="Pretendard" pitchFamily="34" charset="-122"/>
                 <a:cs typeface="Pretendard" pitchFamily="34" charset="-120"/>
               </a:rPr>
-              <a:t>validate, deck, preview 루프로 검증 가능</a:t>
+              <a:t>code block은 boxed monospace component로 분리해 보여준다.</a:t>
             </a:r>
             <a:endParaRPr lang="en-US" sz="1600" dirty="0"/>
           </a:p>
@@ -11645,7 +13523,7 @@
         <p:spPr>
           <a:xfrm>
             <a:off x="612648" y="182880"/>
-            <a:ext cx="1371600" cy="256032"/>
+            <a:ext cx="2286000" cy="256032"/>
           </a:xfrm>
           <a:prstGeom prst="roundRect">
             <a:avLst>
@@ -11672,7 +13550,7 @@
         <p:spPr>
           <a:xfrm>
             <a:off x="740664" y="182880"/>
-            <a:ext cx="1115568" cy="256032"/>
+            <a:ext cx="2029968" cy="256032"/>
           </a:xfrm>
           <a:prstGeom prst="rect">
             <a:avLst/>
@@ -11696,7 +13574,7 @@
                 <a:ea typeface="Pretendard" pitchFamily="34" charset="-122"/>
                 <a:cs typeface="Pretendard" pitchFamily="34" charset="-120"/>
               </a:rPr>
-              <a:t>02. QUALITY</a:t>
+              <a:t>02. SEMANTIC PLANNING</a:t>
             </a:r>
             <a:endParaRPr lang="en-US" sz="1100" dirty="0"/>
           </a:p>
@@ -11735,7 +13613,7 @@
                 <a:ea typeface="Pretendard" pitchFamily="34" charset="-122"/>
                 <a:cs typeface="Pretendard" pitchFamily="34" charset="-120"/>
               </a:rPr>
-              <a:t>의미에 맞는 표현을 고른다</a:t>
+              <a:t>내용을 그대로 옮기지 않고 표현 방식을 선택한다</a:t>
             </a:r>
             <a:endParaRPr lang="en-US" sz="4000" dirty="0"/>
           </a:p>
@@ -11874,7 +13752,7 @@
                 <a:ea typeface="Pretendard" pitchFamily="34" charset="-122"/>
                 <a:cs typeface="Pretendard" pitchFamily="34" charset="-120"/>
               </a:rPr>
-              <a:t>입력만 보는 방식</a:t>
+              <a:t>BULLET TRANSLATION</a:t>
             </a:r>
             <a:endParaRPr lang="en-US" sz="1800" dirty="0"/>
           </a:p>
@@ -12002,7 +13880,7 @@
                 <a:ea typeface="Pretendard" pitchFamily="34" charset="-122"/>
                 <a:cs typeface="Pretendard" pitchFamily="34" charset="-120"/>
               </a:rPr>
-              <a:t>“요약해줘”를 여러 bullet로 변환</a:t>
+              <a:t>수치, 결정, 구조, 절차가 모두 비슷한 bullet로 평평해진다.</a:t>
             </a:r>
             <a:endParaRPr lang="en-US" sz="1600" dirty="0"/>
           </a:p>
@@ -12105,7 +13983,7 @@
                 <a:ea typeface="Pretendard" pitchFamily="34" charset="-122"/>
                 <a:cs typeface="Pretendard" pitchFamily="34" charset="-120"/>
               </a:rPr>
-              <a:t>중요 문장을 모두 같은 레벨로 표시</a:t>
+              <a:t>슬라이드 제목은 주제 라벨이 되고 결론은 본문에 묻힌다.</a:t>
             </a:r>
             <a:endParaRPr lang="en-US" sz="1600" dirty="0"/>
           </a:p>
@@ -12233,7 +14111,7 @@
                 <a:ea typeface="Pretendard" pitchFamily="34" charset="-122"/>
                 <a:cs typeface="Pretendard" pitchFamily="34" charset="-120"/>
               </a:rPr>
-              <a:t>수치와 흐름을 텍스트에 묻어둠</a:t>
+              <a:t>차트나 diagram은 나중에 사람이 다시 설계해야 한다.</a:t>
             </a:r>
             <a:endParaRPr lang="en-US" sz="1600" dirty="0"/>
           </a:p>
@@ -12322,7 +14200,7 @@
                 <a:ea typeface="Pretendard" pitchFamily="34" charset="-122"/>
                 <a:cs typeface="Pretendard" pitchFamily="34" charset="-120"/>
               </a:rPr>
-              <a:t>의미를 보는 방식</a:t>
+              <a:t>SEMANTIC BLUEPRINT</a:t>
             </a:r>
             <a:endParaRPr lang="en-US" sz="1800" dirty="0"/>
           </a:p>
@@ -12450,7 +14328,7 @@
                 <a:ea typeface="Pretendard" pitchFamily="34" charset="-122"/>
                 <a:cs typeface="Pretendard" pitchFamily="34" charset="-120"/>
               </a:rPr>
-              <a:t>수치는 KPI와 chart로 승격</a:t>
+              <a:t>숫자는 KPI/chart, 관계는 architecture, 순서는 flow로 승격한다.</a:t>
             </a:r>
             <a:endParaRPr lang="en-US" sz="1600" dirty="0"/>
           </a:p>
@@ -12553,7 +14431,7 @@
                 <a:ea typeface="Pretendard" pitchFamily="34" charset="-122"/>
                 <a:cs typeface="Pretendard" pitchFamily="34" charset="-120"/>
               </a:rPr>
-              <a:t>결정 문장은 recommendation으로 분리</a:t>
+              <a:t>action title, callout, recommendation, takeaways가 강조 계층을 만든다.</a:t>
             </a:r>
             <a:endParaRPr lang="en-US" sz="1600" dirty="0"/>
           </a:p>
@@ -12681,7 +14559,7 @@
                 <a:ea typeface="Pretendard" pitchFamily="34" charset="-122"/>
                 <a:cs typeface="Pretendard" pitchFamily="34" charset="-120"/>
               </a:rPr>
-              <a:t>시스템 관계는 architecture로 구조화</a:t>
+              <a:t>renderer는 의미 필드를 읽어 editable PPTX 객체로 출력한다.</a:t>
             </a:r>
             <a:endParaRPr lang="en-US" sz="1600" dirty="0"/>
           </a:p>
@@ -12896,7 +14774,7 @@
                 <a:ea typeface="Pretendard" pitchFamily="34" charset="-122"/>
                 <a:cs typeface="Pretendard" pitchFamily="34" charset="-120"/>
               </a:rPr>
-              <a:t>발표 자료의 기본 블록을 지원한다</a:t>
+              <a:t>작은 repo지만 deck 생성에 필요한 핵심 블록을 갖췄다</a:t>
             </a:r>
             <a:endParaRPr lang="en-US" sz="4000" dirty="0"/>
           </a:p>
@@ -13051,7 +14929,7 @@
                 <a:ea typeface="Pretendard" pitchFamily="34" charset="-122"/>
                 <a:cs typeface="Pretendard" pitchFamily="34" charset="-120"/>
               </a:rPr>
-              <a:t>▲ P1 + P2 coverage</a:t>
+              <a:t>▲ core, data, diagram</a:t>
             </a:r>
             <a:endParaRPr lang="en-US" sz="1400" dirty="0"/>
           </a:p>
@@ -13181,7 +15059,7 @@
                 <a:ea typeface="Pretendard" pitchFamily="34" charset="-122"/>
                 <a:cs typeface="Pretendard" pitchFamily="34" charset="-120"/>
               </a:rPr>
-              <a:t>51</a:t>
+              <a:t>58</a:t>
             </a:r>
             <a:endParaRPr lang="en-US" sz="5200" dirty="0"/>
           </a:p>
@@ -13519,7 +15397,7 @@
                 <a:ea typeface="Pretendard" pitchFamily="34" charset="-122"/>
                 <a:cs typeface="Pretendard" pitchFamily="34" charset="-120"/>
               </a:rPr>
-              <a:t>3</a:t>
+              <a:t>10</a:t>
             </a:r>
             <a:endParaRPr lang="en-US" sz="5200" dirty="0"/>
           </a:p>
@@ -13558,7 +15436,7 @@
                 <a:ea typeface="Pretendard" pitchFamily="34" charset="-122"/>
                 <a:cs typeface="Pretendard" pitchFamily="34" charset="-120"/>
               </a:rPr>
-              <a:t>tracked PPTX</a:t>
+              <a:t>blueprint/PPTX/PDF/gallery</a:t>
             </a:r>
             <a:endParaRPr lang="en-US" sz="1400" dirty="0"/>
           </a:p>
@@ -13597,7 +15475,7 @@
                 <a:ea typeface="Pretendard" pitchFamily="34" charset="-122"/>
                 <a:cs typeface="Pretendard" pitchFamily="34" charset="-120"/>
               </a:rPr>
-              <a:t>Result Sets</a:t>
+              <a:t>Result Files</a:t>
             </a:r>
             <a:endParaRPr lang="en-US" sz="1300" dirty="0"/>
           </a:p>
@@ -13722,7 +15600,7 @@
         <p:spPr>
           <a:xfrm>
             <a:off x="612648" y="182880"/>
-            <a:ext cx="1920240" cy="256032"/>
+            <a:ext cx="1463040" cy="256032"/>
           </a:xfrm>
           <a:prstGeom prst="roundRect">
             <a:avLst>
@@ -13749,7 +15627,7 @@
         <p:spPr>
           <a:xfrm>
             <a:off x="740664" y="182880"/>
-            <a:ext cx="1664208" cy="256032"/>
+            <a:ext cx="1207008" cy="256032"/>
           </a:xfrm>
           <a:prstGeom prst="rect">
             <a:avLst/>
@@ -13773,7 +15651,7 @@
                 <a:ea typeface="Pretendard" pitchFamily="34" charset="-122"/>
                 <a:cs typeface="Pretendard" pitchFamily="34" charset="-120"/>
               </a:rPr>
-              <a:t>03. BUILD HISTORY</a:t>
+              <a:t>03. EVIDENCE</a:t>
             </a:r>
             <a:endParaRPr lang="en-US" sz="1100" dirty="0"/>
           </a:p>
@@ -13812,7 +15690,7 @@
                 <a:ea typeface="Pretendard" pitchFamily="34" charset="-122"/>
                 <a:cs typeface="Pretendard" pitchFamily="34" charset="-120"/>
               </a:rPr>
-              <a:t>구현 이력은 빠르게 누적됐다</a:t>
+              <a:t>집중적인 구현이 compiler와 workflow를 동시에 밀어 올렸다</a:t>
             </a:r>
             <a:endParaRPr lang="en-US" sz="4000" dirty="0"/>
           </a:p>
@@ -13978,7 +15856,7 @@
         <p:spPr>
           <a:xfrm>
             <a:off x="612648" y="182880"/>
-            <a:ext cx="1828800" cy="256032"/>
+            <a:ext cx="1463040" cy="256032"/>
           </a:xfrm>
           <a:prstGeom prst="roundRect">
             <a:avLst>
@@ -14005,7 +15883,7 @@
         <p:spPr>
           <a:xfrm>
             <a:off x="740664" y="182880"/>
-            <a:ext cx="1572768" cy="256032"/>
+            <a:ext cx="1207008" cy="256032"/>
           </a:xfrm>
           <a:prstGeom prst="rect">
             <a:avLst/>
@@ -14029,7 +15907,7 @@
                 <a:ea typeface="Pretendard" pitchFamily="34" charset="-122"/>
                 <a:cs typeface="Pretendard" pitchFamily="34" charset="-120"/>
               </a:rPr>
-              <a:t>03. QUALITY LOOP</a:t>
+              <a:t>03. EVIDENCE</a:t>
             </a:r>
             <a:endParaRPr lang="en-US" sz="1100" dirty="0"/>
           </a:p>
@@ -14068,7 +15946,7 @@
                 <a:ea typeface="Pretendard" pitchFamily="34" charset="-122"/>
                 <a:cs typeface="Pretendard" pitchFamily="34" charset="-120"/>
               </a:rPr>
-              <a:t>구조화는 후처리 부담을 줄인다</a:t>
+              <a:t>제품은 코드, skill, 예제, 문서를 함께 갖춘다</a:t>
             </a:r>
             <a:endParaRPr lang="en-US" sz="4000" dirty="0"/>
           </a:p>

</xml_diff>

<commit_message>
feat: improve showcase headline wrapping
</commit_message>
<xml_diff>
--- a/examples/results/showcase-modern-light.pptx
+++ b/examples/results/showcase-modern-light.pptx
@@ -3545,23 +3545,23 @@
         <p:spPr>
           <a:xfrm>
             <a:off x="612648" y="566928"/>
-            <a:ext cx="10972800" cy="749808"/>
-          </a:xfrm>
-          <a:prstGeom prst="rect">
-            <a:avLst/>
-          </a:prstGeom>
-          <a:noFill/>
-          <a:ln/>
-        </p:spPr>
-        <p:txBody>
-          <a:bodyPr wrap="square" rtlCol="0" anchor="ctr"/>
-          <a:lstStyle/>
-          <a:p>
-            <a:pPr indent="0" marL="0">
-              <a:buNone/>
-            </a:pPr>
-            <a:r>
-              <a:rPr lang="en-US" sz="4000" b="1" dirty="0">
+            <a:ext cx="10972800" cy="941832"/>
+          </a:xfrm>
+          <a:prstGeom prst="rect">
+            <a:avLst/>
+          </a:prstGeom>
+          <a:noFill/>
+          <a:ln/>
+        </p:spPr>
+        <p:txBody>
+          <a:bodyPr wrap="square" rtlCol="0" anchor="t"/>
+          <a:lstStyle/>
+          <a:p>
+            <a:pPr indent="0" marL="0">
+              <a:buNone/>
+            </a:pPr>
+            <a:r>
+              <a:rPr lang="en-US" sz="3400" b="1" dirty="0">
                 <a:solidFill>
                   <a:srgbClr val="1A1A1A"/>
                 </a:solidFill>
@@ -3571,7 +3571,7 @@
               </a:rPr>
               <a:t>AI planning과 deterministic rendering을 분리한다</a:t>
             </a:r>
-            <a:endParaRPr lang="en-US" sz="4000" dirty="0"/>
+            <a:endParaRPr lang="en-US" sz="3400" dirty="0"/>
           </a:p>
         </p:txBody>
       </p:sp>
@@ -12984,23 +12984,23 @@
         <p:spPr>
           <a:xfrm>
             <a:off x="612648" y="566928"/>
-            <a:ext cx="10972800" cy="749808"/>
-          </a:xfrm>
-          <a:prstGeom prst="rect">
-            <a:avLst/>
-          </a:prstGeom>
-          <a:noFill/>
-          <a:ln/>
-        </p:spPr>
-        <p:txBody>
-          <a:bodyPr wrap="square" rtlCol="0" anchor="ctr"/>
-          <a:lstStyle/>
-          <a:p>
-            <a:pPr indent="0" marL="0">
-              <a:buNone/>
-            </a:pPr>
-            <a:r>
-              <a:rPr lang="en-US" sz="4000" b="1" dirty="0">
+            <a:ext cx="10972800" cy="941832"/>
+          </a:xfrm>
+          <a:prstGeom prst="rect">
+            <a:avLst/>
+          </a:prstGeom>
+          <a:noFill/>
+          <a:ln/>
+        </p:spPr>
+        <p:txBody>
+          <a:bodyPr wrap="square" rtlCol="0" anchor="t"/>
+          <a:lstStyle/>
+          <a:p>
+            <a:pPr indent="0" marL="0">
+              <a:buNone/>
+            </a:pPr>
+            <a:r>
+              <a:rPr lang="en-US" sz="3400" b="1" dirty="0">
                 <a:solidFill>
                   <a:srgbClr val="1A1A1A"/>
                 </a:solidFill>
@@ -13010,7 +13010,7 @@
               </a:rPr>
               <a:t>Prompt output이 아니라 구조화된 artifact를 남긴다</a:t>
             </a:r>
-            <a:endParaRPr lang="en-US" sz="4000" dirty="0"/>
+            <a:endParaRPr lang="en-US" sz="3400" dirty="0"/>
           </a:p>
         </p:txBody>
       </p:sp>
@@ -14750,23 +14750,23 @@
         <p:spPr>
           <a:xfrm>
             <a:off x="612648" y="566928"/>
-            <a:ext cx="10972800" cy="749808"/>
-          </a:xfrm>
-          <a:prstGeom prst="rect">
-            <a:avLst/>
-          </a:prstGeom>
-          <a:noFill/>
-          <a:ln/>
-        </p:spPr>
-        <p:txBody>
-          <a:bodyPr wrap="square" rtlCol="0" anchor="ctr"/>
-          <a:lstStyle/>
-          <a:p>
-            <a:pPr indent="0" marL="0">
-              <a:buNone/>
-            </a:pPr>
-            <a:r>
-              <a:rPr lang="en-US" sz="4000" b="1" dirty="0">
+            <a:ext cx="10972800" cy="941832"/>
+          </a:xfrm>
+          <a:prstGeom prst="rect">
+            <a:avLst/>
+          </a:prstGeom>
+          <a:noFill/>
+          <a:ln/>
+        </p:spPr>
+        <p:txBody>
+          <a:bodyPr wrap="square" rtlCol="0" anchor="t"/>
+          <a:lstStyle/>
+          <a:p>
+            <a:pPr indent="0" marL="0">
+              <a:buNone/>
+            </a:pPr>
+            <a:r>
+              <a:rPr lang="en-US" sz="3400" b="1" dirty="0">
                 <a:solidFill>
                   <a:srgbClr val="1A1A1A"/>
                 </a:solidFill>
@@ -14776,7 +14776,7 @@
               </a:rPr>
               <a:t>작은 repo지만 deck 생성에 필요한 핵심 블록을 갖췄다</a:t>
             </a:r>
-            <a:endParaRPr lang="en-US" sz="4000" dirty="0"/>
+            <a:endParaRPr lang="en-US" sz="3400" dirty="0"/>
           </a:p>
         </p:txBody>
       </p:sp>
@@ -15059,7 +15059,7 @@
                 <a:ea typeface="Pretendard" pitchFamily="34" charset="-122"/>
                 <a:cs typeface="Pretendard" pitchFamily="34" charset="-120"/>
               </a:rPr>
-              <a:t>58</a:t>
+              <a:t>59</a:t>
             </a:r>
             <a:endParaRPr lang="en-US" sz="5200" dirty="0"/>
           </a:p>
@@ -15666,23 +15666,23 @@
         <p:spPr>
           <a:xfrm>
             <a:off x="612648" y="566928"/>
-            <a:ext cx="10972800" cy="749808"/>
-          </a:xfrm>
-          <a:prstGeom prst="rect">
-            <a:avLst/>
-          </a:prstGeom>
-          <a:noFill/>
-          <a:ln/>
-        </p:spPr>
-        <p:txBody>
-          <a:bodyPr wrap="square" rtlCol="0" anchor="ctr"/>
-          <a:lstStyle/>
-          <a:p>
-            <a:pPr indent="0" marL="0">
-              <a:buNone/>
-            </a:pPr>
-            <a:r>
-              <a:rPr lang="en-US" sz="4000" b="1" dirty="0">
+            <a:ext cx="10972800" cy="941832"/>
+          </a:xfrm>
+          <a:prstGeom prst="rect">
+            <a:avLst/>
+          </a:prstGeom>
+          <a:noFill/>
+          <a:ln/>
+        </p:spPr>
+        <p:txBody>
+          <a:bodyPr wrap="square" rtlCol="0" anchor="t"/>
+          <a:lstStyle/>
+          <a:p>
+            <a:pPr indent="0" marL="0">
+              <a:buNone/>
+            </a:pPr>
+            <a:r>
+              <a:rPr lang="en-US" sz="3400" b="1" dirty="0">
                 <a:solidFill>
                   <a:srgbClr val="1A1A1A"/>
                 </a:solidFill>
@@ -15692,7 +15692,7 @@
               </a:rPr>
               <a:t>집중적인 구현이 compiler와 workflow를 동시에 밀어 올렸다</a:t>
             </a:r>
-            <a:endParaRPr lang="en-US" sz="4000" dirty="0"/>
+            <a:endParaRPr lang="en-US" sz="3400" dirty="0"/>
           </a:p>
         </p:txBody>
       </p:sp>

</xml_diff>